<commit_message>
DR-002: apply supplementary order (5 business decisions)
- 30t target is finished Wuxing premix, not specialty powder
- COFCO Haijia flour/industry resources + Dr Chen formula, co-develop
- B2B customers are raw-material distributors and mantou plants;
  3,719 outlets are potential terminal channels only
- Specialty powder producer marked as pending
- Three revenue models shown in parallel, no preference

Co-Authored-By: Claude Opus 5.5 <noreply@anthropic.com>
Claude-Session: https://claude.ai/code/session_0137DxXVQUvWUjpTeTg3QLMn
</commit_message>
<xml_diff>
--- a/DR-002/DR-002_中粮海嘉五行预拌粉合作计划_V1.0.pptx
+++ b/DR-002/DR-002_中粮海嘉五行预拌粉合作计划_V1.0.pptx
@@ -120,38 +120,38 @@
   <p:extLst>
     <p:ext uri="{521415D9-36F7-43E2-AB2F-B90AF26B5E84}">
       <p14:sectionLst xmlns:p14="http://schemas.microsoft.com/office/powerpoint/2010/main">
-        <p14:section name="开篇" id="{63e7a413-cea1-3f5e-5d89-68ce07ce6595}">
+        <p14:section name="开篇" id="{5b4cd455-d369-d55e-d5f2-9a995f6eec83}">
           <p14:sldIdLst>
             <p14:sldId id="256"/>
           </p14:sldIdLst>
         </p14:section>
-        <p14:section name="合作基础" id="{9e6c1f06-3bba-14cb-3798-811efe94306d}">
+        <p14:section name="合作基础" id="{0504d82c-24af-7893-bc03-3f5489cf6e2b}">
           <p14:sldIdLst>
             <p14:sldId id="257"/>
             <p14:sldId id="258"/>
           </p14:sldIdLst>
         </p14:section>
-        <p14:section name="产品与模式" id="{425031c3-cf5e-2750-39c5-88caaa52864c}">
+        <p14:section name="产品与模式" id="{7a9a400c-cd81-e19f-d84a-f60aa508c37e}">
           <p14:sldIdLst>
             <p14:sldId id="259"/>
             <p14:sldId id="260"/>
             <p14:sldId id="261"/>
           </p14:sldIdLst>
         </p14:section>
-        <p14:section name="市场落地" id="{4a018671-90fd-8db6-607b-1fa3af0664e7}">
+        <p14:section name="市场落地" id="{88f2d14c-300c-dd7e-7f18-2f8bf3bab5b5}">
           <p14:sldIdLst>
             <p14:sldId id="262"/>
             <p14:sldId id="263"/>
           </p14:sldIdLst>
         </p14:section>
-        <p14:section name="收益与财务" id="{c7ee5491-6831-c3d9-1587-697af3963071}">
+        <p14:section name="收益与财务" id="{6dc89c45-60e4-9c46-2c91-0881fa20f2c8}">
           <p14:sldIdLst>
             <p14:sldId id="264"/>
             <p14:sldId id="265"/>
             <p14:sldId id="266"/>
           </p14:sldIdLst>
         </p14:section>
-        <p14:section name="行动计划" id="{44fe0c5a-3690-ed4a-0d0c-4ad268b9428c}">
+        <p14:section name="行动计划" id="{2098f197-57e5-bdb4-bf60-ceb32ea77a25}">
           <p14:sldIdLst>
             <p14:sldId id="267"/>
             <p14:sldId id="268"/>
@@ -929,7 +929,7 @@
           <a:p>
             <a:r>
               <a:rPr lang="en-US" dirty="0"/>
-              <a:t>第一年30吨：Q1 5吨、Q2 5吨、Q3 10吨、Q4暂定10吨，合计1,200包（25公斤/包，每吨40包）。均为目标，非已确认订单。</a:t>
+              <a:t>第一年30吨五行预拌粉成品（不是五行特色粉体）：Q1 5吨、Q2 5吨、Q3 10吨、Q4暂定10吨，合计1,200包（25公斤/包，每吨40包）。均为目标，非已确认订单。</a:t>
             </a:r>
             <a:endParaRPr lang="en-US" dirty="0"/>
           </a:p>
@@ -1457,7 +1457,7 @@
           <a:p>
             <a:r>
               <a:rPr lang="en-US" dirty="0"/>
-              <a:t>双方资源互补：中粮海嘉提供面粉与供应链，陈博士团队提供五行特色粉体配方与产品技术。必须强调：合作关系尚待议定，未正式签约。</a:t>
+              <a:t>双方资源互补：中粮海嘉提供面粉及相关产业资源，陈博士提供五行特色粉体配方，双方合作开发五行预拌粉。五行特色粉体由谁生产尚待议定。必须强调：合作关系尚待议定，未正式签约。</a:t>
             </a:r>
             <a:endParaRPr lang="en-US" dirty="0"/>
           </a:p>
@@ -1721,7 +1721,7 @@
           <a:p>
             <a:r>
               <a:rPr lang="en-US" dirty="0"/>
-              <a:t>产业链：预拌粉供应→经销商→馒头生产企业→终端渠道→消费者。预拌粉的收入来自馒头生产企业的持续复购，终端动销是关键。</a:t>
+              <a:t>产业链：预拌粉供应→原料经销商→馒头生产厂→终端渠道→消费者。B2B直接销售对象为原料经销商及馒头生产厂；福建3,719个据点属于潜在终端渠道资源，尚未去重及确认进场，不是直接客户。</a:t>
             </a:r>
             <a:endParaRPr lang="en-US" dirty="0"/>
           </a:p>
@@ -1809,7 +1809,7 @@
           <a:p>
             <a:r>
               <a:rPr lang="en-US" dirty="0"/>
-              <a:t>福建3,719个潜在渠道据点。必须强调三点：数据由合作伙伴提供；尚未去重；尚未确认进场。分类明细待补，本页表格可直接填入。</a:t>
+              <a:t>福建3,719个潜在终端渠道据点，不是B2B直接客户（直接客户为原料经销商及馒头生产厂）。必须强调三点：数据由合作伙伴提供；尚未去重；尚未确认进场。分类明细待补，本页表格可直接填入。</a:t>
             </a:r>
             <a:endParaRPr lang="en-US" dirty="0"/>
           </a:p>
@@ -1985,7 +1985,7 @@
           <a:p>
             <a:r>
               <a:rPr lang="en-US" dirty="0"/>
-              <a:t>三种合作收益模式比较：A供货、B授权、C共同经营。投入与复杂度依次递增。不预设任何一案已获同意，请集团比较后选择。</a:t>
+              <a:t>三种合作收益模式并列：A供货、B授权、C共同经营。不预设任何一案已获双方同意，也不作推荐。五行特色粉体生产方尚待议定。</a:t>
             </a:r>
             <a:endParaRPr lang="en-US" dirty="0"/>
           </a:p>
@@ -3201,7 +3201,7 @@
                   <a:schemeClr val="tx1"/>
                 </a:solidFill>
               </a:rPr>
-              <a:t>第一年目标：30吨预拌粉成品，合1,200包</a:t>
+              <a:t>第一年目标：30吨五行预拌粉成品，合1,200包</a:t>
             </a:r>
             <a:endParaRPr lang="en-US" sz="3000" dirty="0"/>
           </a:p>
@@ -3318,7 +3318,7 @@
                   <a:schemeClr val="accent4"/>
                 </a:solidFill>
               </a:rPr>
-              <a:t>全年预拌粉成品</a:t>
+              <a:t>全年五行预拌粉成品（非特色粉体）</a:t>
             </a:r>
             <a:endParaRPr lang="en-US" sz="1300" dirty="0"/>
           </a:p>
@@ -4717,7 +4717,7 @@
                   <a:schemeClr val="tx2"/>
                 </a:solidFill>
               </a:rPr>
-              <a:t>注：Q4 10吨为暂定目标；销售计划为提案方目标，非已确认订单。换算：1吨 = 40包（25公斤 / 包）。</a:t>
+              <a:t>注：30吨指五行预拌粉成品，不是五行特色粉体；Q4 10吨为暂定；为提案方目标，非已确认订单。1吨 = 40包（25公斤 / 包）。</a:t>
             </a:r>
             <a:endParaRPr lang="en-US" sz="1000" dirty="0"/>
           </a:p>
@@ -5020,7 +5020,7 @@
                   <a:schemeClr val="accent5"/>
                 </a:solidFill>
               </a:rPr>
-              <a:t>30吨 ×［待报价］</a:t>
+              <a:t>30吨五行预拌粉成品 ×［待报价］</a:t>
             </a:r>
             <a:endParaRPr lang="en-US" sz="1200" dirty="0"/>
           </a:p>
@@ -9064,9 +9064,56 @@
           </a:p>
         </p:txBody>
       </p:sp>
+      <p:sp>
+        <p:nvSpPr>
+          <p:cNvPr id="29" name="Text 27"/>
+          <p:cNvSpPr txBox="1"/>
+          <p:nvPr/>
+        </p:nvSpPr>
+        <p:spPr>
+          <a:xfrm>
+            <a:off x="548640" y="4206240"/>
+            <a:ext cx="11064240" cy="365760"/>
+          </a:xfrm>
+          <a:prstGeom prst="rect">
+            <a:avLst/>
+          </a:prstGeom>
+          <a:noFill/>
+          <a:ln/>
+        </p:spPr>
+        <p:txBody>
+          <a:bodyPr wrap="square" lIns="0" tIns="0" rIns="0" bIns="0" rtlCol="0" anchor="t"/>
+          <a:lstStyle/>
+          <a:p>
+            <a:pPr indent="0" marL="0">
+              <a:buNone/>
+            </a:pPr>
+            <a:r>
+              <a:rPr lang="en-US" sz="1400" b="1" dirty="0">
+                <a:solidFill>
+                  <a:schemeClr val="accent2"/>
+                </a:solidFill>
+              </a:rPr>
+              <a:t>待议定事项：</a:t>
+            </a:r>
+            <a:pPr indent="0" marL="0">
+              <a:buNone/>
+            </a:pPr>
+            <a:r>
+              <a:rPr lang="en-US" sz="1400" dirty="0">
+                <a:solidFill>
+                  <a:schemeClr val="bg1"/>
+                </a:solidFill>
+              </a:rPr>
+              <a:t>合作关系与协议形式　·　五行特色粉体生产方　·　收益模式及具体条款</a:t>
+            </a:r>
+            <a:endParaRPr lang="en-US" sz="1400" dirty="0"/>
+          </a:p>
+        </p:txBody>
+      </p:sp>
       <p:pic>
         <p:nvPicPr>
-          <p:cNvPr id="29" name="Image 0" descr="preencoded.png">    </p:cNvPr>
+          <p:cNvPr id="30" name="Image 0" descr="preencoded.png">    </p:cNvPr>
           <p:cNvPicPr>
             <a:picLocks noChangeAspect="1"/>
           </p:cNvPicPr>
@@ -9080,7 +9127,7 @@
         </p:blipFill>
         <p:spPr>
           <a:xfrm>
-            <a:off x="548640" y="4526280"/>
+            <a:off x="548640" y="4892040"/>
             <a:ext cx="640080" cy="640080"/>
           </a:xfrm>
           <a:prstGeom prst="rect">
@@ -9090,14 +9137,14 @@
       </p:pic>
       <p:sp>
         <p:nvSpPr>
-          <p:cNvPr id="30" name="Text 27"/>
+          <p:cNvPr id="31" name="Text 28"/>
           <p:cNvSpPr txBox="1"/>
           <p:nvPr/>
         </p:nvSpPr>
         <p:spPr>
           <a:xfrm>
-            <a:off x="1417320" y="4389120"/>
-            <a:ext cx="10058400" cy="1188720"/>
+            <a:off x="1417320" y="4709160"/>
+            <a:ext cx="10058400" cy="1051560"/>
           </a:xfrm>
           <a:prstGeom prst="rect">
             <a:avLst/>
@@ -9140,7 +9187,7 @@
       </p:sp>
       <p:sp>
         <p:nvSpPr>
-          <p:cNvPr id="31" name="Text 28"/>
+          <p:cNvPr id="32" name="Text 29"/>
           <p:cNvSpPr txBox="1"/>
           <p:nvPr/>
         </p:nvSpPr>
@@ -10009,7 +10056,7 @@
                   <a:schemeClr val="tx1"/>
                 </a:solidFill>
               </a:rPr>
-              <a:t>统一25公斤规格，便于代工厂标准化复购</a:t>
+              <a:t>统一25公斤规格，便于馒头生产厂标准化复购</a:t>
             </a:r>
             <a:endParaRPr lang="en-US" sz="1300" dirty="0"/>
           </a:p>
@@ -10191,7 +10238,7 @@
                   <a:schemeClr val="tx1"/>
                 </a:solidFill>
               </a:rPr>
-              <a:t>优质面粉 × 特色配方：一端稳供应，一端造差异</a:t>
+              <a:t>中粮海嘉面粉 × 陈博士配方，合作开发五行预拌粉</a:t>
             </a:r>
             <a:endParaRPr lang="en-US" sz="3000" dirty="0"/>
           </a:p>
@@ -10336,7 +10383,7 @@
                   <a:schemeClr val="accent1"/>
                 </a:solidFill>
               </a:rPr>
-              <a:t>面粉与供应链资源</a:t>
+              <a:t>面粉及相关产业资源</a:t>
             </a:r>
             <a:endParaRPr lang="en-US" sz="1300" dirty="0"/>
           </a:p>
@@ -10560,7 +10607,7 @@
                   <a:schemeClr val="tx1"/>
                 </a:solidFill>
               </a:rPr>
-              <a:t>渠道与客户基础（范围待确认）</a:t>
+              <a:t>相关产业资源（范围待确认）</a:t>
             </a:r>
             <a:endParaRPr lang="en-US" sz="1500" dirty="0"/>
           </a:p>
@@ -10669,7 +10716,7 @@
                   <a:schemeClr val="tx1"/>
                 </a:solidFill>
               </a:rPr>
-              <a:t>陈博士团队</a:t>
+              <a:t>陈博士</a:t>
             </a:r>
             <a:endParaRPr lang="en-US" sz="2200" dirty="0"/>
           </a:p>
@@ -10705,7 +10752,7 @@
                   <a:schemeClr val="accent1"/>
                 </a:solidFill>
               </a:rPr>
-              <a:t>五行特色粉体配方与产品技术</a:t>
+              <a:t>五行特色粉体配方</a:t>
             </a:r>
             <a:endParaRPr lang="en-US" sz="1300" dirty="0"/>
           </a:p>
@@ -10817,7 +10864,7 @@
                   <a:schemeClr val="tx1"/>
                 </a:solidFill>
               </a:rPr>
-              <a:t>馒头专用预拌粉产品技术</a:t>
+              <a:t>预拌粉配方与工艺指导</a:t>
             </a:r>
             <a:endParaRPr lang="en-US" sz="1500" dirty="0"/>
           </a:p>
@@ -10873,7 +10920,7 @@
                   <a:schemeClr val="tx1"/>
                 </a:solidFill>
               </a:rPr>
-              <a:t>产品研发与工艺指导</a:t>
+              <a:t>五款产品研发与定型</a:t>
             </a:r>
             <a:endParaRPr lang="en-US" sz="1500" dirty="0"/>
           </a:p>
@@ -10929,7 +10976,7 @@
                   <a:schemeClr val="tx1"/>
                 </a:solidFill>
               </a:rPr>
-              <a:t>特色产品定位与市场推广</a:t>
+              <a:t>特色产品定位</a:t>
             </a:r>
             <a:endParaRPr lang="en-US" sz="1500" dirty="0"/>
           </a:p>
@@ -10987,8 +11034,8 @@
         </p:nvSpPr>
         <p:spPr>
           <a:xfrm>
-            <a:off x="5303520" y="3886200"/>
-            <a:ext cx="1581912" cy="365760"/>
+            <a:off x="5239512" y="3794760"/>
+            <a:ext cx="1709928" cy="548640"/>
           </a:xfrm>
           <a:prstGeom prst="rect">
             <a:avLst/>
@@ -11004,14 +11051,28 @@
               <a:buNone/>
             </a:pPr>
             <a:r>
-              <a:rPr lang="en-US" sz="1600" b="1" dirty="0">
+              <a:rPr lang="en-US" sz="1300" b="1" dirty="0">
                 <a:solidFill>
                   <a:schemeClr val="accent3"/>
                 </a:solidFill>
               </a:rPr>
-              <a:t>互补</a:t>
-            </a:r>
-            <a:endParaRPr lang="en-US" sz="1600" dirty="0"/>
+              <a:t>合作开发</a:t>
+            </a:r>
+            <a:endParaRPr lang="en-US" sz="1300" dirty="0"/>
+          </a:p>
+          <a:p>
+            <a:pPr algn="ctr" indent="0" marL="0">
+              <a:buNone/>
+            </a:pPr>
+            <a:r>
+              <a:rPr lang="en-US" sz="1300" b="1" dirty="0">
+                <a:solidFill>
+                  <a:schemeClr val="accent3"/>
+                </a:solidFill>
+              </a:rPr>
+              <a:t>五行预拌粉</a:t>
+            </a:r>
+            <a:endParaRPr lang="en-US" sz="1300" dirty="0"/>
           </a:p>
         </p:txBody>
       </p:sp>
@@ -11117,7 +11178,7 @@
                   <a:schemeClr val="tx2"/>
                 </a:solidFill>
               </a:rPr>
-              <a:t>注：双方尚未签署任何合作协议；中粮海嘉相关资源的具体范围以集团正式确认为准。</a:t>
+              <a:t>注：双方尚未签署任何合作协议；中粮海嘉相关资源的具体范围以集团正式确认为准；五行特色粉体由谁生产尚待议定。</a:t>
             </a:r>
             <a:endParaRPr lang="en-US" sz="1000" dirty="0"/>
           </a:p>
@@ -12674,7 +12735,7 @@
                   <a:schemeClr val="tx2"/>
                 </a:solidFill>
               </a:rPr>
-              <a:t>注：馒头图形为色泽示意，非实际产品照片；具体配方组成以陈博士团队最终确认为准；按普通食品管理，不作任何保健或功效宣称。</a:t>
+              <a:t>注：馒头图形为色泽示意，非实际产品照片；具体配方组成以陈博士最终确认为准；按普通食品管理，不作任何保健或功效宣称。</a:t>
             </a:r>
             <a:endParaRPr lang="en-US" sz="1000" dirty="0"/>
           </a:p>
@@ -12863,8 +12924,8 @@
         </p:nvSpPr>
         <p:spPr>
           <a:xfrm>
-            <a:off x="548640" y="1828800"/>
-            <a:ext cx="2560320" cy="868680"/>
+            <a:off x="548640" y="1901952"/>
+            <a:ext cx="2560320" cy="457200"/>
           </a:xfrm>
           <a:prstGeom prst="rect">
             <a:avLst/>
@@ -12893,7 +12954,65 @@
       </p:sp>
       <p:sp>
         <p:nvSpPr>
-          <p:cNvPr id="6" name="Text 4"/>
+          <p:cNvPr id="6" name="Shape 4"/>
+          <p:cNvSpPr/>
+          <p:nvPr/>
+        </p:nvSpPr>
+        <p:spPr>
+          <a:xfrm>
+            <a:off x="1188720" y="2304288"/>
+            <a:ext cx="1280160" cy="329184"/>
+          </a:xfrm>
+          <a:prstGeom prst="roundRect">
+            <a:avLst>
+              <a:gd name="adj" fmla="val 50000"/>
+            </a:avLst>
+          </a:prstGeom>
+          <a:solidFill>
+            <a:schemeClr val="bg1"/>
+          </a:solidFill>
+          <a:ln/>
+        </p:spPr>
+      </p:sp>
+      <p:sp>
+        <p:nvSpPr>
+          <p:cNvPr id="7" name="Text 5"/>
+          <p:cNvSpPr txBox="1"/>
+          <p:nvPr/>
+        </p:nvSpPr>
+        <p:spPr>
+          <a:xfrm>
+            <a:off x="1188720" y="2304288"/>
+            <a:ext cx="1280160" cy="329184"/>
+          </a:xfrm>
+          <a:prstGeom prst="rect">
+            <a:avLst/>
+          </a:prstGeom>
+          <a:noFill/>
+          <a:ln/>
+        </p:spPr>
+        <p:txBody>
+          <a:bodyPr wrap="square" lIns="0" tIns="0" rIns="0" bIns="0" rtlCol="0" anchor="ctr"/>
+          <a:lstStyle/>
+          <a:p>
+            <a:pPr algn="ctr" indent="0" marL="0">
+              <a:buNone/>
+            </a:pPr>
+            <a:r>
+              <a:rPr lang="en-US" sz="1100" b="1" dirty="0">
+                <a:solidFill>
+                  <a:schemeClr val="accent5"/>
+                </a:solidFill>
+              </a:rPr>
+              <a:t>生产方待议定</a:t>
+            </a:r>
+            <a:endParaRPr lang="en-US" sz="1100" dirty="0"/>
+          </a:p>
+        </p:txBody>
+      </p:sp>
+      <p:sp>
+        <p:nvSpPr>
+          <p:cNvPr id="8" name="Text 6"/>
           <p:cNvSpPr txBox="1"/>
           <p:nvPr/>
         </p:nvSpPr>
@@ -12929,7 +13048,7 @@
       </p:sp>
       <p:sp>
         <p:nvSpPr>
-          <p:cNvPr id="7" name="Shape 5"/>
+          <p:cNvPr id="9" name="Shape 7"/>
           <p:cNvSpPr/>
           <p:nvPr/>
         </p:nvSpPr>
@@ -12958,7 +13077,7 @@
       </p:sp>
       <p:sp>
         <p:nvSpPr>
-          <p:cNvPr id="8" name="Text 6"/>
+          <p:cNvPr id="10" name="Text 8"/>
           <p:cNvSpPr txBox="1"/>
           <p:nvPr/>
         </p:nvSpPr>
@@ -12994,7 +13113,7 @@
       </p:sp>
       <p:sp>
         <p:nvSpPr>
-          <p:cNvPr id="9" name="Text 7"/>
+          <p:cNvPr id="11" name="Text 9"/>
           <p:cNvSpPr txBox="1"/>
           <p:nvPr/>
         </p:nvSpPr>
@@ -13030,7 +13149,7 @@
       </p:sp>
       <p:sp>
         <p:nvSpPr>
-          <p:cNvPr id="10" name="Shape 8"/>
+          <p:cNvPr id="12" name="Shape 10"/>
           <p:cNvSpPr/>
           <p:nvPr/>
         </p:nvSpPr>
@@ -13059,7 +13178,7 @@
       </p:sp>
       <p:sp>
         <p:nvSpPr>
-          <p:cNvPr id="11" name="Text 9"/>
+          <p:cNvPr id="13" name="Text 11"/>
           <p:cNvSpPr txBox="1"/>
           <p:nvPr/>
         </p:nvSpPr>
@@ -13095,7 +13214,7 @@
       </p:sp>
       <p:sp>
         <p:nvSpPr>
-          <p:cNvPr id="12" name="Shape 10"/>
+          <p:cNvPr id="14" name="Shape 12"/>
           <p:cNvSpPr/>
           <p:nvPr/>
         </p:nvSpPr>
@@ -13118,7 +13237,7 @@
       </p:sp>
       <p:sp>
         <p:nvSpPr>
-          <p:cNvPr id="13" name="Shape 11"/>
+          <p:cNvPr id="15" name="Shape 13"/>
           <p:cNvSpPr/>
           <p:nvPr/>
         </p:nvSpPr>
@@ -13147,7 +13266,7 @@
       </p:sp>
       <p:sp>
         <p:nvSpPr>
-          <p:cNvPr id="14" name="Shape 12"/>
+          <p:cNvPr id="16" name="Shape 14"/>
           <p:cNvSpPr/>
           <p:nvPr/>
         </p:nvSpPr>
@@ -13167,7 +13286,7 @@
       </p:sp>
       <p:pic>
         <p:nvPicPr>
-          <p:cNvPr id="15" name="Image 0" descr="preencoded.png">    </p:cNvPr>
+          <p:cNvPr id="17" name="Image 0" descr="preencoded.png">    </p:cNvPr>
           <p:cNvPicPr>
             <a:picLocks noChangeAspect="1"/>
           </p:cNvPicPr>
@@ -13191,7 +13310,7 @@
       </p:pic>
       <p:sp>
         <p:nvSpPr>
-          <p:cNvPr id="16" name="Shape 13"/>
+          <p:cNvPr id="18" name="Shape 15"/>
           <p:cNvSpPr/>
           <p:nvPr/>
         </p:nvSpPr>
@@ -13211,7 +13330,7 @@
       </p:sp>
       <p:sp>
         <p:nvSpPr>
-          <p:cNvPr id="17" name="Text 14"/>
+          <p:cNvPr id="19" name="Text 16"/>
           <p:cNvSpPr txBox="1"/>
           <p:nvPr/>
         </p:nvSpPr>
@@ -13247,7 +13366,7 @@
       </p:sp>
       <p:sp>
         <p:nvSpPr>
-          <p:cNvPr id="18" name="Text 15"/>
+          <p:cNvPr id="20" name="Text 17"/>
           <p:cNvSpPr txBox="1"/>
           <p:nvPr/>
         </p:nvSpPr>
@@ -13283,7 +13402,7 @@
       </p:sp>
       <p:sp>
         <p:nvSpPr>
-          <p:cNvPr id="19" name="Text 16"/>
+          <p:cNvPr id="21" name="Text 18"/>
           <p:cNvSpPr txBox="1"/>
           <p:nvPr/>
         </p:nvSpPr>
@@ -13333,7 +13452,7 @@
       </p:sp>
       <p:sp>
         <p:nvSpPr>
-          <p:cNvPr id="20" name="Shape 17"/>
+          <p:cNvPr id="22" name="Shape 19"/>
           <p:cNvSpPr/>
           <p:nvPr/>
         </p:nvSpPr>
@@ -13353,7 +13472,7 @@
       </p:sp>
       <p:sp>
         <p:nvSpPr>
-          <p:cNvPr id="21" name="Shape 18"/>
+          <p:cNvPr id="23" name="Shape 20"/>
           <p:cNvSpPr/>
           <p:nvPr/>
         </p:nvSpPr>
@@ -13382,7 +13501,7 @@
       </p:sp>
       <p:sp>
         <p:nvSpPr>
-          <p:cNvPr id="22" name="Shape 19"/>
+          <p:cNvPr id="24" name="Shape 21"/>
           <p:cNvSpPr/>
           <p:nvPr/>
         </p:nvSpPr>
@@ -13402,7 +13521,7 @@
       </p:sp>
       <p:pic>
         <p:nvPicPr>
-          <p:cNvPr id="23" name="Image 1" descr="preencoded.png">    </p:cNvPr>
+          <p:cNvPr id="25" name="Image 1" descr="preencoded.png">    </p:cNvPr>
           <p:cNvPicPr>
             <a:picLocks noChangeAspect="1"/>
           </p:cNvPicPr>
@@ -13426,7 +13545,7 @@
       </p:pic>
       <p:sp>
         <p:nvSpPr>
-          <p:cNvPr id="24" name="Shape 20"/>
+          <p:cNvPr id="26" name="Shape 22"/>
           <p:cNvSpPr/>
           <p:nvPr/>
         </p:nvSpPr>
@@ -13446,7 +13565,7 @@
       </p:sp>
       <p:sp>
         <p:nvSpPr>
-          <p:cNvPr id="25" name="Text 21"/>
+          <p:cNvPr id="27" name="Text 23"/>
           <p:cNvSpPr txBox="1"/>
           <p:nvPr/>
         </p:nvSpPr>
@@ -13482,7 +13601,7 @@
       </p:sp>
       <p:sp>
         <p:nvSpPr>
-          <p:cNvPr id="26" name="Text 22"/>
+          <p:cNvPr id="28" name="Text 24"/>
           <p:cNvSpPr txBox="1"/>
           <p:nvPr/>
         </p:nvSpPr>
@@ -13518,7 +13637,7 @@
       </p:sp>
       <p:sp>
         <p:nvSpPr>
-          <p:cNvPr id="27" name="Text 23"/>
+          <p:cNvPr id="29" name="Text 25"/>
           <p:cNvSpPr txBox="1"/>
           <p:nvPr/>
         </p:nvSpPr>
@@ -13568,7 +13687,7 @@
       </p:sp>
       <p:sp>
         <p:nvSpPr>
-          <p:cNvPr id="28" name="Shape 24"/>
+          <p:cNvPr id="30" name="Shape 26"/>
           <p:cNvSpPr/>
           <p:nvPr/>
         </p:nvSpPr>
@@ -13588,7 +13707,7 @@
       </p:sp>
       <p:sp>
         <p:nvSpPr>
-          <p:cNvPr id="29" name="Shape 25"/>
+          <p:cNvPr id="31" name="Shape 27"/>
           <p:cNvSpPr/>
           <p:nvPr/>
         </p:nvSpPr>
@@ -13617,7 +13736,7 @@
       </p:sp>
       <p:sp>
         <p:nvSpPr>
-          <p:cNvPr id="30" name="Shape 26"/>
+          <p:cNvPr id="32" name="Shape 28"/>
           <p:cNvSpPr/>
           <p:nvPr/>
         </p:nvSpPr>
@@ -13637,7 +13756,7 @@
       </p:sp>
       <p:pic>
         <p:nvPicPr>
-          <p:cNvPr id="31" name="Image 2" descr="preencoded.png">    </p:cNvPr>
+          <p:cNvPr id="33" name="Image 2" descr="preencoded.png">    </p:cNvPr>
           <p:cNvPicPr>
             <a:picLocks noChangeAspect="1"/>
           </p:cNvPicPr>
@@ -13661,7 +13780,7 @@
       </p:pic>
       <p:sp>
         <p:nvSpPr>
-          <p:cNvPr id="32" name="Shape 27"/>
+          <p:cNvPr id="34" name="Shape 29"/>
           <p:cNvSpPr/>
           <p:nvPr/>
         </p:nvSpPr>
@@ -13681,7 +13800,7 @@
       </p:sp>
       <p:sp>
         <p:nvSpPr>
-          <p:cNvPr id="33" name="Text 28"/>
+          <p:cNvPr id="35" name="Text 30"/>
           <p:cNvSpPr txBox="1"/>
           <p:nvPr/>
         </p:nvSpPr>
@@ -13717,7 +13836,7 @@
       </p:sp>
       <p:sp>
         <p:nvSpPr>
-          <p:cNvPr id="34" name="Text 29"/>
+          <p:cNvPr id="36" name="Text 31"/>
           <p:cNvSpPr txBox="1"/>
           <p:nvPr/>
         </p:nvSpPr>
@@ -13753,7 +13872,7 @@
       </p:sp>
       <p:sp>
         <p:nvSpPr>
-          <p:cNvPr id="35" name="Text 30"/>
+          <p:cNvPr id="37" name="Text 32"/>
           <p:cNvSpPr txBox="1"/>
           <p:nvPr/>
         </p:nvSpPr>
@@ -13803,7 +13922,7 @@
       </p:sp>
       <p:sp>
         <p:nvSpPr>
-          <p:cNvPr id="36" name="Shape 31"/>
+          <p:cNvPr id="38" name="Shape 33"/>
           <p:cNvSpPr/>
           <p:nvPr/>
         </p:nvSpPr>
@@ -13823,7 +13942,7 @@
       </p:sp>
       <p:sp>
         <p:nvSpPr>
-          <p:cNvPr id="37" name="Shape 32"/>
+          <p:cNvPr id="39" name="Shape 34"/>
           <p:cNvSpPr/>
           <p:nvPr/>
         </p:nvSpPr>
@@ -13845,7 +13964,7 @@
       </p:sp>
       <p:pic>
         <p:nvPicPr>
-          <p:cNvPr id="38" name="Image 3" descr="preencoded.png">    </p:cNvPr>
+          <p:cNvPr id="40" name="Image 3" descr="preencoded.png">    </p:cNvPr>
           <p:cNvPicPr>
             <a:picLocks noChangeAspect="1"/>
           </p:cNvPicPr>
@@ -13869,7 +13988,7 @@
       </p:pic>
       <p:sp>
         <p:nvSpPr>
-          <p:cNvPr id="39" name="Text 33"/>
+          <p:cNvPr id="41" name="Text 35"/>
           <p:cNvSpPr txBox="1"/>
           <p:nvPr/>
         </p:nvSpPr>
@@ -14331,7 +14450,7 @@
                   <a:schemeClr val="tx1"/>
                 </a:solidFill>
               </a:rPr>
-              <a:t>经销商</a:t>
+              <a:t>原料经销商</a:t>
             </a:r>
             <a:endParaRPr lang="en-US" sz="1700" dirty="0"/>
           </a:p>
@@ -14510,7 +14629,7 @@
                   <a:schemeClr val="tx1"/>
                 </a:solidFill>
               </a:rPr>
-              <a:t>馒头生产企业</a:t>
+              <a:t>馒头生产厂</a:t>
             </a:r>
             <a:endParaRPr lang="en-US" sz="1700" dirty="0"/>
           </a:p>
@@ -14725,7 +14844,7 @@
                   <a:schemeClr val="tx2"/>
                 </a:solidFill>
               </a:rPr>
-              <a:t>门店、商超</a:t>
+              <a:t>3,719个潜在据点</a:t>
             </a:r>
             <a:endParaRPr lang="en-US" sz="1200" dirty="0"/>
           </a:p>
@@ -14739,7 +14858,7 @@
                   <a:schemeClr val="tx2"/>
                 </a:solidFill>
               </a:rPr>
-              <a:t>团餐等</a:t>
+              <a:t>属于此环节</a:t>
             </a:r>
             <a:endParaRPr lang="en-US" sz="1200" dirty="0"/>
           </a:p>
@@ -14932,12 +15051,12 @@
         </p:nvSpPr>
         <p:spPr>
           <a:xfrm>
-            <a:off x="548640" y="1554480"/>
-            <a:ext cx="4160520" cy="640080"/>
+            <a:off x="548640" y="1417320"/>
+            <a:ext cx="4160520" cy="502920"/>
           </a:xfrm>
           <a:prstGeom prst="roundRect">
             <a:avLst>
-              <a:gd name="adj" fmla="val 11429"/>
+              <a:gd name="adj" fmla="val 14545"/>
             </a:avLst>
           </a:prstGeom>
           <a:solidFill>
@@ -14954,8 +15073,8 @@
         </p:nvSpPr>
         <p:spPr>
           <a:xfrm>
-            <a:off x="731520" y="1554480"/>
-            <a:ext cx="3931920" cy="640080"/>
+            <a:off x="731520" y="1417320"/>
+            <a:ext cx="3931920" cy="502920"/>
           </a:xfrm>
           <a:prstGeom prst="rect">
             <a:avLst/>
@@ -14987,7 +15106,7 @@
                   <a:schemeClr val="tx1"/>
                 </a:solidFill>
               </a:rPr>
-              <a:t>中粮海嘉面粉 + 陈博士五行配方</a:t>
+              <a:t>中粮海嘉面粉 + 陈博士配方，合作开发</a:t>
             </a:r>
             <a:endParaRPr lang="en-US" sz="1400" dirty="0"/>
           </a:p>
@@ -15001,8 +15120,124 @@
         </p:nvSpPr>
         <p:spPr>
           <a:xfrm>
-            <a:off x="1481328" y="2194560"/>
-            <a:ext cx="0" cy="320040"/>
+            <a:off x="2843784" y="2011680"/>
+            <a:ext cx="4169664" cy="329184"/>
+          </a:xfrm>
+          <a:prstGeom prst="roundRect">
+            <a:avLst>
+              <a:gd name="adj" fmla="val 50000"/>
+            </a:avLst>
+          </a:prstGeom>
+          <a:solidFill>
+            <a:schemeClr val="accent1"/>
+          </a:solidFill>
+          <a:ln/>
+        </p:spPr>
+      </p:sp>
+      <p:sp>
+        <p:nvSpPr>
+          <p:cNvPr id="36" name="Text 29"/>
+          <p:cNvSpPr txBox="1"/>
+          <p:nvPr/>
+        </p:nvSpPr>
+        <p:spPr>
+          <a:xfrm>
+            <a:off x="2843784" y="2011680"/>
+            <a:ext cx="4169664" cy="329184"/>
+          </a:xfrm>
+          <a:prstGeom prst="rect">
+            <a:avLst/>
+          </a:prstGeom>
+          <a:noFill/>
+          <a:ln/>
+        </p:spPr>
+        <p:txBody>
+          <a:bodyPr wrap="square" lIns="0" tIns="0" rIns="0" bIns="0" rtlCol="0" anchor="ctr"/>
+          <a:lstStyle/>
+          <a:p>
+            <a:pPr algn="ctr" indent="0" marL="0">
+              <a:buNone/>
+            </a:pPr>
+            <a:r>
+              <a:rPr lang="en-US" sz="1100" b="1" dirty="0">
+                <a:solidFill>
+                  <a:schemeClr val="bg1"/>
+                </a:solidFill>
+              </a:rPr>
+              <a:t>B2B 直接销售对象</a:t>
+            </a:r>
+            <a:endParaRPr lang="en-US" sz="1100" dirty="0"/>
+          </a:p>
+        </p:txBody>
+      </p:sp>
+      <p:sp>
+        <p:nvSpPr>
+          <p:cNvPr id="37" name="Shape 30"/>
+          <p:cNvSpPr/>
+          <p:nvPr/>
+        </p:nvSpPr>
+        <p:spPr>
+          <a:xfrm>
+            <a:off x="7434072" y="2011680"/>
+            <a:ext cx="4169664" cy="329184"/>
+          </a:xfrm>
+          <a:prstGeom prst="roundRect">
+            <a:avLst>
+              <a:gd name="adj" fmla="val 50000"/>
+            </a:avLst>
+          </a:prstGeom>
+          <a:solidFill>
+            <a:schemeClr val="accent4"/>
+          </a:solidFill>
+          <a:ln/>
+        </p:spPr>
+      </p:sp>
+      <p:sp>
+        <p:nvSpPr>
+          <p:cNvPr id="38" name="Text 31"/>
+          <p:cNvSpPr txBox="1"/>
+          <p:nvPr/>
+        </p:nvSpPr>
+        <p:spPr>
+          <a:xfrm>
+            <a:off x="7434072" y="2011680"/>
+            <a:ext cx="4169664" cy="329184"/>
+          </a:xfrm>
+          <a:prstGeom prst="rect">
+            <a:avLst/>
+          </a:prstGeom>
+          <a:noFill/>
+          <a:ln/>
+        </p:spPr>
+        <p:txBody>
+          <a:bodyPr wrap="square" lIns="0" tIns="0" rIns="0" bIns="0" rtlCol="0" anchor="ctr"/>
+          <a:lstStyle/>
+          <a:p>
+            <a:pPr algn="ctr" indent="0" marL="0">
+              <a:buNone/>
+            </a:pPr>
+            <a:r>
+              <a:rPr lang="en-US" sz="1100" b="1" dirty="0">
+                <a:solidFill>
+                  <a:schemeClr val="tx1"/>
+                </a:solidFill>
+              </a:rPr>
+              <a:t>下游终端（间接拉动，非直接客户）</a:t>
+            </a:r>
+            <a:endParaRPr lang="en-US" sz="1100" dirty="0"/>
+          </a:p>
+        </p:txBody>
+      </p:sp>
+      <p:sp>
+        <p:nvSpPr>
+          <p:cNvPr id="39" name="Shape 32"/>
+          <p:cNvSpPr/>
+          <p:nvPr/>
+        </p:nvSpPr>
+        <p:spPr>
+          <a:xfrm>
+            <a:off x="1481328" y="1920240"/>
+            <a:ext cx="0" cy="594360"/>
           </a:xfrm>
           <a:prstGeom prst="line">
             <a:avLst/>
@@ -15019,7 +15254,7 @@
       </p:sp>
       <p:sp>
         <p:nvSpPr>
-          <p:cNvPr id="36" name="Shape 29"/>
+          <p:cNvPr id="40" name="Shape 33"/>
           <p:cNvSpPr/>
           <p:nvPr/>
         </p:nvSpPr>
@@ -15039,7 +15274,7 @@
       </p:sp>
       <p:sp>
         <p:nvSpPr>
-          <p:cNvPr id="37" name="Text 30"/>
+          <p:cNvPr id="41" name="Text 34"/>
           <p:cNvSpPr txBox="1"/>
           <p:nvPr/>
         </p:nvSpPr>
@@ -15213,7 +15448,7 @@
                   <a:schemeClr val="tx1"/>
                 </a:solidFill>
               </a:rPr>
-              <a:t>福建：3,719个潜在渠道据点，作为首个示范市场</a:t>
+              <a:t>福建：3,719个潜在终端渠道据点，支撑示范市场动销</a:t>
             </a:r>
             <a:endParaRPr lang="en-US" sz="3000" dirty="0"/>
           </a:p>
@@ -15358,7 +15593,7 @@
                   <a:schemeClr val="bg1"/>
                 </a:solidFill>
               </a:rPr>
-              <a:t>个潜在渠道据点（福建省）</a:t>
+              <a:t>个潜在终端渠道据点（福建省）</a:t>
             </a:r>
             <a:endParaRPr lang="en-US" sz="1500" dirty="0"/>
           </a:p>
@@ -15576,7 +15811,76 @@
       </p:sp>
       <p:sp>
         <p:nvSpPr>
-          <p:cNvPr id="16" name="Text 13"/>
+          <p:cNvPr id="16" name="Shape 13"/>
+          <p:cNvSpPr/>
+          <p:nvPr/>
+        </p:nvSpPr>
+        <p:spPr>
+          <a:xfrm>
+            <a:off x="4754880" y="4709160"/>
+            <a:ext cx="6858000" cy="1097280"/>
+          </a:xfrm>
+          <a:prstGeom prst="roundRect">
+            <a:avLst>
+              <a:gd name="adj" fmla="val 6667"/>
+            </a:avLst>
+          </a:prstGeom>
+          <a:solidFill>
+            <a:schemeClr val="accent4"/>
+          </a:solidFill>
+          <a:ln/>
+        </p:spPr>
+      </p:sp>
+      <p:sp>
+        <p:nvSpPr>
+          <p:cNvPr id="17" name="Text 14"/>
+          <p:cNvSpPr txBox="1"/>
+          <p:nvPr/>
+        </p:nvSpPr>
+        <p:spPr>
+          <a:xfrm>
+            <a:off x="4937760" y="4709160"/>
+            <a:ext cx="6492240" cy="1097280"/>
+          </a:xfrm>
+          <a:prstGeom prst="rect">
+            <a:avLst/>
+          </a:prstGeom>
+          <a:noFill/>
+          <a:ln/>
+        </p:spPr>
+        <p:txBody>
+          <a:bodyPr wrap="square" lIns="0" tIns="0" rIns="0" bIns="0" rtlCol="0" anchor="ctr"/>
+          <a:lstStyle/>
+          <a:p>
+            <a:pPr indent="0" marL="0">
+              <a:buNone/>
+            </a:pPr>
+            <a:r>
+              <a:rPr lang="en-US" sz="1300" b="1" dirty="0">
+                <a:solidFill>
+                  <a:schemeClr val="accent5"/>
+                </a:solidFill>
+              </a:rPr>
+              <a:t>客户定位：</a:t>
+            </a:r>
+            <a:pPr indent="0" marL="0">
+              <a:buNone/>
+            </a:pPr>
+            <a:r>
+              <a:rPr lang="en-US" sz="1300" dirty="0">
+                <a:solidFill>
+                  <a:schemeClr val="tx1"/>
+                </a:solidFill>
+              </a:rPr>
+              <a:t>B2B 直接销售对象为原料经销商及馒头生产厂；3,719个据点是馒头产品的潜在终端渠道资源，用于带动下游动销，不是预拌粉的直接客户。</a:t>
+            </a:r>
+            <a:endParaRPr lang="en-US" sz="1300" dirty="0"/>
+          </a:p>
+        </p:txBody>
+      </p:sp>
+      <p:sp>
+        <p:nvSpPr>
+          <p:cNvPr id="18" name="Text 15"/>
           <p:cNvSpPr txBox="1"/>
           <p:nvPr/>
         </p:nvSpPr>
@@ -15604,7 +15908,7 @@
                   <a:schemeClr val="tx1"/>
                 </a:solidFill>
               </a:rPr>
-              <a:t>渠道据点分类</a:t>
+              <a:t>终端渠道据点分类</a:t>
             </a:r>
             <a:endParaRPr lang="en-US" sz="1800" dirty="0"/>
           </a:p>
@@ -15637,7 +15941,7 @@
                 <a:gridCol w="1280160"/>
                 <a:gridCol w="2926080"/>
               </a:tblGrid>
-              <a:tr h="438912">
+              <a:tr h="411480">
                 <a:tc>
                   <a:txBody>
                     <a:bodyPr/>
@@ -15822,7 +16126,7 @@
                   </a:tcPr>
                 </a:tc>
               </a:tr>
-              <a:tr h="438912">
+              <a:tr h="411480">
                 <a:tc>
                   <a:txBody>
                     <a:bodyPr/>
@@ -15837,7 +16141,7 @@
                             <a:schemeClr val="tx1"/>
                           </a:solidFill>
                         </a:rPr>
-                        <a:t>馒头 / 包子生产企业</a:t>
+                        <a:t>早餐店及面点门店</a:t>
                       </a:r>
                       <a:endParaRPr lang="en-US" sz="1300" dirty="0"/>
                     </a:p>
@@ -15959,7 +16263,7 @@
                             <a:schemeClr val="tx1"/>
                           </a:solidFill>
                         </a:rPr>
-                        <a:t>预拌粉直接使用方</a:t>
+                        <a:t>现做现售终端</a:t>
                       </a:r>
                       <a:endParaRPr lang="en-US" sz="1300" dirty="0"/>
                     </a:p>
@@ -16007,7 +16311,7 @@
                   </a:tcPr>
                 </a:tc>
               </a:tr>
-              <a:tr h="438912">
+              <a:tr h="411480">
                 <a:tc>
                   <a:txBody>
                     <a:bodyPr/>
@@ -16022,7 +16326,7 @@
                             <a:schemeClr val="tx1"/>
                           </a:solidFill>
                         </a:rPr>
-                        <a:t>经销 / 批发商</a:t>
+                        <a:t>商超 / 农贸市场</a:t>
                       </a:r>
                       <a:endParaRPr lang="en-US" sz="1300" dirty="0"/>
                     </a:p>
@@ -16144,7 +16448,7 @@
                             <a:schemeClr val="tx1"/>
                           </a:solidFill>
                         </a:rPr>
-                        <a:t>区域分销</a:t>
+                        <a:t>零售终端</a:t>
                       </a:r>
                       <a:endParaRPr lang="en-US" sz="1300" dirty="0"/>
                     </a:p>
@@ -16192,7 +16496,7 @@
                   </a:tcPr>
                 </a:tc>
               </a:tr>
-              <a:tr h="438912">
+              <a:tr h="411480">
                 <a:tc>
                   <a:txBody>
                     <a:bodyPr/>
@@ -16207,7 +16511,7 @@
                             <a:schemeClr val="tx1"/>
                           </a:solidFill>
                         </a:rPr>
-                        <a:t>早餐店及面点门店</a:t>
+                        <a:t>团餐 / 单位食堂</a:t>
                       </a:r>
                       <a:endParaRPr lang="en-US" sz="1300" dirty="0"/>
                     </a:p>
@@ -16329,7 +16633,7 @@
                             <a:schemeClr val="tx1"/>
                           </a:solidFill>
                         </a:rPr>
-                        <a:t>现做现售终端</a:t>
+                        <a:t>集中采购终端</a:t>
                       </a:r>
                       <a:endParaRPr lang="en-US" sz="1300" dirty="0"/>
                     </a:p>
@@ -16377,7 +16681,7 @@
                   </a:tcPr>
                 </a:tc>
               </a:tr>
-              <a:tr h="438912">
+              <a:tr h="411480">
                 <a:tc>
                   <a:txBody>
                     <a:bodyPr/>
@@ -16392,7 +16696,7 @@
                             <a:schemeClr val="tx1"/>
                           </a:solidFill>
                         </a:rPr>
-                        <a:t>商超 / 农贸市场</a:t>
+                        <a:t>其他</a:t>
                       </a:r>
                       <a:endParaRPr lang="en-US" sz="1300" dirty="0"/>
                     </a:p>
@@ -16514,7 +16818,7 @@
                             <a:schemeClr val="tx1"/>
                           </a:solidFill>
                         </a:rPr>
-                        <a:t>零售终端</a:t>
+                        <a:t>—</a:t>
                       </a:r>
                       <a:endParaRPr lang="en-US" sz="1300" dirty="0"/>
                     </a:p>
@@ -16562,377 +16866,7 @@
                   </a:tcPr>
                 </a:tc>
               </a:tr>
-              <a:tr h="438912">
-                <a:tc>
-                  <a:txBody>
-                    <a:bodyPr/>
-                    <a:lstStyle/>
-                    <a:p>
-                      <a:pPr indent="0" marL="0">
-                        <a:buNone/>
-                      </a:pPr>
-                      <a:r>
-                        <a:rPr lang="en-US" sz="1300" dirty="0">
-                          <a:solidFill>
-                            <a:schemeClr val="tx1"/>
-                          </a:solidFill>
-                        </a:rPr>
-                        <a:t>团餐 / 单位食堂</a:t>
-                      </a:r>
-                      <a:endParaRPr lang="en-US" sz="1300" dirty="0"/>
-                    </a:p>
-                  </a:txBody>
-                  <a:tcPr marL="109728" marR="109728" marT="0" marB="0" anchor="ctr">
-                    <a:lnL w="9525" cap="flat" cmpd="sng" algn="ctr">
-                      <a:solidFill>
-                        <a:srgbClr val="EADFC8"/>
-                      </a:solidFill>
-                      <a:prstDash val="solid"/>
-                      <a:round/>
-                      <a:headEnd type="none" w="med" len="med"/>
-                      <a:tailEnd type="none" w="med" len="med"/>
-                    </a:lnL>
-                    <a:lnR w="9525" cap="flat" cmpd="sng" algn="ctr">
-                      <a:solidFill>
-                        <a:srgbClr val="EADFC8"/>
-                      </a:solidFill>
-                      <a:prstDash val="solid"/>
-                      <a:round/>
-                      <a:headEnd type="none" w="med" len="med"/>
-                      <a:tailEnd type="none" w="med" len="med"/>
-                    </a:lnR>
-                    <a:lnT w="9525" cap="flat" cmpd="sng" algn="ctr">
-                      <a:solidFill>
-                        <a:srgbClr val="EADFC8"/>
-                      </a:solidFill>
-                      <a:prstDash val="solid"/>
-                      <a:round/>
-                      <a:headEnd type="none" w="med" len="med"/>
-                      <a:tailEnd type="none" w="med" len="med"/>
-                    </a:lnT>
-                    <a:lnB w="9525" cap="flat" cmpd="sng" algn="ctr">
-                      <a:solidFill>
-                        <a:srgbClr val="EADFC8"/>
-                      </a:solidFill>
-                      <a:prstDash val="solid"/>
-                      <a:round/>
-                      <a:headEnd type="none" w="med" len="med"/>
-                      <a:tailEnd type="none" w="med" len="med"/>
-                    </a:lnB>
-                    <a:solidFill>
-                      <a:schemeClr val="bg1"/>
-                    </a:solidFill>
-                  </a:tcPr>
-                </a:tc>
-                <a:tc>
-                  <a:txBody>
-                    <a:bodyPr/>
-                    <a:lstStyle/>
-                    <a:p>
-                      <a:pPr algn="r" indent="0" marL="0">
-                        <a:buNone/>
-                      </a:pPr>
-                      <a:r>
-                        <a:rPr lang="en-US" sz="1300" dirty="0">
-                          <a:solidFill>
-                            <a:schemeClr val="accent5"/>
-                          </a:solidFill>
-                        </a:rPr>
-                        <a:t>待填</a:t>
-                      </a:r>
-                      <a:endParaRPr lang="en-US" sz="1300" dirty="0"/>
-                    </a:p>
-                  </a:txBody>
-                  <a:tcPr marL="109728" marR="109728" marT="0" marB="0" anchor="ctr">
-                    <a:lnL w="9525" cap="flat" cmpd="sng" algn="ctr">
-                      <a:solidFill>
-                        <a:srgbClr val="EADFC8"/>
-                      </a:solidFill>
-                      <a:prstDash val="solid"/>
-                      <a:round/>
-                      <a:headEnd type="none" w="med" len="med"/>
-                      <a:tailEnd type="none" w="med" len="med"/>
-                    </a:lnL>
-                    <a:lnR w="9525" cap="flat" cmpd="sng" algn="ctr">
-                      <a:solidFill>
-                        <a:srgbClr val="EADFC8"/>
-                      </a:solidFill>
-                      <a:prstDash val="solid"/>
-                      <a:round/>
-                      <a:headEnd type="none" w="med" len="med"/>
-                      <a:tailEnd type="none" w="med" len="med"/>
-                    </a:lnR>
-                    <a:lnT w="9525" cap="flat" cmpd="sng" algn="ctr">
-                      <a:solidFill>
-                        <a:srgbClr val="EADFC8"/>
-                      </a:solidFill>
-                      <a:prstDash val="solid"/>
-                      <a:round/>
-                      <a:headEnd type="none" w="med" len="med"/>
-                      <a:tailEnd type="none" w="med" len="med"/>
-                    </a:lnT>
-                    <a:lnB w="9525" cap="flat" cmpd="sng" algn="ctr">
-                      <a:solidFill>
-                        <a:srgbClr val="EADFC8"/>
-                      </a:solidFill>
-                      <a:prstDash val="solid"/>
-                      <a:round/>
-                      <a:headEnd type="none" w="med" len="med"/>
-                      <a:tailEnd type="none" w="med" len="med"/>
-                    </a:lnB>
-                    <a:solidFill>
-                      <a:schemeClr val="bg1"/>
-                    </a:solidFill>
-                  </a:tcPr>
-                </a:tc>
-                <a:tc>
-                  <a:txBody>
-                    <a:bodyPr/>
-                    <a:lstStyle/>
-                    <a:p>
-                      <a:pPr indent="0" marL="0">
-                        <a:buNone/>
-                      </a:pPr>
-                      <a:r>
-                        <a:rPr lang="en-US" sz="1300" dirty="0">
-                          <a:solidFill>
-                            <a:schemeClr val="tx1"/>
-                          </a:solidFill>
-                        </a:rPr>
-                        <a:t>集中采购终端</a:t>
-                      </a:r>
-                      <a:endParaRPr lang="en-US" sz="1300" dirty="0"/>
-                    </a:p>
-                  </a:txBody>
-                  <a:tcPr marL="109728" marR="109728" marT="0" marB="0" anchor="ctr">
-                    <a:lnL w="9525" cap="flat" cmpd="sng" algn="ctr">
-                      <a:solidFill>
-                        <a:srgbClr val="EADFC8"/>
-                      </a:solidFill>
-                      <a:prstDash val="solid"/>
-                      <a:round/>
-                      <a:headEnd type="none" w="med" len="med"/>
-                      <a:tailEnd type="none" w="med" len="med"/>
-                    </a:lnL>
-                    <a:lnR w="9525" cap="flat" cmpd="sng" algn="ctr">
-                      <a:solidFill>
-                        <a:srgbClr val="EADFC8"/>
-                      </a:solidFill>
-                      <a:prstDash val="solid"/>
-                      <a:round/>
-                      <a:headEnd type="none" w="med" len="med"/>
-                      <a:tailEnd type="none" w="med" len="med"/>
-                    </a:lnR>
-                    <a:lnT w="9525" cap="flat" cmpd="sng" algn="ctr">
-                      <a:solidFill>
-                        <a:srgbClr val="EADFC8"/>
-                      </a:solidFill>
-                      <a:prstDash val="solid"/>
-                      <a:round/>
-                      <a:headEnd type="none" w="med" len="med"/>
-                      <a:tailEnd type="none" w="med" len="med"/>
-                    </a:lnT>
-                    <a:lnB w="9525" cap="flat" cmpd="sng" algn="ctr">
-                      <a:solidFill>
-                        <a:srgbClr val="EADFC8"/>
-                      </a:solidFill>
-                      <a:prstDash val="solid"/>
-                      <a:round/>
-                      <a:headEnd type="none" w="med" len="med"/>
-                      <a:tailEnd type="none" w="med" len="med"/>
-                    </a:lnB>
-                    <a:solidFill>
-                      <a:schemeClr val="bg1"/>
-                    </a:solidFill>
-                  </a:tcPr>
-                </a:tc>
-              </a:tr>
-              <a:tr h="438912">
-                <a:tc>
-                  <a:txBody>
-                    <a:bodyPr/>
-                    <a:lstStyle/>
-                    <a:p>
-                      <a:pPr indent="0" marL="0">
-                        <a:buNone/>
-                      </a:pPr>
-                      <a:r>
-                        <a:rPr lang="en-US" sz="1300" dirty="0">
-                          <a:solidFill>
-                            <a:schemeClr val="tx1"/>
-                          </a:solidFill>
-                        </a:rPr>
-                        <a:t>其他</a:t>
-                      </a:r>
-                      <a:endParaRPr lang="en-US" sz="1300" dirty="0"/>
-                    </a:p>
-                  </a:txBody>
-                  <a:tcPr marL="109728" marR="109728" marT="0" marB="0" anchor="ctr">
-                    <a:lnL w="9525" cap="flat" cmpd="sng" algn="ctr">
-                      <a:solidFill>
-                        <a:srgbClr val="EADFC8"/>
-                      </a:solidFill>
-                      <a:prstDash val="solid"/>
-                      <a:round/>
-                      <a:headEnd type="none" w="med" len="med"/>
-                      <a:tailEnd type="none" w="med" len="med"/>
-                    </a:lnL>
-                    <a:lnR w="9525" cap="flat" cmpd="sng" algn="ctr">
-                      <a:solidFill>
-                        <a:srgbClr val="EADFC8"/>
-                      </a:solidFill>
-                      <a:prstDash val="solid"/>
-                      <a:round/>
-                      <a:headEnd type="none" w="med" len="med"/>
-                      <a:tailEnd type="none" w="med" len="med"/>
-                    </a:lnR>
-                    <a:lnT w="9525" cap="flat" cmpd="sng" algn="ctr">
-                      <a:solidFill>
-                        <a:srgbClr val="EADFC8"/>
-                      </a:solidFill>
-                      <a:prstDash val="solid"/>
-                      <a:round/>
-                      <a:headEnd type="none" w="med" len="med"/>
-                      <a:tailEnd type="none" w="med" len="med"/>
-                    </a:lnT>
-                    <a:lnB w="9525" cap="flat" cmpd="sng" algn="ctr">
-                      <a:solidFill>
-                        <a:srgbClr val="EADFC8"/>
-                      </a:solidFill>
-                      <a:prstDash val="solid"/>
-                      <a:round/>
-                      <a:headEnd type="none" w="med" len="med"/>
-                      <a:tailEnd type="none" w="med" len="med"/>
-                    </a:lnB>
-                    <a:solidFill>
-                      <a:schemeClr val="bg1"/>
-                    </a:solidFill>
-                  </a:tcPr>
-                </a:tc>
-                <a:tc>
-                  <a:txBody>
-                    <a:bodyPr/>
-                    <a:lstStyle/>
-                    <a:p>
-                      <a:pPr algn="r" indent="0" marL="0">
-                        <a:buNone/>
-                      </a:pPr>
-                      <a:r>
-                        <a:rPr lang="en-US" sz="1300" dirty="0">
-                          <a:solidFill>
-                            <a:schemeClr val="accent5"/>
-                          </a:solidFill>
-                        </a:rPr>
-                        <a:t>待填</a:t>
-                      </a:r>
-                      <a:endParaRPr lang="en-US" sz="1300" dirty="0"/>
-                    </a:p>
-                  </a:txBody>
-                  <a:tcPr marL="109728" marR="109728" marT="0" marB="0" anchor="ctr">
-                    <a:lnL w="9525" cap="flat" cmpd="sng" algn="ctr">
-                      <a:solidFill>
-                        <a:srgbClr val="EADFC8"/>
-                      </a:solidFill>
-                      <a:prstDash val="solid"/>
-                      <a:round/>
-                      <a:headEnd type="none" w="med" len="med"/>
-                      <a:tailEnd type="none" w="med" len="med"/>
-                    </a:lnL>
-                    <a:lnR w="9525" cap="flat" cmpd="sng" algn="ctr">
-                      <a:solidFill>
-                        <a:srgbClr val="EADFC8"/>
-                      </a:solidFill>
-                      <a:prstDash val="solid"/>
-                      <a:round/>
-                      <a:headEnd type="none" w="med" len="med"/>
-                      <a:tailEnd type="none" w="med" len="med"/>
-                    </a:lnR>
-                    <a:lnT w="9525" cap="flat" cmpd="sng" algn="ctr">
-                      <a:solidFill>
-                        <a:srgbClr val="EADFC8"/>
-                      </a:solidFill>
-                      <a:prstDash val="solid"/>
-                      <a:round/>
-                      <a:headEnd type="none" w="med" len="med"/>
-                      <a:tailEnd type="none" w="med" len="med"/>
-                    </a:lnT>
-                    <a:lnB w="9525" cap="flat" cmpd="sng" algn="ctr">
-                      <a:solidFill>
-                        <a:srgbClr val="EADFC8"/>
-                      </a:solidFill>
-                      <a:prstDash val="solid"/>
-                      <a:round/>
-                      <a:headEnd type="none" w="med" len="med"/>
-                      <a:tailEnd type="none" w="med" len="med"/>
-                    </a:lnB>
-                    <a:solidFill>
-                      <a:schemeClr val="bg1"/>
-                    </a:solidFill>
-                  </a:tcPr>
-                </a:tc>
-                <a:tc>
-                  <a:txBody>
-                    <a:bodyPr/>
-                    <a:lstStyle/>
-                    <a:p>
-                      <a:pPr indent="0" marL="0">
-                        <a:buNone/>
-                      </a:pPr>
-                      <a:r>
-                        <a:rPr lang="en-US" sz="1300" dirty="0">
-                          <a:solidFill>
-                            <a:schemeClr val="tx1"/>
-                          </a:solidFill>
-                        </a:rPr>
-                        <a:t>—</a:t>
-                      </a:r>
-                      <a:endParaRPr lang="en-US" sz="1300" dirty="0"/>
-                    </a:p>
-                  </a:txBody>
-                  <a:tcPr marL="109728" marR="109728" marT="0" marB="0" anchor="ctr">
-                    <a:lnL w="9525" cap="flat" cmpd="sng" algn="ctr">
-                      <a:solidFill>
-                        <a:srgbClr val="EADFC8"/>
-                      </a:solidFill>
-                      <a:prstDash val="solid"/>
-                      <a:round/>
-                      <a:headEnd type="none" w="med" len="med"/>
-                      <a:tailEnd type="none" w="med" len="med"/>
-                    </a:lnL>
-                    <a:lnR w="9525" cap="flat" cmpd="sng" algn="ctr">
-                      <a:solidFill>
-                        <a:srgbClr val="EADFC8"/>
-                      </a:solidFill>
-                      <a:prstDash val="solid"/>
-                      <a:round/>
-                      <a:headEnd type="none" w="med" len="med"/>
-                      <a:tailEnd type="none" w="med" len="med"/>
-                    </a:lnR>
-                    <a:lnT w="9525" cap="flat" cmpd="sng" algn="ctr">
-                      <a:solidFill>
-                        <a:srgbClr val="EADFC8"/>
-                      </a:solidFill>
-                      <a:prstDash val="solid"/>
-                      <a:round/>
-                      <a:headEnd type="none" w="med" len="med"/>
-                      <a:tailEnd type="none" w="med" len="med"/>
-                    </a:lnT>
-                    <a:lnB w="9525" cap="flat" cmpd="sng" algn="ctr">
-                      <a:solidFill>
-                        <a:srgbClr val="EADFC8"/>
-                      </a:solidFill>
-                      <a:prstDash val="solid"/>
-                      <a:round/>
-                      <a:headEnd type="none" w="med" len="med"/>
-                      <a:tailEnd type="none" w="med" len="med"/>
-                    </a:lnB>
-                    <a:solidFill>
-                      <a:schemeClr val="bg1"/>
-                    </a:solidFill>
-                  </a:tcPr>
-                </a:tc>
-              </a:tr>
-              <a:tr h="438912">
+              <a:tr h="411480">
                 <a:tc>
                   <a:txBody>
                     <a:bodyPr/>
@@ -17123,7 +17057,7 @@
       </p:graphicFrame>
       <p:sp>
         <p:nvSpPr>
-          <p:cNvPr id="18" name="Text 14"/>
+          <p:cNvPr id="20" name="Text 16"/>
           <p:cNvSpPr txBox="1"/>
           <p:nvPr/>
         </p:nvSpPr>
@@ -17151,7 +17085,7 @@
                   <a:schemeClr val="tx2"/>
                 </a:solidFill>
               </a:rPr>
-              <a:t>注：分类为建议框架，各类数量待合作伙伴提供明细后填入；据点数据未经去重、未确认进场意向，不代表已有客户或订单。</a:t>
+              <a:t>注：分类为建议框架，各类数量待合作伙伴提供明细后填入；据点数据未经去重、未确认进场，不代表已有客户或订单。</a:t>
             </a:r>
             <a:endParaRPr lang="en-US" sz="1000" dirty="0"/>
           </a:p>
@@ -18800,7 +18734,7 @@
                   <a:schemeClr val="tx1"/>
                 </a:solidFill>
               </a:rPr>
-              <a:t>三种合作收益模式，供集团比较选择</a:t>
+              <a:t>三种合作收益模式并列，供双方比较议定</a:t>
             </a:r>
             <a:endParaRPr lang="en-US" sz="3000" dirty="0"/>
           </a:p>
@@ -18821,7 +18755,7 @@
             <a:avLst/>
           </a:prstGeom>
           <a:solidFill>
-            <a:schemeClr val="accent2"/>
+            <a:schemeClr val="accent1"/>
           </a:solidFill>
           <a:ln/>
         </p:spPr>
@@ -18909,7 +18843,7 @@
             <a:r>
               <a:rPr lang="en-US" sz="1600" b="1" dirty="0">
                 <a:solidFill>
-                  <a:schemeClr val="tx1"/>
+                  <a:schemeClr val="bg1"/>
                 </a:solidFill>
               </a:rPr>
               <a:t>特色粉体供货合作</a:t>
@@ -19045,7 +18979,7 @@
             <a:avLst/>
           </a:prstGeom>
           <a:solidFill>
-            <a:schemeClr val="accent3"/>
+            <a:schemeClr val="accent1"/>
           </a:solidFill>
           <a:ln/>
         </p:spPr>
@@ -19246,7 +19180,7 @@
                             <a:schemeClr val="tx1"/>
                           </a:solidFill>
                         </a:rPr>
-                        <a:t>陈博士团队供应特色粉体，海嘉混配生产与销售</a:t>
+                        <a:t>按约定供应五行特色粉体，用于预拌粉生产</a:t>
                       </a:r>
                       <a:endParaRPr lang="en-US" sz="1300" dirty="0"/>
                     </a:p>
@@ -19307,7 +19241,7 @@
                             <a:schemeClr val="tx1"/>
                           </a:solidFill>
                         </a:rPr>
-                        <a:t>陈博士团队授权配方与工艺，海嘉自主生产销售</a:t>
+                        <a:t>陈博士授权五行特色粉体配方与工艺</a:t>
                       </a:r>
                       <a:endParaRPr lang="en-US" sz="1300" dirty="0"/>
                     </a:p>
@@ -19368,7 +19302,7 @@
                             <a:schemeClr val="tx1"/>
                           </a:solidFill>
                         </a:rPr>
-                        <a:t>双方共同经营产品线，按约定分配利润</a:t>
+                        <a:t>双方共同经营五行预拌粉，按约定分配利润</a:t>
                       </a:r>
                       <a:endParaRPr lang="en-US" sz="1300" dirty="0"/>
                     </a:p>
@@ -19431,7 +19365,7 @@
                             <a:schemeClr val="accent3"/>
                           </a:solidFill>
                         </a:rPr>
-                        <a:t>技术方收益</a:t>
+                        <a:t>收益来源</a:t>
                       </a:r>
                       <a:endParaRPr lang="en-US" sz="1300" dirty="0"/>
                     </a:p>
@@ -20169,7 +20103,7 @@
                             <a:schemeClr val="accent3"/>
                           </a:solidFill>
                         </a:rPr>
-                        <a:t>适用阶段</a:t>
+                        <a:t>待议定要点</a:t>
                       </a:r>
                       <a:endParaRPr lang="en-US" sz="1300" dirty="0"/>
                     </a:p>
@@ -20230,7 +20164,7 @@
                             <a:schemeClr val="tx1"/>
                           </a:solidFill>
                         </a:rPr>
-                        <a:t>试点期快速启动</a:t>
+                        <a:t>粉体生产方、供货价格与数量</a:t>
                       </a:r>
                       <a:endParaRPr lang="en-US" sz="1300" dirty="0"/>
                     </a:p>
@@ -20291,7 +20225,7 @@
                             <a:schemeClr val="tx1"/>
                           </a:solidFill>
                         </a:rPr>
-                        <a:t>规模化区域复制</a:t>
+                        <a:t>授权范围、费率与配方保护</a:t>
                       </a:r>
                       <a:endParaRPr lang="en-US" sz="1300" dirty="0"/>
                     </a:p>
@@ -20352,7 +20286,7 @@
                             <a:schemeClr val="tx1"/>
                           </a:solidFill>
                         </a:rPr>
-                        <a:t>长期战略合作</a:t>
+                        <a:t>出资、共管机制与分配比例</a:t>
                       </a:r>
                       <a:endParaRPr lang="en-US" sz="1300" dirty="0"/>
                     </a:p>
@@ -20434,7 +20368,7 @@
                   <a:schemeClr val="tx2"/>
                 </a:solidFill>
               </a:rPr>
-              <a:t>注：本矩阵为讨论用比较框架，三案均未获任何一方同意；具体条款、比例与费率须经双方正式谈判确定。</a:t>
+              <a:t>注：三案并列、无先后与推荐顺序，均未获双方同意；五行特色粉体由谁生产尚待议定；具体条款须经双方正式谈判确定。</a:t>
             </a:r>
             <a:endParaRPr lang="en-US" sz="1000" dirty="0"/>
           </a:p>

</xml_diff>

<commit_message>
DR-002: update P04 to five SKUs with compliant wording; refresh PDF
Co-Authored-By: Claude Opus 5.5 <noreply@anthropic.com>
Claude-Session: https://claude.ai/code/session_0137DxXVQUvWUjpTeTg3QLMn
</commit_message>
<xml_diff>
--- a/DR-002/DR-002_中粮海嘉五行预拌粉合作计划_V1.0.pptx
+++ b/DR-002/DR-002_中粮海嘉五行预拌粉合作计划_V1.0.pptx
@@ -120,44 +120,44 @@
   <p:extLst>
     <p:ext uri="{521415D9-36F7-43E2-AB2F-B90AF26B5E84}">
       <p14:sectionLst xmlns:p14="http://schemas.microsoft.com/office/powerpoint/2010/main">
-        <p14:section name="开篇" id="{8bab30d7-242a-ab7c-111d-bcabc901709e}">
+        <p14:section name="开篇" id="{03450c05-94df-5e00-690d-fd450fc6a8fe}">
           <p14:sldIdLst>
             <p14:sldId id="256"/>
           </p14:sldIdLst>
         </p14:section>
-        <p14:section name="合作基础" id="{6e14387e-6df2-c946-c62d-f229d7250772}">
+        <p14:section name="合作基础" id="{cb805b3d-8c3a-d237-6b8e-7a39ac3c368d}">
           <p14:sldIdLst>
             <p14:sldId id="257"/>
             <p14:sldId id="258"/>
           </p14:sldIdLst>
         </p14:section>
-        <p14:section name="产品与模式" id="{a4175476-4867-ba78-5085-f4f76bd16aba}">
+        <p14:section name="产品与模式" id="{555341eb-c640-a229-606e-e34033a82450}">
           <p14:sldIdLst>
             <p14:sldId id="259"/>
             <p14:sldId id="260"/>
             <p14:sldId id="261"/>
           </p14:sldIdLst>
         </p14:section>
-        <p14:section name="市场落地" id="{b1847636-fd66-0475-ddf8-cc682557dd30}">
+        <p14:section name="市场落地" id="{8ae3fb6b-be27-4a64-07d4-e99e114e2d62}">
           <p14:sldIdLst>
             <p14:sldId id="262"/>
           </p14:sldIdLst>
         </p14:section>
-        <p14:section name="收益与财务" id="{d04f7148-e693-415e-19e2-a92b2633b851}">
+        <p14:section name="收益与财务" id="{4ce5a13b-bf97-1e7c-8348-907a9d5658ef}">
           <p14:sldIdLst>
             <p14:sldId id="263"/>
             <p14:sldId id="264"/>
             <p14:sldId id="265"/>
           </p14:sldIdLst>
         </p14:section>
-        <p14:section name="行动计划" id="{bd703bfe-cae4-d1ed-3372-4587239c53ac}">
+        <p14:section name="行动计划" id="{f283d524-9f90-089a-4a0c-23cfed66501a}">
           <p14:sldIdLst>
             <p14:sldId id="266"/>
             <p14:sldId id="267"/>
             <p14:sldId id="268"/>
           </p14:sldIdLst>
         </p14:section>
-        <p14:section name="附件" id="{fef166c2-98ee-770f-13f8-9fbd3e48495f}">
+        <p14:section name="附件" id="{426db1c6-32b9-4b9b-7b9b-d84212136161}">
           <p14:sldIdLst>
             <p14:sldId id="269"/>
           </p14:sldIdLst>
@@ -1549,7 +1549,7 @@
           <a:p>
             <a:r>
               <a:rPr lang="en-US" dirty="0"/>
-              <a:t>宽瑜膳元五行功能配方：五黑、五红、茯苓山药、姜黄、海藻，均为馒头专用预拌粉，25公斤/包。五行指配方功能体系，不是颜色。各款功能定位待陈博士确认，对外表述须符合普通食品法规，不作疾病预防、治疗或保健功能声称。茯苓、山药、姜黄是否在适用的药食同源目录及使用范围内，须合规确认。</a:t>
+              <a:t>宽瑜膳元五行系列5个SKU：五黑馒头、五红馒头、茯苓馒头、姜黄馒头、海藻馒头，均为馒头专用预拌粉，25公斤/包。产品属普通食品，卡片文字为合规表述；各SKU的五行功能方向须经食品合规审核后再决定对外说法。茯苓、姜黄是否在适用的药食同源目录及使用范围内，须合规确认。</a:t>
             </a:r>
             <a:endParaRPr lang="en-US" dirty="0"/>
           </a:p>
@@ -11463,7 +11463,7 @@
                   <a:schemeClr val="tx1"/>
                 </a:solidFill>
               </a:rPr>
-              <a:t>宽瑜膳元五行功能配方：五款馒头专用预拌粉</a:t>
+              <a:t>宽瑜膳元五行系列：5个SKU，均为馒头专用预拌粉</a:t>
             </a:r>
             <a:endParaRPr lang="en-US" sz="3000" dirty="0"/>
           </a:p>
@@ -11471,7 +11471,7 @@
       </p:sp>
       <p:sp>
         <p:nvSpPr>
-          <p:cNvPr id="4" name="product-五黑"/>
+          <p:cNvPr id="4" name="product-五黑馒头"/>
           <p:cNvSpPr/>
           <p:nvPr/>
         </p:nvSpPr>
@@ -11506,14 +11506,70 @@
         </p:nvSpPr>
         <p:spPr>
           <a:xfrm>
-            <a:off x="1033272" y="1874520"/>
-            <a:ext cx="1097280" cy="1097280"/>
+            <a:off x="777240" y="1783080"/>
+            <a:ext cx="384048" cy="384048"/>
           </a:xfrm>
           <a:prstGeom prst="ellipse">
             <a:avLst/>
           </a:prstGeom>
           <a:solidFill>
             <a:schemeClr val="accent4"/>
+          </a:solidFill>
+          <a:ln/>
+        </p:spPr>
+      </p:sp>
+      <p:sp>
+        <p:nvSpPr>
+          <p:cNvPr id="6" name="Text 4"/>
+          <p:cNvSpPr txBox="1"/>
+          <p:nvPr/>
+        </p:nvSpPr>
+        <p:spPr>
+          <a:xfrm>
+            <a:off x="777240" y="1783080"/>
+            <a:ext cx="384048" cy="384048"/>
+          </a:xfrm>
+          <a:prstGeom prst="rect">
+            <a:avLst/>
+          </a:prstGeom>
+          <a:noFill/>
+          <a:ln/>
+        </p:spPr>
+        <p:txBody>
+          <a:bodyPr wrap="square" lIns="0" tIns="0" rIns="0" bIns="0" rtlCol="0" anchor="ctr"/>
+          <a:lstStyle/>
+          <a:p>
+            <a:pPr algn="ctr" indent="0" marL="0">
+              <a:buNone/>
+            </a:pPr>
+            <a:r>
+              <a:rPr lang="en-US" sz="1100" b="1" dirty="0">
+                <a:solidFill>
+                  <a:schemeClr val="tx1"/>
+                </a:solidFill>
+              </a:rPr>
+              <a:t>01</a:t>
+            </a:r>
+            <a:endParaRPr lang="en-US" sz="1100" dirty="0"/>
+          </a:p>
+        </p:txBody>
+      </p:sp>
+      <p:sp>
+        <p:nvSpPr>
+          <p:cNvPr id="7" name="Shape 5"/>
+          <p:cNvSpPr/>
+          <p:nvPr/>
+        </p:nvSpPr>
+        <p:spPr>
+          <a:xfrm>
+            <a:off x="1078992" y="1874520"/>
+            <a:ext cx="1005840" cy="1005840"/>
+          </a:xfrm>
+          <a:prstGeom prst="ellipse">
+            <a:avLst/>
+          </a:prstGeom>
+          <a:solidFill>
+            <a:srgbClr val="2F2A27"/>
           </a:solidFill>
           <a:ln w="19050">
             <a:solidFill>
@@ -11525,109 +11581,37 @@
       </p:sp>
       <p:sp>
         <p:nvSpPr>
-          <p:cNvPr id="6" name="Text 4"/>
-          <p:cNvSpPr txBox="1"/>
-          <p:nvPr/>
-        </p:nvSpPr>
-        <p:spPr>
-          <a:xfrm>
-            <a:off x="1033272" y="1874520"/>
-            <a:ext cx="1097280" cy="1097280"/>
-          </a:xfrm>
-          <a:prstGeom prst="rect">
-            <a:avLst/>
-          </a:prstGeom>
-          <a:noFill/>
-          <a:ln/>
-        </p:spPr>
-        <p:txBody>
-          <a:bodyPr wrap="square" lIns="0" tIns="0" rIns="0" bIns="0" rtlCol="0" anchor="ctr"/>
-          <a:lstStyle/>
-          <a:p>
-            <a:pPr algn="ctr" indent="0" marL="0">
-              <a:buNone/>
-            </a:pPr>
-            <a:r>
-              <a:rPr lang="en-US" sz="3600" b="1" dirty="0">
-                <a:solidFill>
-                  <a:schemeClr val="accent1"/>
-                </a:solidFill>
-              </a:rPr>
-              <a:t>黑</a:t>
-            </a:r>
-            <a:endParaRPr lang="en-US" sz="3600" dirty="0"/>
-          </a:p>
-        </p:txBody>
-      </p:sp>
-      <p:sp>
-        <p:nvSpPr>
-          <p:cNvPr id="7" name="Text 5"/>
-          <p:cNvSpPr txBox="1"/>
-          <p:nvPr/>
-        </p:nvSpPr>
-        <p:spPr>
-          <a:xfrm>
-            <a:off x="640080" y="3154680"/>
-            <a:ext cx="1883664" cy="457200"/>
-          </a:xfrm>
-          <a:prstGeom prst="rect">
-            <a:avLst/>
-          </a:prstGeom>
-          <a:noFill/>
-          <a:ln/>
-        </p:spPr>
-        <p:txBody>
-          <a:bodyPr wrap="square" lIns="0" tIns="0" rIns="0" bIns="0" rtlCol="0" anchor="t"/>
-          <a:lstStyle/>
-          <a:p>
-            <a:pPr algn="ctr" indent="0" marL="0">
-              <a:buNone/>
-            </a:pPr>
-            <a:r>
-              <a:rPr lang="en-US" sz="2000" b="1" dirty="0">
-                <a:solidFill>
-                  <a:schemeClr val="tx1"/>
-                </a:solidFill>
-              </a:rPr>
-              <a:t>五黑</a:t>
-            </a:r>
-            <a:endParaRPr lang="en-US" sz="2000" dirty="0"/>
-          </a:p>
-        </p:txBody>
-      </p:sp>
-      <p:sp>
-        <p:nvSpPr>
           <p:cNvPr id="8" name="Text 6"/>
           <p:cNvSpPr txBox="1"/>
           <p:nvPr/>
         </p:nvSpPr>
         <p:spPr>
           <a:xfrm>
-            <a:off x="640080" y="3611880"/>
-            <a:ext cx="1883664" cy="320040"/>
-          </a:xfrm>
-          <a:prstGeom prst="rect">
-            <a:avLst/>
-          </a:prstGeom>
-          <a:noFill/>
-          <a:ln/>
-        </p:spPr>
-        <p:txBody>
-          <a:bodyPr wrap="square" lIns="0" tIns="0" rIns="0" bIns="0" rtlCol="0" anchor="t"/>
+            <a:off x="1078992" y="1874520"/>
+            <a:ext cx="1005840" cy="1005840"/>
+          </a:xfrm>
+          <a:prstGeom prst="rect">
+            <a:avLst/>
+          </a:prstGeom>
+          <a:noFill/>
+          <a:ln/>
+        </p:spPr>
+        <p:txBody>
+          <a:bodyPr wrap="square" lIns="0" tIns="0" rIns="0" bIns="0" rtlCol="0" anchor="ctr"/>
           <a:lstStyle/>
           <a:p>
             <a:pPr algn="ctr" indent="0" marL="0">
               <a:buNone/>
             </a:pPr>
             <a:r>
-              <a:rPr lang="en-US" sz="1200" b="1" dirty="0">
-                <a:solidFill>
-                  <a:schemeClr val="accent1"/>
-                </a:solidFill>
-              </a:rPr>
-              <a:t>五黑食材配伍</a:t>
-            </a:r>
-            <a:endParaRPr lang="en-US" sz="1200" dirty="0"/>
+              <a:rPr lang="en-US" sz="3200" b="1" dirty="0">
+                <a:solidFill>
+                  <a:schemeClr val="bg1"/>
+                </a:solidFill>
+              </a:rPr>
+              <a:t>黑</a:t>
+            </a:r>
+            <a:endParaRPr lang="en-US" sz="3200" dirty="0"/>
           </a:p>
         </p:txBody>
       </p:sp>
@@ -11639,8 +11623,8 @@
         </p:nvSpPr>
         <p:spPr>
           <a:xfrm>
-            <a:off x="685800" y="4069080"/>
-            <a:ext cx="1792224" cy="640080"/>
+            <a:off x="640080" y="3063240"/>
+            <a:ext cx="1883664" cy="457200"/>
           </a:xfrm>
           <a:prstGeom prst="rect">
             <a:avLst/>
@@ -11656,12 +11640,84 @@
               <a:buNone/>
             </a:pPr>
             <a:r>
+              <a:rPr lang="en-US" sz="2000" b="1" dirty="0">
+                <a:solidFill>
+                  <a:schemeClr val="tx1"/>
+                </a:solidFill>
+              </a:rPr>
+              <a:t>五黑馒头</a:t>
+            </a:r>
+            <a:endParaRPr lang="en-US" sz="2000" dirty="0"/>
+          </a:p>
+        </p:txBody>
+      </p:sp>
+      <p:sp>
+        <p:nvSpPr>
+          <p:cNvPr id="10" name="Text 8"/>
+          <p:cNvSpPr txBox="1"/>
+          <p:nvPr/>
+        </p:nvSpPr>
+        <p:spPr>
+          <a:xfrm>
+            <a:off x="640080" y="3520440"/>
+            <a:ext cx="1883664" cy="320040"/>
+          </a:xfrm>
+          <a:prstGeom prst="rect">
+            <a:avLst/>
+          </a:prstGeom>
+          <a:noFill/>
+          <a:ln/>
+        </p:spPr>
+        <p:txBody>
+          <a:bodyPr wrap="square" lIns="0" tIns="0" rIns="0" bIns="0" rtlCol="0" anchor="t"/>
+          <a:lstStyle/>
+          <a:p>
+            <a:pPr algn="ctr" indent="0" marL="0">
+              <a:buNone/>
+            </a:pPr>
+            <a:r>
               <a:rPr lang="en-US" sz="1200" b="1" dirty="0">
                 <a:solidFill>
+                  <a:schemeClr val="accent1"/>
+                </a:solidFill>
+              </a:rPr>
+              <a:t>黑色</a:t>
+            </a:r>
+            <a:endParaRPr lang="en-US" sz="1200" dirty="0"/>
+          </a:p>
+        </p:txBody>
+      </p:sp>
+      <p:sp>
+        <p:nvSpPr>
+          <p:cNvPr id="11" name="Text 9"/>
+          <p:cNvSpPr txBox="1"/>
+          <p:nvPr/>
+        </p:nvSpPr>
+        <p:spPr>
+          <a:xfrm>
+            <a:off x="685800" y="3977640"/>
+            <a:ext cx="1792224" cy="731520"/>
+          </a:xfrm>
+          <a:prstGeom prst="rect">
+            <a:avLst/>
+          </a:prstGeom>
+          <a:noFill/>
+          <a:ln/>
+        </p:spPr>
+        <p:txBody>
+          <a:bodyPr wrap="square" lIns="0" tIns="0" rIns="0" bIns="0" rtlCol="0" anchor="t"/>
+          <a:lstStyle/>
+          <a:p>
+            <a:pPr algn="ctr" indent="0" marL="0">
+              <a:buNone/>
+            </a:pPr>
+            <a:r>
+              <a:rPr lang="en-US" sz="1200" dirty="0">
+                <a:solidFill>
                   <a:schemeClr val="tx2"/>
                 </a:solidFill>
               </a:rPr>
-              <a:t>功能定位</a:t>
+              <a:t>五黑食材配伍</a:t>
             </a:r>
             <a:endParaRPr lang="en-US" sz="1200" dirty="0"/>
           </a:p>
@@ -11672,10 +11728,10 @@
             <a:r>
               <a:rPr lang="en-US" sz="1200" dirty="0">
                 <a:solidFill>
-                  <a:schemeClr val="accent5"/>
-                </a:solidFill>
-              </a:rPr>
-              <a:t>［待陈博士确认］</a:t>
+                  <a:schemeClr val="tx2"/>
+                </a:solidFill>
+              </a:rPr>
+              <a:t>传统“五黑”食养理念</a:t>
             </a:r>
             <a:endParaRPr lang="en-US" sz="1200" dirty="0"/>
           </a:p>
@@ -11683,7 +11739,7 @@
       </p:sp>
       <p:sp>
         <p:nvSpPr>
-          <p:cNvPr id="10" name="Shape 8"/>
+          <p:cNvPr id="12" name="Shape 10"/>
           <p:cNvSpPr/>
           <p:nvPr/>
         </p:nvSpPr>
@@ -11706,7 +11762,7 @@
       </p:sp>
       <p:sp>
         <p:nvSpPr>
-          <p:cNvPr id="11" name="Text 9"/>
+          <p:cNvPr id="13" name="Text 11"/>
           <p:cNvSpPr txBox="1"/>
           <p:nvPr/>
         </p:nvSpPr>
@@ -11742,7 +11798,7 @@
       </p:sp>
       <p:sp>
         <p:nvSpPr>
-          <p:cNvPr id="12" name="product-五红"/>
+          <p:cNvPr id="14" name="product-五红馒头"/>
           <p:cNvSpPr/>
           <p:nvPr/>
         </p:nvSpPr>
@@ -11771,20 +11827,76 @@
       </p:sp>
       <p:sp>
         <p:nvSpPr>
-          <p:cNvPr id="13" name="Shape 11"/>
+          <p:cNvPr id="15" name="Shape 13"/>
           <p:cNvSpPr/>
           <p:nvPr/>
         </p:nvSpPr>
         <p:spPr>
           <a:xfrm>
-            <a:off x="3282696" y="1874520"/>
-            <a:ext cx="1097280" cy="1097280"/>
+            <a:off x="3026664" y="1783080"/>
+            <a:ext cx="384048" cy="384048"/>
           </a:xfrm>
           <a:prstGeom prst="ellipse">
             <a:avLst/>
           </a:prstGeom>
           <a:solidFill>
             <a:schemeClr val="accent4"/>
+          </a:solidFill>
+          <a:ln/>
+        </p:spPr>
+      </p:sp>
+      <p:sp>
+        <p:nvSpPr>
+          <p:cNvPr id="16" name="Text 14"/>
+          <p:cNvSpPr txBox="1"/>
+          <p:nvPr/>
+        </p:nvSpPr>
+        <p:spPr>
+          <a:xfrm>
+            <a:off x="3026664" y="1783080"/>
+            <a:ext cx="384048" cy="384048"/>
+          </a:xfrm>
+          <a:prstGeom prst="rect">
+            <a:avLst/>
+          </a:prstGeom>
+          <a:noFill/>
+          <a:ln/>
+        </p:spPr>
+        <p:txBody>
+          <a:bodyPr wrap="square" lIns="0" tIns="0" rIns="0" bIns="0" rtlCol="0" anchor="ctr"/>
+          <a:lstStyle/>
+          <a:p>
+            <a:pPr algn="ctr" indent="0" marL="0">
+              <a:buNone/>
+            </a:pPr>
+            <a:r>
+              <a:rPr lang="en-US" sz="1100" b="1" dirty="0">
+                <a:solidFill>
+                  <a:schemeClr val="tx1"/>
+                </a:solidFill>
+              </a:rPr>
+              <a:t>02</a:t>
+            </a:r>
+            <a:endParaRPr lang="en-US" sz="1100" dirty="0"/>
+          </a:p>
+        </p:txBody>
+      </p:sp>
+      <p:sp>
+        <p:nvSpPr>
+          <p:cNvPr id="17" name="Shape 15"/>
+          <p:cNvSpPr/>
+          <p:nvPr/>
+        </p:nvSpPr>
+        <p:spPr>
+          <a:xfrm>
+            <a:off x="3328416" y="1874520"/>
+            <a:ext cx="1005840" cy="1005840"/>
+          </a:xfrm>
+          <a:prstGeom prst="ellipse">
+            <a:avLst/>
+          </a:prstGeom>
+          <a:solidFill>
+            <a:srgbClr val="A0453A"/>
           </a:solidFill>
           <a:ln w="19050">
             <a:solidFill>
@@ -11796,14 +11908,14 @@
       </p:sp>
       <p:sp>
         <p:nvSpPr>
-          <p:cNvPr id="14" name="Text 12"/>
+          <p:cNvPr id="18" name="Text 16"/>
           <p:cNvSpPr txBox="1"/>
           <p:nvPr/>
         </p:nvSpPr>
         <p:spPr>
           <a:xfrm>
-            <a:off x="3282696" y="1874520"/>
-            <a:ext cx="1097280" cy="1097280"/>
+            <a:off x="3328416" y="1874520"/>
+            <a:ext cx="1005840" cy="1005840"/>
           </a:xfrm>
           <a:prstGeom prst="rect">
             <a:avLst/>
@@ -11819,27 +11931,99 @@
               <a:buNone/>
             </a:pPr>
             <a:r>
-              <a:rPr lang="en-US" sz="3600" b="1" dirty="0">
+              <a:rPr lang="en-US" sz="3200" b="1" dirty="0">
+                <a:solidFill>
+                  <a:schemeClr val="bg1"/>
+                </a:solidFill>
+              </a:rPr>
+              <a:t>红</a:t>
+            </a:r>
+            <a:endParaRPr lang="en-US" sz="3200" dirty="0"/>
+          </a:p>
+        </p:txBody>
+      </p:sp>
+      <p:sp>
+        <p:nvSpPr>
+          <p:cNvPr id="19" name="Text 17"/>
+          <p:cNvSpPr txBox="1"/>
+          <p:nvPr/>
+        </p:nvSpPr>
+        <p:spPr>
+          <a:xfrm>
+            <a:off x="2889504" y="3063240"/>
+            <a:ext cx="1883664" cy="457200"/>
+          </a:xfrm>
+          <a:prstGeom prst="rect">
+            <a:avLst/>
+          </a:prstGeom>
+          <a:noFill/>
+          <a:ln/>
+        </p:spPr>
+        <p:txBody>
+          <a:bodyPr wrap="square" lIns="0" tIns="0" rIns="0" bIns="0" rtlCol="0" anchor="t"/>
+          <a:lstStyle/>
+          <a:p>
+            <a:pPr algn="ctr" indent="0" marL="0">
+              <a:buNone/>
+            </a:pPr>
+            <a:r>
+              <a:rPr lang="en-US" sz="2000" b="1" dirty="0">
+                <a:solidFill>
+                  <a:schemeClr val="tx1"/>
+                </a:solidFill>
+              </a:rPr>
+              <a:t>五红馒头</a:t>
+            </a:r>
+            <a:endParaRPr lang="en-US" sz="2000" dirty="0"/>
+          </a:p>
+        </p:txBody>
+      </p:sp>
+      <p:sp>
+        <p:nvSpPr>
+          <p:cNvPr id="20" name="Text 18"/>
+          <p:cNvSpPr txBox="1"/>
+          <p:nvPr/>
+        </p:nvSpPr>
+        <p:spPr>
+          <a:xfrm>
+            <a:off x="2889504" y="3520440"/>
+            <a:ext cx="1883664" cy="320040"/>
+          </a:xfrm>
+          <a:prstGeom prst="rect">
+            <a:avLst/>
+          </a:prstGeom>
+          <a:noFill/>
+          <a:ln/>
+        </p:spPr>
+        <p:txBody>
+          <a:bodyPr wrap="square" lIns="0" tIns="0" rIns="0" bIns="0" rtlCol="0" anchor="t"/>
+          <a:lstStyle/>
+          <a:p>
+            <a:pPr algn="ctr" indent="0" marL="0">
+              <a:buNone/>
+            </a:pPr>
+            <a:r>
+              <a:rPr lang="en-US" sz="1200" b="1" dirty="0">
                 <a:solidFill>
                   <a:schemeClr val="accent1"/>
                 </a:solidFill>
               </a:rPr>
-              <a:t>红</a:t>
-            </a:r>
-            <a:endParaRPr lang="en-US" sz="3600" dirty="0"/>
-          </a:p>
-        </p:txBody>
-      </p:sp>
-      <p:sp>
-        <p:nvSpPr>
-          <p:cNvPr id="15" name="Text 13"/>
+              <a:t>红色</a:t>
+            </a:r>
+            <a:endParaRPr lang="en-US" sz="1200" dirty="0"/>
+          </a:p>
+        </p:txBody>
+      </p:sp>
+      <p:sp>
+        <p:nvSpPr>
+          <p:cNvPr id="21" name="Text 19"/>
           <p:cNvSpPr txBox="1"/>
           <p:nvPr/>
         </p:nvSpPr>
         <p:spPr>
           <a:xfrm>
-            <a:off x="2889504" y="3154680"/>
-            <a:ext cx="1883664" cy="457200"/>
+            <a:off x="2935224" y="3977640"/>
+            <a:ext cx="1792224" cy="731520"/>
           </a:xfrm>
           <a:prstGeom prst="rect">
             <a:avLst/>
@@ -11855,48 +12039,26 @@
               <a:buNone/>
             </a:pPr>
             <a:r>
-              <a:rPr lang="en-US" sz="2000" b="1" dirty="0">
-                <a:solidFill>
-                  <a:schemeClr val="tx1"/>
-                </a:solidFill>
-              </a:rPr>
-              <a:t>五红</a:t>
-            </a:r>
-            <a:endParaRPr lang="en-US" sz="2000" dirty="0"/>
-          </a:p>
-        </p:txBody>
-      </p:sp>
-      <p:sp>
-        <p:nvSpPr>
-          <p:cNvPr id="16" name="Text 14"/>
-          <p:cNvSpPr txBox="1"/>
-          <p:nvPr/>
-        </p:nvSpPr>
-        <p:spPr>
-          <a:xfrm>
-            <a:off x="2889504" y="3611880"/>
-            <a:ext cx="1883664" cy="320040"/>
-          </a:xfrm>
-          <a:prstGeom prst="rect">
-            <a:avLst/>
-          </a:prstGeom>
-          <a:noFill/>
-          <a:ln/>
-        </p:spPr>
-        <p:txBody>
-          <a:bodyPr wrap="square" lIns="0" tIns="0" rIns="0" bIns="0" rtlCol="0" anchor="t"/>
-          <a:lstStyle/>
+              <a:rPr lang="en-US" sz="1200" dirty="0">
+                <a:solidFill>
+                  <a:schemeClr val="tx2"/>
+                </a:solidFill>
+              </a:rPr>
+              <a:t>五红食材配伍</a:t>
+            </a:r>
+            <a:endParaRPr lang="en-US" sz="1200" dirty="0"/>
+          </a:p>
           <a:p>
             <a:pPr algn="ctr" indent="0" marL="0">
               <a:buNone/>
             </a:pPr>
             <a:r>
-              <a:rPr lang="en-US" sz="1200" b="1" dirty="0">
-                <a:solidFill>
-                  <a:schemeClr val="accent1"/>
-                </a:solidFill>
-              </a:rPr>
-              <a:t>五红食材配伍</a:t>
+              <a:rPr lang="en-US" sz="1200" dirty="0">
+                <a:solidFill>
+                  <a:schemeClr val="tx2"/>
+                </a:solidFill>
+              </a:rPr>
+              <a:t>传统“五红”食养理念</a:t>
             </a:r>
             <a:endParaRPr lang="en-US" sz="1200" dirty="0"/>
           </a:p>
@@ -11904,57 +12066,7 @@
       </p:sp>
       <p:sp>
         <p:nvSpPr>
-          <p:cNvPr id="17" name="Text 15"/>
-          <p:cNvSpPr txBox="1"/>
-          <p:nvPr/>
-        </p:nvSpPr>
-        <p:spPr>
-          <a:xfrm>
-            <a:off x="2935224" y="4069080"/>
-            <a:ext cx="1792224" cy="640080"/>
-          </a:xfrm>
-          <a:prstGeom prst="rect">
-            <a:avLst/>
-          </a:prstGeom>
-          <a:noFill/>
-          <a:ln/>
-        </p:spPr>
-        <p:txBody>
-          <a:bodyPr wrap="square" lIns="0" tIns="0" rIns="0" bIns="0" rtlCol="0" anchor="t"/>
-          <a:lstStyle/>
-          <a:p>
-            <a:pPr algn="ctr" indent="0" marL="0">
-              <a:buNone/>
-            </a:pPr>
-            <a:r>
-              <a:rPr lang="en-US" sz="1200" b="1" dirty="0">
-                <a:solidFill>
-                  <a:schemeClr val="tx2"/>
-                </a:solidFill>
-              </a:rPr>
-              <a:t>功能定位</a:t>
-            </a:r>
-            <a:endParaRPr lang="en-US" sz="1200" dirty="0"/>
-          </a:p>
-          <a:p>
-            <a:pPr algn="ctr" indent="0" marL="0">
-              <a:buNone/>
-            </a:pPr>
-            <a:r>
-              <a:rPr lang="en-US" sz="1200" dirty="0">
-                <a:solidFill>
-                  <a:schemeClr val="accent5"/>
-                </a:solidFill>
-              </a:rPr>
-              <a:t>［待陈博士确认］</a:t>
-            </a:r>
-            <a:endParaRPr lang="en-US" sz="1200" dirty="0"/>
-          </a:p>
-        </p:txBody>
-      </p:sp>
-      <p:sp>
-        <p:nvSpPr>
-          <p:cNvPr id="18" name="Shape 16"/>
+          <p:cNvPr id="22" name="Shape 20"/>
           <p:cNvSpPr/>
           <p:nvPr/>
         </p:nvSpPr>
@@ -11977,7 +12089,7 @@
       </p:sp>
       <p:sp>
         <p:nvSpPr>
-          <p:cNvPr id="19" name="Text 17"/>
+          <p:cNvPr id="23" name="Text 21"/>
           <p:cNvSpPr txBox="1"/>
           <p:nvPr/>
         </p:nvSpPr>
@@ -12013,7 +12125,7 @@
       </p:sp>
       <p:sp>
         <p:nvSpPr>
-          <p:cNvPr id="20" name="product-茯苓山药"/>
+          <p:cNvPr id="24" name="product-茯苓馒头"/>
           <p:cNvSpPr/>
           <p:nvPr/>
         </p:nvSpPr>
@@ -12042,20 +12154,76 @@
       </p:sp>
       <p:sp>
         <p:nvSpPr>
-          <p:cNvPr id="21" name="Shape 19"/>
+          <p:cNvPr id="25" name="Shape 23"/>
           <p:cNvSpPr/>
           <p:nvPr/>
         </p:nvSpPr>
         <p:spPr>
           <a:xfrm>
-            <a:off x="5532120" y="1874520"/>
-            <a:ext cx="1097280" cy="1097280"/>
+            <a:off x="5276088" y="1783080"/>
+            <a:ext cx="384048" cy="384048"/>
           </a:xfrm>
           <a:prstGeom prst="ellipse">
             <a:avLst/>
           </a:prstGeom>
           <a:solidFill>
             <a:schemeClr val="accent4"/>
+          </a:solidFill>
+          <a:ln/>
+        </p:spPr>
+      </p:sp>
+      <p:sp>
+        <p:nvSpPr>
+          <p:cNvPr id="26" name="Text 24"/>
+          <p:cNvSpPr txBox="1"/>
+          <p:nvPr/>
+        </p:nvSpPr>
+        <p:spPr>
+          <a:xfrm>
+            <a:off x="5276088" y="1783080"/>
+            <a:ext cx="384048" cy="384048"/>
+          </a:xfrm>
+          <a:prstGeom prst="rect">
+            <a:avLst/>
+          </a:prstGeom>
+          <a:noFill/>
+          <a:ln/>
+        </p:spPr>
+        <p:txBody>
+          <a:bodyPr wrap="square" lIns="0" tIns="0" rIns="0" bIns="0" rtlCol="0" anchor="ctr"/>
+          <a:lstStyle/>
+          <a:p>
+            <a:pPr algn="ctr" indent="0" marL="0">
+              <a:buNone/>
+            </a:pPr>
+            <a:r>
+              <a:rPr lang="en-US" sz="1100" b="1" dirty="0">
+                <a:solidFill>
+                  <a:schemeClr val="tx1"/>
+                </a:solidFill>
+              </a:rPr>
+              <a:t>03</a:t>
+            </a:r>
+            <a:endParaRPr lang="en-US" sz="1100" dirty="0"/>
+          </a:p>
+        </p:txBody>
+      </p:sp>
+      <p:sp>
+        <p:nvSpPr>
+          <p:cNvPr id="27" name="Shape 25"/>
+          <p:cNvSpPr/>
+          <p:nvPr/>
+        </p:nvSpPr>
+        <p:spPr>
+          <a:xfrm>
+            <a:off x="5577840" y="1874520"/>
+            <a:ext cx="1005840" cy="1005840"/>
+          </a:xfrm>
+          <a:prstGeom prst="ellipse">
+            <a:avLst/>
+          </a:prstGeom>
+          <a:solidFill>
+            <a:srgbClr val="E6DCC6"/>
           </a:solidFill>
           <a:ln w="19050">
             <a:solidFill>
@@ -12067,14 +12235,14 @@
       </p:sp>
       <p:sp>
         <p:nvSpPr>
-          <p:cNvPr id="22" name="Text 20"/>
+          <p:cNvPr id="28" name="Text 26"/>
           <p:cNvSpPr txBox="1"/>
           <p:nvPr/>
         </p:nvSpPr>
         <p:spPr>
           <a:xfrm>
-            <a:off x="5532120" y="1874520"/>
-            <a:ext cx="1097280" cy="1097280"/>
+            <a:off x="5577840" y="1874520"/>
+            <a:ext cx="1005840" cy="1005840"/>
           </a:xfrm>
           <a:prstGeom prst="rect">
             <a:avLst/>
@@ -12090,27 +12258,99 @@
               <a:buNone/>
             </a:pPr>
             <a:r>
-              <a:rPr lang="en-US" sz="3600" b="1" dirty="0">
+              <a:rPr lang="en-US" sz="3200" b="1" dirty="0">
+                <a:solidFill>
+                  <a:schemeClr val="tx1"/>
+                </a:solidFill>
+              </a:rPr>
+              <a:t>苓</a:t>
+            </a:r>
+            <a:endParaRPr lang="en-US" sz="3200" dirty="0"/>
+          </a:p>
+        </p:txBody>
+      </p:sp>
+      <p:sp>
+        <p:nvSpPr>
+          <p:cNvPr id="29" name="Text 27"/>
+          <p:cNvSpPr txBox="1"/>
+          <p:nvPr/>
+        </p:nvSpPr>
+        <p:spPr>
+          <a:xfrm>
+            <a:off x="5138928" y="3063240"/>
+            <a:ext cx="1883664" cy="457200"/>
+          </a:xfrm>
+          <a:prstGeom prst="rect">
+            <a:avLst/>
+          </a:prstGeom>
+          <a:noFill/>
+          <a:ln/>
+        </p:spPr>
+        <p:txBody>
+          <a:bodyPr wrap="square" lIns="0" tIns="0" rIns="0" bIns="0" rtlCol="0" anchor="t"/>
+          <a:lstStyle/>
+          <a:p>
+            <a:pPr algn="ctr" indent="0" marL="0">
+              <a:buNone/>
+            </a:pPr>
+            <a:r>
+              <a:rPr lang="en-US" sz="2000" b="1" dirty="0">
+                <a:solidFill>
+                  <a:schemeClr val="tx1"/>
+                </a:solidFill>
+              </a:rPr>
+              <a:t>茯苓馒头</a:t>
+            </a:r>
+            <a:endParaRPr lang="en-US" sz="2000" dirty="0"/>
+          </a:p>
+        </p:txBody>
+      </p:sp>
+      <p:sp>
+        <p:nvSpPr>
+          <p:cNvPr id="30" name="Text 28"/>
+          <p:cNvSpPr txBox="1"/>
+          <p:nvPr/>
+        </p:nvSpPr>
+        <p:spPr>
+          <a:xfrm>
+            <a:off x="5138928" y="3520440"/>
+            <a:ext cx="1883664" cy="320040"/>
+          </a:xfrm>
+          <a:prstGeom prst="rect">
+            <a:avLst/>
+          </a:prstGeom>
+          <a:noFill/>
+          <a:ln/>
+        </p:spPr>
+        <p:txBody>
+          <a:bodyPr wrap="square" lIns="0" tIns="0" rIns="0" bIns="0" rtlCol="0" anchor="t"/>
+          <a:lstStyle/>
+          <a:p>
+            <a:pPr algn="ctr" indent="0" marL="0">
+              <a:buNone/>
+            </a:pPr>
+            <a:r>
+              <a:rPr lang="en-US" sz="1200" b="1" dirty="0">
                 <a:solidFill>
                   <a:schemeClr val="accent1"/>
                 </a:solidFill>
               </a:rPr>
-              <a:t>苓</a:t>
-            </a:r>
-            <a:endParaRPr lang="en-US" sz="3600" dirty="0"/>
-          </a:p>
-        </p:txBody>
-      </p:sp>
-      <p:sp>
-        <p:nvSpPr>
-          <p:cNvPr id="23" name="Text 21"/>
+              <a:t>色系待确认</a:t>
+            </a:r>
+            <a:endParaRPr lang="en-US" sz="1200" dirty="0"/>
+          </a:p>
+        </p:txBody>
+      </p:sp>
+      <p:sp>
+        <p:nvSpPr>
+          <p:cNvPr id="31" name="Text 29"/>
           <p:cNvSpPr txBox="1"/>
           <p:nvPr/>
         </p:nvSpPr>
         <p:spPr>
           <a:xfrm>
-            <a:off x="5138928" y="3154680"/>
-            <a:ext cx="1883664" cy="457200"/>
+            <a:off x="5184648" y="3977640"/>
+            <a:ext cx="1792224" cy="731520"/>
           </a:xfrm>
           <a:prstGeom prst="rect">
             <a:avLst/>
@@ -12126,48 +12366,26 @@
               <a:buNone/>
             </a:pPr>
             <a:r>
-              <a:rPr lang="en-US" sz="2000" b="1" dirty="0">
-                <a:solidFill>
-                  <a:schemeClr val="tx1"/>
-                </a:solidFill>
-              </a:rPr>
-              <a:t>茯苓山药</a:t>
-            </a:r>
-            <a:endParaRPr lang="en-US" sz="2000" dirty="0"/>
-          </a:p>
-        </p:txBody>
-      </p:sp>
-      <p:sp>
-        <p:nvSpPr>
-          <p:cNvPr id="24" name="Text 22"/>
-          <p:cNvSpPr txBox="1"/>
-          <p:nvPr/>
-        </p:nvSpPr>
-        <p:spPr>
-          <a:xfrm>
-            <a:off x="5138928" y="3611880"/>
-            <a:ext cx="1883664" cy="320040"/>
-          </a:xfrm>
-          <a:prstGeom prst="rect">
-            <a:avLst/>
-          </a:prstGeom>
-          <a:noFill/>
-          <a:ln/>
-        </p:spPr>
-        <p:txBody>
-          <a:bodyPr wrap="square" lIns="0" tIns="0" rIns="0" bIns="0" rtlCol="0" anchor="t"/>
-          <a:lstStyle/>
+              <a:rPr lang="en-US" sz="1200" dirty="0">
+                <a:solidFill>
+                  <a:schemeClr val="tx2"/>
+                </a:solidFill>
+              </a:rPr>
+              <a:t>药食同源原料茯苓</a:t>
+            </a:r>
+            <a:endParaRPr lang="en-US" sz="1200" dirty="0"/>
+          </a:p>
           <a:p>
             <a:pPr algn="ctr" indent="0" marL="0">
               <a:buNone/>
             </a:pPr>
             <a:r>
-              <a:rPr lang="en-US" sz="1200" b="1" dirty="0">
-                <a:solidFill>
-                  <a:schemeClr val="accent1"/>
-                </a:solidFill>
-              </a:rPr>
-              <a:t>茯苓、山药配伍</a:t>
+              <a:rPr lang="en-US" sz="1200" dirty="0">
+                <a:solidFill>
+                  <a:schemeClr val="tx2"/>
+                </a:solidFill>
+              </a:rPr>
+              <a:t>入面制作</a:t>
             </a:r>
             <a:endParaRPr lang="en-US" sz="1200" dirty="0"/>
           </a:p>
@@ -12175,57 +12393,7 @@
       </p:sp>
       <p:sp>
         <p:nvSpPr>
-          <p:cNvPr id="25" name="Text 23"/>
-          <p:cNvSpPr txBox="1"/>
-          <p:nvPr/>
-        </p:nvSpPr>
-        <p:spPr>
-          <a:xfrm>
-            <a:off x="5184648" y="4069080"/>
-            <a:ext cx="1792224" cy="640080"/>
-          </a:xfrm>
-          <a:prstGeom prst="rect">
-            <a:avLst/>
-          </a:prstGeom>
-          <a:noFill/>
-          <a:ln/>
-        </p:spPr>
-        <p:txBody>
-          <a:bodyPr wrap="square" lIns="0" tIns="0" rIns="0" bIns="0" rtlCol="0" anchor="t"/>
-          <a:lstStyle/>
-          <a:p>
-            <a:pPr algn="ctr" indent="0" marL="0">
-              <a:buNone/>
-            </a:pPr>
-            <a:r>
-              <a:rPr lang="en-US" sz="1200" b="1" dirty="0">
-                <a:solidFill>
-                  <a:schemeClr val="tx2"/>
-                </a:solidFill>
-              </a:rPr>
-              <a:t>功能定位</a:t>
-            </a:r>
-            <a:endParaRPr lang="en-US" sz="1200" dirty="0"/>
-          </a:p>
-          <a:p>
-            <a:pPr algn="ctr" indent="0" marL="0">
-              <a:buNone/>
-            </a:pPr>
-            <a:r>
-              <a:rPr lang="en-US" sz="1200" dirty="0">
-                <a:solidFill>
-                  <a:schemeClr val="accent5"/>
-                </a:solidFill>
-              </a:rPr>
-              <a:t>［待陈博士确认］</a:t>
-            </a:r>
-            <a:endParaRPr lang="en-US" sz="1200" dirty="0"/>
-          </a:p>
-        </p:txBody>
-      </p:sp>
-      <p:sp>
-        <p:nvSpPr>
-          <p:cNvPr id="26" name="Shape 24"/>
+          <p:cNvPr id="32" name="Shape 30"/>
           <p:cNvSpPr/>
           <p:nvPr/>
         </p:nvSpPr>
@@ -12248,7 +12416,7 @@
       </p:sp>
       <p:sp>
         <p:nvSpPr>
-          <p:cNvPr id="27" name="Text 25"/>
+          <p:cNvPr id="33" name="Text 31"/>
           <p:cNvSpPr txBox="1"/>
           <p:nvPr/>
         </p:nvSpPr>
@@ -12284,7 +12452,7 @@
       </p:sp>
       <p:sp>
         <p:nvSpPr>
-          <p:cNvPr id="28" name="product-姜黄"/>
+          <p:cNvPr id="34" name="product-姜黄馒头"/>
           <p:cNvSpPr/>
           <p:nvPr/>
         </p:nvSpPr>
@@ -12313,20 +12481,76 @@
       </p:sp>
       <p:sp>
         <p:nvSpPr>
-          <p:cNvPr id="29" name="Shape 27"/>
+          <p:cNvPr id="35" name="Shape 33"/>
           <p:cNvSpPr/>
           <p:nvPr/>
         </p:nvSpPr>
         <p:spPr>
           <a:xfrm>
-            <a:off x="7781544" y="1874520"/>
-            <a:ext cx="1097280" cy="1097280"/>
+            <a:off x="7525512" y="1783080"/>
+            <a:ext cx="384048" cy="384048"/>
           </a:xfrm>
           <a:prstGeom prst="ellipse">
             <a:avLst/>
           </a:prstGeom>
           <a:solidFill>
             <a:schemeClr val="accent4"/>
+          </a:solidFill>
+          <a:ln/>
+        </p:spPr>
+      </p:sp>
+      <p:sp>
+        <p:nvSpPr>
+          <p:cNvPr id="36" name="Text 34"/>
+          <p:cNvSpPr txBox="1"/>
+          <p:nvPr/>
+        </p:nvSpPr>
+        <p:spPr>
+          <a:xfrm>
+            <a:off x="7525512" y="1783080"/>
+            <a:ext cx="384048" cy="384048"/>
+          </a:xfrm>
+          <a:prstGeom prst="rect">
+            <a:avLst/>
+          </a:prstGeom>
+          <a:noFill/>
+          <a:ln/>
+        </p:spPr>
+        <p:txBody>
+          <a:bodyPr wrap="square" lIns="0" tIns="0" rIns="0" bIns="0" rtlCol="0" anchor="ctr"/>
+          <a:lstStyle/>
+          <a:p>
+            <a:pPr algn="ctr" indent="0" marL="0">
+              <a:buNone/>
+            </a:pPr>
+            <a:r>
+              <a:rPr lang="en-US" sz="1100" b="1" dirty="0">
+                <a:solidFill>
+                  <a:schemeClr val="tx1"/>
+                </a:solidFill>
+              </a:rPr>
+              <a:t>04</a:t>
+            </a:r>
+            <a:endParaRPr lang="en-US" sz="1100" dirty="0"/>
+          </a:p>
+        </p:txBody>
+      </p:sp>
+      <p:sp>
+        <p:nvSpPr>
+          <p:cNvPr id="37" name="Shape 35"/>
+          <p:cNvSpPr/>
+          <p:nvPr/>
+        </p:nvSpPr>
+        <p:spPr>
+          <a:xfrm>
+            <a:off x="7827264" y="1874520"/>
+            <a:ext cx="1005840" cy="1005840"/>
+          </a:xfrm>
+          <a:prstGeom prst="ellipse">
+            <a:avLst/>
+          </a:prstGeom>
+          <a:solidFill>
+            <a:srgbClr val="D39B2E"/>
           </a:solidFill>
           <a:ln w="19050">
             <a:solidFill>
@@ -12338,14 +12562,14 @@
       </p:sp>
       <p:sp>
         <p:nvSpPr>
-          <p:cNvPr id="30" name="Text 28"/>
+          <p:cNvPr id="38" name="Text 36"/>
           <p:cNvSpPr txBox="1"/>
           <p:nvPr/>
         </p:nvSpPr>
         <p:spPr>
           <a:xfrm>
-            <a:off x="7781544" y="1874520"/>
-            <a:ext cx="1097280" cy="1097280"/>
+            <a:off x="7827264" y="1874520"/>
+            <a:ext cx="1005840" cy="1005840"/>
           </a:xfrm>
           <a:prstGeom prst="rect">
             <a:avLst/>
@@ -12361,27 +12585,99 @@
               <a:buNone/>
             </a:pPr>
             <a:r>
-              <a:rPr lang="en-US" sz="3600" b="1" dirty="0">
+              <a:rPr lang="en-US" sz="3200" b="1" dirty="0">
+                <a:solidFill>
+                  <a:schemeClr val="bg1"/>
+                </a:solidFill>
+              </a:rPr>
+              <a:t>姜</a:t>
+            </a:r>
+            <a:endParaRPr lang="en-US" sz="3200" dirty="0"/>
+          </a:p>
+        </p:txBody>
+      </p:sp>
+      <p:sp>
+        <p:nvSpPr>
+          <p:cNvPr id="39" name="Text 37"/>
+          <p:cNvSpPr txBox="1"/>
+          <p:nvPr/>
+        </p:nvSpPr>
+        <p:spPr>
+          <a:xfrm>
+            <a:off x="7388352" y="3063240"/>
+            <a:ext cx="1883664" cy="457200"/>
+          </a:xfrm>
+          <a:prstGeom prst="rect">
+            <a:avLst/>
+          </a:prstGeom>
+          <a:noFill/>
+          <a:ln/>
+        </p:spPr>
+        <p:txBody>
+          <a:bodyPr wrap="square" lIns="0" tIns="0" rIns="0" bIns="0" rtlCol="0" anchor="t"/>
+          <a:lstStyle/>
+          <a:p>
+            <a:pPr algn="ctr" indent="0" marL="0">
+              <a:buNone/>
+            </a:pPr>
+            <a:r>
+              <a:rPr lang="en-US" sz="2000" b="1" dirty="0">
+                <a:solidFill>
+                  <a:schemeClr val="tx1"/>
+                </a:solidFill>
+              </a:rPr>
+              <a:t>姜黄馒头</a:t>
+            </a:r>
+            <a:endParaRPr lang="en-US" sz="2000" dirty="0"/>
+          </a:p>
+        </p:txBody>
+      </p:sp>
+      <p:sp>
+        <p:nvSpPr>
+          <p:cNvPr id="40" name="Text 38"/>
+          <p:cNvSpPr txBox="1"/>
+          <p:nvPr/>
+        </p:nvSpPr>
+        <p:spPr>
+          <a:xfrm>
+            <a:off x="7388352" y="3520440"/>
+            <a:ext cx="1883664" cy="320040"/>
+          </a:xfrm>
+          <a:prstGeom prst="rect">
+            <a:avLst/>
+          </a:prstGeom>
+          <a:noFill/>
+          <a:ln/>
+        </p:spPr>
+        <p:txBody>
+          <a:bodyPr wrap="square" lIns="0" tIns="0" rIns="0" bIns="0" rtlCol="0" anchor="t"/>
+          <a:lstStyle/>
+          <a:p>
+            <a:pPr algn="ctr" indent="0" marL="0">
+              <a:buNone/>
+            </a:pPr>
+            <a:r>
+              <a:rPr lang="en-US" sz="1200" b="1" dirty="0">
                 <a:solidFill>
                   <a:schemeClr val="accent1"/>
                 </a:solidFill>
               </a:rPr>
-              <a:t>姜</a:t>
-            </a:r>
-            <a:endParaRPr lang="en-US" sz="3600" dirty="0"/>
-          </a:p>
-        </p:txBody>
-      </p:sp>
-      <p:sp>
-        <p:nvSpPr>
-          <p:cNvPr id="31" name="Text 29"/>
+              <a:t>黄色</a:t>
+            </a:r>
+            <a:endParaRPr lang="en-US" sz="1200" dirty="0"/>
+          </a:p>
+        </p:txBody>
+      </p:sp>
+      <p:sp>
+        <p:nvSpPr>
+          <p:cNvPr id="41" name="Text 39"/>
           <p:cNvSpPr txBox="1"/>
           <p:nvPr/>
         </p:nvSpPr>
         <p:spPr>
           <a:xfrm>
-            <a:off x="7388352" y="3154680"/>
-            <a:ext cx="1883664" cy="457200"/>
+            <a:off x="7434072" y="3977640"/>
+            <a:ext cx="1792224" cy="731520"/>
           </a:xfrm>
           <a:prstGeom prst="rect">
             <a:avLst/>
@@ -12397,48 +12693,26 @@
               <a:buNone/>
             </a:pPr>
             <a:r>
-              <a:rPr lang="en-US" sz="2000" b="1" dirty="0">
-                <a:solidFill>
-                  <a:schemeClr val="tx1"/>
-                </a:solidFill>
-              </a:rPr>
-              <a:t>姜黄</a:t>
-            </a:r>
-            <a:endParaRPr lang="en-US" sz="2000" dirty="0"/>
-          </a:p>
-        </p:txBody>
-      </p:sp>
-      <p:sp>
-        <p:nvSpPr>
-          <p:cNvPr id="32" name="Text 30"/>
-          <p:cNvSpPr txBox="1"/>
-          <p:nvPr/>
-        </p:nvSpPr>
-        <p:spPr>
-          <a:xfrm>
-            <a:off x="7388352" y="3611880"/>
-            <a:ext cx="1883664" cy="320040"/>
-          </a:xfrm>
-          <a:prstGeom prst="rect">
-            <a:avLst/>
-          </a:prstGeom>
-          <a:noFill/>
-          <a:ln/>
-        </p:spPr>
-        <p:txBody>
-          <a:bodyPr wrap="square" lIns="0" tIns="0" rIns="0" bIns="0" rtlCol="0" anchor="t"/>
-          <a:lstStyle/>
+              <a:rPr lang="en-US" sz="1200" dirty="0">
+                <a:solidFill>
+                  <a:schemeClr val="tx2"/>
+                </a:solidFill>
+              </a:rPr>
+              <a:t>姜黄入面</a:t>
+            </a:r>
+            <a:endParaRPr lang="en-US" sz="1200" dirty="0"/>
+          </a:p>
           <a:p>
             <a:pPr algn="ctr" indent="0" marL="0">
               <a:buNone/>
             </a:pPr>
             <a:r>
-              <a:rPr lang="en-US" sz="1200" b="1" dirty="0">
-                <a:solidFill>
-                  <a:schemeClr val="accent1"/>
-                </a:solidFill>
-              </a:rPr>
-              <a:t>姜黄配伍</a:t>
+              <a:rPr lang="en-US" sz="1200" dirty="0">
+                <a:solidFill>
+                  <a:schemeClr val="tx2"/>
+                </a:solidFill>
+              </a:rPr>
+              <a:t>天然金黄色泽</a:t>
             </a:r>
             <a:endParaRPr lang="en-US" sz="1200" dirty="0"/>
           </a:p>
@@ -12446,57 +12720,7 @@
       </p:sp>
       <p:sp>
         <p:nvSpPr>
-          <p:cNvPr id="33" name="Text 31"/>
-          <p:cNvSpPr txBox="1"/>
-          <p:nvPr/>
-        </p:nvSpPr>
-        <p:spPr>
-          <a:xfrm>
-            <a:off x="7434072" y="4069080"/>
-            <a:ext cx="1792224" cy="640080"/>
-          </a:xfrm>
-          <a:prstGeom prst="rect">
-            <a:avLst/>
-          </a:prstGeom>
-          <a:noFill/>
-          <a:ln/>
-        </p:spPr>
-        <p:txBody>
-          <a:bodyPr wrap="square" lIns="0" tIns="0" rIns="0" bIns="0" rtlCol="0" anchor="t"/>
-          <a:lstStyle/>
-          <a:p>
-            <a:pPr algn="ctr" indent="0" marL="0">
-              <a:buNone/>
-            </a:pPr>
-            <a:r>
-              <a:rPr lang="en-US" sz="1200" b="1" dirty="0">
-                <a:solidFill>
-                  <a:schemeClr val="tx2"/>
-                </a:solidFill>
-              </a:rPr>
-              <a:t>功能定位</a:t>
-            </a:r>
-            <a:endParaRPr lang="en-US" sz="1200" dirty="0"/>
-          </a:p>
-          <a:p>
-            <a:pPr algn="ctr" indent="0" marL="0">
-              <a:buNone/>
-            </a:pPr>
-            <a:r>
-              <a:rPr lang="en-US" sz="1200" dirty="0">
-                <a:solidFill>
-                  <a:schemeClr val="accent5"/>
-                </a:solidFill>
-              </a:rPr>
-              <a:t>［待陈博士确认］</a:t>
-            </a:r>
-            <a:endParaRPr lang="en-US" sz="1200" dirty="0"/>
-          </a:p>
-        </p:txBody>
-      </p:sp>
-      <p:sp>
-        <p:nvSpPr>
-          <p:cNvPr id="34" name="Shape 32"/>
+          <p:cNvPr id="42" name="Shape 40"/>
           <p:cNvSpPr/>
           <p:nvPr/>
         </p:nvSpPr>
@@ -12519,7 +12743,7 @@
       </p:sp>
       <p:sp>
         <p:nvSpPr>
-          <p:cNvPr id="35" name="Text 33"/>
+          <p:cNvPr id="43" name="Text 41"/>
           <p:cNvSpPr txBox="1"/>
           <p:nvPr/>
         </p:nvSpPr>
@@ -12555,7 +12779,7 @@
       </p:sp>
       <p:sp>
         <p:nvSpPr>
-          <p:cNvPr id="36" name="product-海藻"/>
+          <p:cNvPr id="44" name="product-海藻馒头"/>
           <p:cNvSpPr/>
           <p:nvPr/>
         </p:nvSpPr>
@@ -12584,20 +12808,76 @@
       </p:sp>
       <p:sp>
         <p:nvSpPr>
-          <p:cNvPr id="37" name="Shape 35"/>
+          <p:cNvPr id="45" name="Shape 43"/>
           <p:cNvSpPr/>
           <p:nvPr/>
         </p:nvSpPr>
         <p:spPr>
           <a:xfrm>
-            <a:off x="10030968" y="1874520"/>
-            <a:ext cx="1097280" cy="1097280"/>
+            <a:off x="9774936" y="1783080"/>
+            <a:ext cx="384048" cy="384048"/>
           </a:xfrm>
           <a:prstGeom prst="ellipse">
             <a:avLst/>
           </a:prstGeom>
           <a:solidFill>
             <a:schemeClr val="accent4"/>
+          </a:solidFill>
+          <a:ln/>
+        </p:spPr>
+      </p:sp>
+      <p:sp>
+        <p:nvSpPr>
+          <p:cNvPr id="46" name="Text 44"/>
+          <p:cNvSpPr txBox="1"/>
+          <p:nvPr/>
+        </p:nvSpPr>
+        <p:spPr>
+          <a:xfrm>
+            <a:off x="9774936" y="1783080"/>
+            <a:ext cx="384048" cy="384048"/>
+          </a:xfrm>
+          <a:prstGeom prst="rect">
+            <a:avLst/>
+          </a:prstGeom>
+          <a:noFill/>
+          <a:ln/>
+        </p:spPr>
+        <p:txBody>
+          <a:bodyPr wrap="square" lIns="0" tIns="0" rIns="0" bIns="0" rtlCol="0" anchor="ctr"/>
+          <a:lstStyle/>
+          <a:p>
+            <a:pPr algn="ctr" indent="0" marL="0">
+              <a:buNone/>
+            </a:pPr>
+            <a:r>
+              <a:rPr lang="en-US" sz="1100" b="1" dirty="0">
+                <a:solidFill>
+                  <a:schemeClr val="tx1"/>
+                </a:solidFill>
+              </a:rPr>
+              <a:t>05</a:t>
+            </a:r>
+            <a:endParaRPr lang="en-US" sz="1100" dirty="0"/>
+          </a:p>
+        </p:txBody>
+      </p:sp>
+      <p:sp>
+        <p:nvSpPr>
+          <p:cNvPr id="47" name="Shape 45"/>
+          <p:cNvSpPr/>
+          <p:nvPr/>
+        </p:nvSpPr>
+        <p:spPr>
+          <a:xfrm>
+            <a:off x="10076688" y="1874520"/>
+            <a:ext cx="1005840" cy="1005840"/>
+          </a:xfrm>
+          <a:prstGeom prst="ellipse">
+            <a:avLst/>
+          </a:prstGeom>
+          <a:solidFill>
+            <a:srgbClr val="4F6B4A"/>
           </a:solidFill>
           <a:ln w="19050">
             <a:solidFill>
@@ -12609,14 +12889,14 @@
       </p:sp>
       <p:sp>
         <p:nvSpPr>
-          <p:cNvPr id="38" name="Text 36"/>
+          <p:cNvPr id="48" name="Text 46"/>
           <p:cNvSpPr txBox="1"/>
           <p:nvPr/>
         </p:nvSpPr>
         <p:spPr>
           <a:xfrm>
-            <a:off x="10030968" y="1874520"/>
-            <a:ext cx="1097280" cy="1097280"/>
+            <a:off x="10076688" y="1874520"/>
+            <a:ext cx="1005840" cy="1005840"/>
           </a:xfrm>
           <a:prstGeom prst="rect">
             <a:avLst/>
@@ -12632,27 +12912,99 @@
               <a:buNone/>
             </a:pPr>
             <a:r>
-              <a:rPr lang="en-US" sz="3600" b="1" dirty="0">
+              <a:rPr lang="en-US" sz="3200" b="1" dirty="0">
+                <a:solidFill>
+                  <a:schemeClr val="bg1"/>
+                </a:solidFill>
+              </a:rPr>
+              <a:t>藻</a:t>
+            </a:r>
+            <a:endParaRPr lang="en-US" sz="3200" dirty="0"/>
+          </a:p>
+        </p:txBody>
+      </p:sp>
+      <p:sp>
+        <p:nvSpPr>
+          <p:cNvPr id="49" name="Text 47"/>
+          <p:cNvSpPr txBox="1"/>
+          <p:nvPr/>
+        </p:nvSpPr>
+        <p:spPr>
+          <a:xfrm>
+            <a:off x="9637776" y="3063240"/>
+            <a:ext cx="1883664" cy="457200"/>
+          </a:xfrm>
+          <a:prstGeom prst="rect">
+            <a:avLst/>
+          </a:prstGeom>
+          <a:noFill/>
+          <a:ln/>
+        </p:spPr>
+        <p:txBody>
+          <a:bodyPr wrap="square" lIns="0" tIns="0" rIns="0" bIns="0" rtlCol="0" anchor="t"/>
+          <a:lstStyle/>
+          <a:p>
+            <a:pPr algn="ctr" indent="0" marL="0">
+              <a:buNone/>
+            </a:pPr>
+            <a:r>
+              <a:rPr lang="en-US" sz="2000" b="1" dirty="0">
+                <a:solidFill>
+                  <a:schemeClr val="tx1"/>
+                </a:solidFill>
+              </a:rPr>
+              <a:t>海藻馒头</a:t>
+            </a:r>
+            <a:endParaRPr lang="en-US" sz="2000" dirty="0"/>
+          </a:p>
+        </p:txBody>
+      </p:sp>
+      <p:sp>
+        <p:nvSpPr>
+          <p:cNvPr id="50" name="Text 48"/>
+          <p:cNvSpPr txBox="1"/>
+          <p:nvPr/>
+        </p:nvSpPr>
+        <p:spPr>
+          <a:xfrm>
+            <a:off x="9637776" y="3520440"/>
+            <a:ext cx="1883664" cy="320040"/>
+          </a:xfrm>
+          <a:prstGeom prst="rect">
+            <a:avLst/>
+          </a:prstGeom>
+          <a:noFill/>
+          <a:ln/>
+        </p:spPr>
+        <p:txBody>
+          <a:bodyPr wrap="square" lIns="0" tIns="0" rIns="0" bIns="0" rtlCol="0" anchor="t"/>
+          <a:lstStyle/>
+          <a:p>
+            <a:pPr algn="ctr" indent="0" marL="0">
+              <a:buNone/>
+            </a:pPr>
+            <a:r>
+              <a:rPr lang="en-US" sz="1200" b="1" dirty="0">
                 <a:solidFill>
                   <a:schemeClr val="accent1"/>
                 </a:solidFill>
               </a:rPr>
-              <a:t>藻</a:t>
-            </a:r>
-            <a:endParaRPr lang="en-US" sz="3600" dirty="0"/>
-          </a:p>
-        </p:txBody>
-      </p:sp>
-      <p:sp>
-        <p:nvSpPr>
-          <p:cNvPr id="39" name="Text 37"/>
+              <a:t>绿色</a:t>
+            </a:r>
+            <a:endParaRPr lang="en-US" sz="1200" dirty="0"/>
+          </a:p>
+        </p:txBody>
+      </p:sp>
+      <p:sp>
+        <p:nvSpPr>
+          <p:cNvPr id="51" name="Text 49"/>
           <p:cNvSpPr txBox="1"/>
           <p:nvPr/>
         </p:nvSpPr>
         <p:spPr>
           <a:xfrm>
-            <a:off x="9637776" y="3154680"/>
-            <a:ext cx="1883664" cy="457200"/>
+            <a:off x="9683496" y="3977640"/>
+            <a:ext cx="1792224" cy="731520"/>
           </a:xfrm>
           <a:prstGeom prst="rect">
             <a:avLst/>
@@ -12668,48 +13020,26 @@
               <a:buNone/>
             </a:pPr>
             <a:r>
-              <a:rPr lang="en-US" sz="2000" b="1" dirty="0">
-                <a:solidFill>
-                  <a:schemeClr val="tx1"/>
-                </a:solidFill>
-              </a:rPr>
-              <a:t>海藻</a:t>
-            </a:r>
-            <a:endParaRPr lang="en-US" sz="2000" dirty="0"/>
-          </a:p>
-        </p:txBody>
-      </p:sp>
-      <p:sp>
-        <p:nvSpPr>
-          <p:cNvPr id="40" name="Text 38"/>
-          <p:cNvSpPr txBox="1"/>
-          <p:nvPr/>
-        </p:nvSpPr>
-        <p:spPr>
-          <a:xfrm>
-            <a:off x="9637776" y="3611880"/>
-            <a:ext cx="1883664" cy="320040"/>
-          </a:xfrm>
-          <a:prstGeom prst="rect">
-            <a:avLst/>
-          </a:prstGeom>
-          <a:noFill/>
-          <a:ln/>
-        </p:spPr>
-        <p:txBody>
-          <a:bodyPr wrap="square" lIns="0" tIns="0" rIns="0" bIns="0" rtlCol="0" anchor="t"/>
-          <a:lstStyle/>
+              <a:rPr lang="en-US" sz="1200" dirty="0">
+                <a:solidFill>
+                  <a:schemeClr val="tx2"/>
+                </a:solidFill>
+              </a:rPr>
+              <a:t>海藻入面</a:t>
+            </a:r>
+            <a:endParaRPr lang="en-US" sz="1200" dirty="0"/>
+          </a:p>
           <a:p>
             <a:pPr algn="ctr" indent="0" marL="0">
               <a:buNone/>
             </a:pPr>
             <a:r>
-              <a:rPr lang="en-US" sz="1200" b="1" dirty="0">
-                <a:solidFill>
-                  <a:schemeClr val="accent1"/>
-                </a:solidFill>
-              </a:rPr>
-              <a:t>海藻配伍</a:t>
+              <a:rPr lang="en-US" sz="1200" dirty="0">
+                <a:solidFill>
+                  <a:schemeClr val="tx2"/>
+                </a:solidFill>
+              </a:rPr>
+              <a:t>轻食主食定位</a:t>
             </a:r>
             <a:endParaRPr lang="en-US" sz="1200" dirty="0"/>
           </a:p>
@@ -12717,57 +13047,7 @@
       </p:sp>
       <p:sp>
         <p:nvSpPr>
-          <p:cNvPr id="41" name="Text 39"/>
-          <p:cNvSpPr txBox="1"/>
-          <p:nvPr/>
-        </p:nvSpPr>
-        <p:spPr>
-          <a:xfrm>
-            <a:off x="9683496" y="4069080"/>
-            <a:ext cx="1792224" cy="640080"/>
-          </a:xfrm>
-          <a:prstGeom prst="rect">
-            <a:avLst/>
-          </a:prstGeom>
-          <a:noFill/>
-          <a:ln/>
-        </p:spPr>
-        <p:txBody>
-          <a:bodyPr wrap="square" lIns="0" tIns="0" rIns="0" bIns="0" rtlCol="0" anchor="t"/>
-          <a:lstStyle/>
-          <a:p>
-            <a:pPr algn="ctr" indent="0" marL="0">
-              <a:buNone/>
-            </a:pPr>
-            <a:r>
-              <a:rPr lang="en-US" sz="1200" b="1" dirty="0">
-                <a:solidFill>
-                  <a:schemeClr val="tx2"/>
-                </a:solidFill>
-              </a:rPr>
-              <a:t>功能定位</a:t>
-            </a:r>
-            <a:endParaRPr lang="en-US" sz="1200" dirty="0"/>
-          </a:p>
-          <a:p>
-            <a:pPr algn="ctr" indent="0" marL="0">
-              <a:buNone/>
-            </a:pPr>
-            <a:r>
-              <a:rPr lang="en-US" sz="1200" dirty="0">
-                <a:solidFill>
-                  <a:schemeClr val="accent5"/>
-                </a:solidFill>
-              </a:rPr>
-              <a:t>［待陈博士确认］</a:t>
-            </a:r>
-            <a:endParaRPr lang="en-US" sz="1200" dirty="0"/>
-          </a:p>
-        </p:txBody>
-      </p:sp>
-      <p:sp>
-        <p:nvSpPr>
-          <p:cNvPr id="42" name="Shape 40"/>
+          <p:cNvPr id="52" name="Shape 50"/>
           <p:cNvSpPr/>
           <p:nvPr/>
         </p:nvSpPr>
@@ -12790,7 +13070,7 @@
       </p:sp>
       <p:sp>
         <p:nvSpPr>
-          <p:cNvPr id="43" name="Text 41"/>
+          <p:cNvPr id="53" name="Text 51"/>
           <p:cNvSpPr txBox="1"/>
           <p:nvPr/>
         </p:nvSpPr>
@@ -12826,7 +13106,7 @@
       </p:sp>
       <p:sp>
         <p:nvSpPr>
-          <p:cNvPr id="44" name="Text 42"/>
+          <p:cNvPr id="54" name="Text 52"/>
           <p:cNvSpPr txBox="1"/>
           <p:nvPr/>
         </p:nvSpPr>
@@ -12854,7 +13134,7 @@
                   <a:schemeClr val="tx2"/>
                 </a:solidFill>
               </a:rPr>
-              <a:t>注：五行为配方功能体系，非颜色分类；功能对外表述须符合普通食品法规，不得声称预防、治疗疾病或保健功能；配方组成以陈博士最终确认为准。</a:t>
+              <a:t>注：产品为普通食品，对外不作预防、治疗疾病或保健功能声称；各SKU功能方向表述须经食品合规审核后方可使用；配方组成以陈博士最终确认为准。</a:t>
             </a:r>
             <a:endParaRPr lang="en-US" sz="1000" dirty="0"/>
           </a:p>

</xml_diff>

<commit_message>
DR-002: fill channel appendix from partner table; 茯苓馒头 white
Co-Authored-By: Claude Opus 5.5 <noreply@anthropic.com>
Claude-Session: https://claude.ai/code/session_0137DxXVQUvWUjpTeTg3QLMn
</commit_message>
<xml_diff>
--- a/DR-002/DR-002_中粮海嘉五行预拌粉合作计划_V1.0.pptx
+++ b/DR-002/DR-002_中粮海嘉五行预拌粉合作计划_V1.0.pptx
@@ -120,44 +120,44 @@
   <p:extLst>
     <p:ext uri="{521415D9-36F7-43E2-AB2F-B90AF26B5E84}">
       <p14:sectionLst xmlns:p14="http://schemas.microsoft.com/office/powerpoint/2010/main">
-        <p14:section name="开篇" id="{03450c05-94df-5e00-690d-fd450fc6a8fe}">
+        <p14:section name="开篇" id="{b4b9687c-e152-5b57-c5ec-596f3f4f5d04}">
           <p14:sldIdLst>
             <p14:sldId id="256"/>
           </p14:sldIdLst>
         </p14:section>
-        <p14:section name="合作基础" id="{cb805b3d-8c3a-d237-6b8e-7a39ac3c368d}">
+        <p14:section name="合作基础" id="{b15c7e50-474f-0815-b078-ea3b8ff480c8}">
           <p14:sldIdLst>
             <p14:sldId id="257"/>
             <p14:sldId id="258"/>
           </p14:sldIdLst>
         </p14:section>
-        <p14:section name="产品与模式" id="{555341eb-c640-a229-606e-e34033a82450}">
+        <p14:section name="产品与模式" id="{af2488d6-4c99-57a2-6c39-5ac11627249d}">
           <p14:sldIdLst>
             <p14:sldId id="259"/>
             <p14:sldId id="260"/>
             <p14:sldId id="261"/>
           </p14:sldIdLst>
         </p14:section>
-        <p14:section name="市场落地" id="{8ae3fb6b-be27-4a64-07d4-e99e114e2d62}">
+        <p14:section name="市场落地" id="{b690f230-459c-8e9e-8adc-fb7952c32538}">
           <p14:sldIdLst>
             <p14:sldId id="262"/>
           </p14:sldIdLst>
         </p14:section>
-        <p14:section name="收益与财务" id="{4ce5a13b-bf97-1e7c-8348-907a9d5658ef}">
+        <p14:section name="收益与财务" id="{cffdfe82-2868-3987-f474-fd5a6f65c4e7}">
           <p14:sldIdLst>
             <p14:sldId id="263"/>
             <p14:sldId id="264"/>
             <p14:sldId id="265"/>
           </p14:sldIdLst>
         </p14:section>
-        <p14:section name="行动计划" id="{f283d524-9f90-089a-4a0c-23cfed66501a}">
+        <p14:section name="行动计划" id="{55e5ddcf-f428-75a4-e284-10801fa839e4}">
           <p14:sldIdLst>
             <p14:sldId id="266"/>
             <p14:sldId id="267"/>
             <p14:sldId id="268"/>
           </p14:sldIdLst>
         </p14:section>
-        <p14:section name="附件" id="{426db1c6-32b9-4b9b-7b9b-d84212136161}">
+        <p14:section name="附件" id="{044dc920-872f-a002-f6ea-9dd79b908aa3}">
           <p14:sldIdLst>
             <p14:sldId id="269"/>
           </p14:sldIdLst>
@@ -1285,7 +1285,7 @@
           <a:p>
             <a:r>
               <a:rPr lang="en-US" dirty="0"/>
-              <a:t>福建3,719个潜在终端渠道据点，不是B2B直接客户（直接客户为原料经销商及馒头生产厂）。必须强调三点：数据由合作伙伴提供；尚未去重；尚未确认进场。分类明细待补，本页表格可直接填入。</a:t>
+              <a:t>附件为合作伙伴提供的潜在终端渠道清单，含便利连锁、卖场、生鲜连锁、精品店、面包连锁、中专大学及二批。原资料合计3,719，各类小计合计3,592，明细与小计有不符之处，须核对。罗森（广东）300家不在福建。这些均为潜在终端渠道，不是预拌粉的B2B直接客户，尚未去重及确认进场。</a:t>
             </a:r>
             <a:endParaRPr lang="en-US" dirty="0"/>
           </a:p>
@@ -7679,7 +7679,7 @@
                   <a:schemeClr val="accent1"/>
                 </a:solidFill>
               </a:rPr>
-              <a:t>附件 · 福建终端渠道资源</a:t>
+              <a:t>附件 · 终端渠道资源</a:t>
             </a:r>
             <a:endParaRPr lang="en-US" sz="1200" dirty="0"/>
           </a:p>
@@ -7717,7 +7717,7 @@
                   <a:schemeClr val="tx1"/>
                 </a:solidFill>
               </a:rPr>
-              <a:t>附件：福建3,719个潜在终端渠道据点</a:t>
+              <a:t>附件：潜在终端渠道资源明细（合作伙伴提供）</a:t>
             </a:r>
             <a:endParaRPr lang="en-US" sz="3000" dirty="0"/>
           </a:p>
@@ -7732,11 +7732,11 @@
         <p:spPr>
           <a:xfrm>
             <a:off x="548640" y="1600200"/>
-            <a:ext cx="3840480" cy="4206240"/>
+            <a:ext cx="3017520" cy="4114800"/>
           </a:xfrm>
           <a:prstGeom prst="roundRect">
             <a:avLst>
-              <a:gd name="adj" fmla="val 1905"/>
+              <a:gd name="adj" fmla="val 2424"/>
             </a:avLst>
           </a:prstGeom>
           <a:solidFill>
@@ -7760,8 +7760,8 @@
         </p:nvSpPr>
         <p:spPr>
           <a:xfrm>
-            <a:off x="868680" y="1874520"/>
-            <a:ext cx="685800" cy="685800"/>
+            <a:off x="822960" y="1828800"/>
+            <a:ext cx="594360" cy="594360"/>
           </a:xfrm>
           <a:prstGeom prst="ellipse">
             <a:avLst/>
@@ -7788,8 +7788,8 @@
         </p:blipFill>
         <p:spPr>
           <a:xfrm>
-            <a:off x="1046988" y="2052828"/>
-            <a:ext cx="329184" cy="329184"/>
+            <a:off x="977494" y="1983334"/>
+            <a:ext cx="285293" cy="285293"/>
           </a:xfrm>
           <a:prstGeom prst="rect">
             <a:avLst/>
@@ -7804,8 +7804,8 @@
         </p:nvSpPr>
         <p:spPr>
           <a:xfrm>
-            <a:off x="822960" y="2697480"/>
-            <a:ext cx="3383280" cy="1097280"/>
+            <a:off x="822960" y="2514600"/>
+            <a:ext cx="2651760" cy="868680"/>
           </a:xfrm>
           <a:prstGeom prst="rect">
             <a:avLst/>
@@ -7821,14 +7821,14 @@
               <a:buNone/>
             </a:pPr>
             <a:r>
-              <a:rPr lang="en-US" sz="6600" b="1" dirty="0">
+              <a:rPr lang="en-US" sz="6000" b="1" dirty="0">
                 <a:solidFill>
                   <a:schemeClr val="accent2"/>
                 </a:solidFill>
               </a:rPr>
               <a:t>3,719</a:t>
             </a:r>
-            <a:endParaRPr lang="en-US" sz="6600" dirty="0"/>
+            <a:endParaRPr lang="en-US" sz="6000" dirty="0"/>
           </a:p>
         </p:txBody>
       </p:sp>
@@ -7840,8 +7840,8 @@
         </p:nvSpPr>
         <p:spPr>
           <a:xfrm>
-            <a:off x="868680" y="3794760"/>
-            <a:ext cx="3383280" cy="365760"/>
+            <a:off x="822960" y="3383280"/>
+            <a:ext cx="2651760" cy="594360"/>
           </a:xfrm>
           <a:prstGeom prst="rect">
             <a:avLst/>
@@ -7857,14 +7857,28 @@
               <a:buNone/>
             </a:pPr>
             <a:r>
-              <a:rPr lang="en-US" sz="1500" dirty="0">
+              <a:rPr lang="en-US" sz="1400" dirty="0">
                 <a:solidFill>
                   <a:schemeClr val="bg1"/>
                 </a:solidFill>
               </a:rPr>
-              <a:t>个潜在终端渠道据点（福建省）</a:t>
-            </a:r>
-            <a:endParaRPr lang="en-US" sz="1500" dirty="0"/>
+              <a:t>原资料合计</a:t>
+            </a:r>
+            <a:endParaRPr lang="en-US" sz="1400" dirty="0"/>
+          </a:p>
+          <a:p>
+            <a:pPr indent="0" marL="0">
+              <a:buNone/>
+            </a:pPr>
+            <a:r>
+              <a:rPr lang="en-US" sz="1400" dirty="0">
+                <a:solidFill>
+                  <a:schemeClr val="bg1"/>
+                </a:solidFill>
+              </a:rPr>
+              <a:t>潜在终端渠道据点</a:t>
+            </a:r>
+            <a:endParaRPr lang="en-US" sz="1400" dirty="0"/>
           </a:p>
         </p:txBody>
       </p:sp>
@@ -7876,8 +7890,8 @@
         </p:nvSpPr>
         <p:spPr>
           <a:xfrm>
-            <a:off x="868680" y="4572000"/>
-            <a:ext cx="1051560" cy="329184"/>
+            <a:off x="822960" y="4114800"/>
+            <a:ext cx="1828800" cy="329184"/>
           </a:xfrm>
           <a:prstGeom prst="roundRect">
             <a:avLst>
@@ -7898,8 +7912,8 @@
         </p:nvSpPr>
         <p:spPr>
           <a:xfrm>
-            <a:off x="868680" y="4572000"/>
-            <a:ext cx="1051560" cy="329184"/>
+            <a:off x="822960" y="4114800"/>
+            <a:ext cx="1828800" cy="329184"/>
           </a:xfrm>
           <a:prstGeom prst="rect">
             <a:avLst/>
@@ -7934,8 +7948,8 @@
         </p:nvSpPr>
         <p:spPr>
           <a:xfrm>
-            <a:off x="1984248" y="4572000"/>
-            <a:ext cx="1051560" cy="329184"/>
+            <a:off x="822960" y="4526280"/>
+            <a:ext cx="1828800" cy="329184"/>
           </a:xfrm>
           <a:prstGeom prst="roundRect">
             <a:avLst>
@@ -7956,8 +7970,8 @@
         </p:nvSpPr>
         <p:spPr>
           <a:xfrm>
-            <a:off x="1984248" y="4572000"/>
-            <a:ext cx="1051560" cy="329184"/>
+            <a:off x="822960" y="4526280"/>
+            <a:ext cx="1828800" cy="329184"/>
           </a:xfrm>
           <a:prstGeom prst="rect">
             <a:avLst/>
@@ -7992,8 +8006,8 @@
         </p:nvSpPr>
         <p:spPr>
           <a:xfrm>
-            <a:off x="3099816" y="4572000"/>
-            <a:ext cx="1051560" cy="329184"/>
+            <a:off x="822960" y="4937760"/>
+            <a:ext cx="1828800" cy="329184"/>
           </a:xfrm>
           <a:prstGeom prst="roundRect">
             <a:avLst>
@@ -8014,8 +8028,8 @@
         </p:nvSpPr>
         <p:spPr>
           <a:xfrm>
-            <a:off x="3099816" y="4572000"/>
-            <a:ext cx="1051560" cy="329184"/>
+            <a:off x="822960" y="4937760"/>
+            <a:ext cx="1828800" cy="329184"/>
           </a:xfrm>
           <a:prstGeom prst="rect">
             <a:avLst/>
@@ -8050,8 +8064,8 @@
         </p:nvSpPr>
         <p:spPr>
           <a:xfrm>
-            <a:off x="868680" y="5120640"/>
-            <a:ext cx="3291840" cy="320040"/>
+            <a:off x="822960" y="5349240"/>
+            <a:ext cx="2651760" cy="274320"/>
           </a:xfrm>
           <a:prstGeom prst="rect">
             <a:avLst/>
@@ -8067,119 +8081,14 @@
               <a:buNone/>
             </a:pPr>
             <a:r>
-              <a:rPr lang="en-US" sz="1100" dirty="0">
+              <a:rPr lang="en-US" sz="1000" dirty="0">
                 <a:solidFill>
                   <a:schemeClr val="accent4"/>
                 </a:solidFill>
               </a:rPr>
               <a:t>数据口径以合作伙伴原始清单为准</a:t>
             </a:r>
-            <a:endParaRPr lang="en-US" sz="1100" dirty="0"/>
-          </a:p>
-        </p:txBody>
-      </p:sp>
-      <p:sp>
-        <p:nvSpPr>
-          <p:cNvPr id="16" name="Shape 13"/>
-          <p:cNvSpPr/>
-          <p:nvPr/>
-        </p:nvSpPr>
-        <p:spPr>
-          <a:xfrm>
-            <a:off x="4754880" y="4709160"/>
-            <a:ext cx="6858000" cy="1097280"/>
-          </a:xfrm>
-          <a:prstGeom prst="roundRect">
-            <a:avLst>
-              <a:gd name="adj" fmla="val 6667"/>
-            </a:avLst>
-          </a:prstGeom>
-          <a:solidFill>
-            <a:schemeClr val="accent4"/>
-          </a:solidFill>
-          <a:ln/>
-        </p:spPr>
-      </p:sp>
-      <p:sp>
-        <p:nvSpPr>
-          <p:cNvPr id="17" name="Text 14"/>
-          <p:cNvSpPr txBox="1"/>
-          <p:nvPr/>
-        </p:nvSpPr>
-        <p:spPr>
-          <a:xfrm>
-            <a:off x="4937760" y="4709160"/>
-            <a:ext cx="6492240" cy="1097280"/>
-          </a:xfrm>
-          <a:prstGeom prst="rect">
-            <a:avLst/>
-          </a:prstGeom>
-          <a:noFill/>
-          <a:ln/>
-        </p:spPr>
-        <p:txBody>
-          <a:bodyPr wrap="square" lIns="0" tIns="0" rIns="0" bIns="0" rtlCol="0" anchor="ctr"/>
-          <a:lstStyle/>
-          <a:p>
-            <a:pPr indent="0" marL="0">
-              <a:buNone/>
-            </a:pPr>
-            <a:r>
-              <a:rPr lang="en-US" sz="1300" b="1" dirty="0">
-                <a:solidFill>
-                  <a:schemeClr val="accent5"/>
-                </a:solidFill>
-              </a:rPr>
-              <a:t>客户定位：</a:t>
-            </a:r>
-            <a:pPr indent="0" marL="0">
-              <a:buNone/>
-            </a:pPr>
-            <a:r>
-              <a:rPr lang="en-US" sz="1300" dirty="0">
-                <a:solidFill>
-                  <a:schemeClr val="tx1"/>
-                </a:solidFill>
-              </a:rPr>
-              <a:t>B2B 直接销售对象为原料经销商及馒头生产厂；3,719个据点是馒头产品的潜在终端渠道资源，用于带动下游动销，不是预拌粉的直接客户。</a:t>
-            </a:r>
-            <a:endParaRPr lang="en-US" sz="1300" dirty="0"/>
-          </a:p>
-        </p:txBody>
-      </p:sp>
-      <p:sp>
-        <p:nvSpPr>
-          <p:cNvPr id="18" name="Text 15"/>
-          <p:cNvSpPr txBox="1"/>
-          <p:nvPr/>
-        </p:nvSpPr>
-        <p:spPr>
-          <a:xfrm>
-            <a:off x="4754880" y="1600200"/>
-            <a:ext cx="4572000" cy="365760"/>
-          </a:xfrm>
-          <a:prstGeom prst="rect">
-            <a:avLst/>
-          </a:prstGeom>
-          <a:noFill/>
-          <a:ln/>
-        </p:spPr>
-        <p:txBody>
-          <a:bodyPr wrap="square" lIns="0" tIns="0" rIns="0" bIns="0" rtlCol="0" anchor="t"/>
-          <a:lstStyle/>
-          <a:p>
-            <a:pPr indent="0" marL="0">
-              <a:buNone/>
-            </a:pPr>
-            <a:r>
-              <a:rPr lang="en-US" sz="1800" b="1" dirty="0">
-                <a:solidFill>
-                  <a:schemeClr val="tx1"/>
-                </a:solidFill>
-              </a:rPr>
-              <a:t>终端渠道据点分类</a:t>
-            </a:r>
-            <a:endParaRPr lang="en-US" sz="1800" dirty="0"/>
+            <a:endParaRPr lang="en-US" sz="1000" dirty="0"/>
           </a:p>
         </p:txBody>
       </p:sp>
@@ -8198,19 +8107,19 @@
           </p:nvPr>
         </p:nvGraphicFramePr>
         <p:xfrm>
-          <a:off x="4754880" y="2057400"/>
-          <a:ext cx="6858000" cy="914400"/>
+          <a:off x="3840480" y="1600200"/>
+          <a:ext cx="7772400" cy="914400"/>
         </p:xfrm>
         <a:graphic>
           <a:graphicData uri="http://schemas.openxmlformats.org/drawingml/2006/table">
             <a:tbl>
               <a:tblPr/>
               <a:tblGrid>
-                <a:gridCol w="2651760"/>
                 <a:gridCol w="1280160"/>
-                <a:gridCol w="2926080"/>
+                <a:gridCol w="5394960"/>
+                <a:gridCol w="1097280"/>
               </a:tblGrid>
-              <a:tr h="411480">
+              <a:tr h="347472">
                 <a:tc>
                   <a:txBody>
                     <a:bodyPr/>
@@ -8220,17 +8129,78 @@
                         <a:buNone/>
                       </a:pPr>
                       <a:r>
-                        <a:rPr lang="en-US" sz="1300" b="1" dirty="0">
+                        <a:rPr lang="en-US" sz="1200" b="1" dirty="0">
                           <a:solidFill>
                             <a:schemeClr val="bg1"/>
                           </a:solidFill>
                         </a:rPr>
-                        <a:t>渠道类别</a:t>
+                        <a:t>渠道类型</a:t>
                       </a:r>
-                      <a:endParaRPr lang="en-US" sz="1300" dirty="0"/>
+                      <a:endParaRPr lang="en-US" sz="1200" dirty="0"/>
                     </a:p>
                   </a:txBody>
-                  <a:tcPr marL="109728" marR="109728" marT="0" marB="0" anchor="ctr">
+                  <a:tcPr marL="91440" marR="91440" marT="0" marB="0" anchor="ctr">
+                    <a:lnL w="9525" cap="flat" cmpd="sng" algn="ctr">
+                      <a:solidFill>
+                        <a:srgbClr val="EADFC8"/>
+                      </a:solidFill>
+                      <a:prstDash val="solid"/>
+                      <a:round/>
+                      <a:headEnd type="none" w="med" len="med"/>
+                      <a:tailEnd type="none" w="med" len="med"/>
+                    </a:lnL>
+                    <a:lnR w="9525" cap="flat" cmpd="sng" algn="ctr">
+                      <a:solidFill>
+                        <a:srgbClr val="EADFC8"/>
+                      </a:solidFill>
+                      <a:prstDash val="solid"/>
+                      <a:round/>
+                      <a:headEnd type="none" w="med" len="med"/>
+                      <a:tailEnd type="none" w="med" len="med"/>
+                    </a:lnR>
+                    <a:lnT w="9525" cap="flat" cmpd="sng" algn="ctr">
+                      <a:solidFill>
+                        <a:srgbClr val="EADFC8"/>
+                      </a:solidFill>
+                      <a:prstDash val="solid"/>
+                      <a:round/>
+                      <a:headEnd type="none" w="med" len="med"/>
+                      <a:tailEnd type="none" w="med" len="med"/>
+                    </a:lnT>
+                    <a:lnB w="9525" cap="flat" cmpd="sng" algn="ctr">
+                      <a:solidFill>
+                        <a:srgbClr val="EADFC8"/>
+                      </a:solidFill>
+                      <a:prstDash val="solid"/>
+                      <a:round/>
+                      <a:headEnd type="none" w="med" len="med"/>
+                      <a:tailEnd type="none" w="med" len="med"/>
+                    </a:lnB>
+                    <a:solidFill>
+                      <a:schemeClr val="accent1"/>
+                    </a:solidFill>
+                  </a:tcPr>
+                </a:tc>
+                <a:tc>
+                  <a:txBody>
+                    <a:bodyPr/>
+                    <a:lstStyle/>
+                    <a:p>
+                      <a:pPr indent="0" marL="0">
+                        <a:buNone/>
+                      </a:pPr>
+                      <a:r>
+                        <a:rPr lang="en-US" sz="1200" b="1" dirty="0">
+                          <a:solidFill>
+                            <a:schemeClr val="bg1"/>
+                          </a:solidFill>
+                        </a:rPr>
+                        <a:t>主要客户（店数）</a:t>
+                      </a:r>
+                      <a:endParaRPr lang="en-US" sz="1200" dirty="0"/>
+                    </a:p>
+                  </a:txBody>
+                  <a:tcPr marL="91440" marR="91440" marT="0" marB="0" anchor="ctr">
                     <a:lnL w="9525" cap="flat" cmpd="sng" algn="ctr">
                       <a:solidFill>
                         <a:srgbClr val="EADFC8"/>
@@ -8281,17 +8251,17 @@
                         <a:buNone/>
                       </a:pPr>
                       <a:r>
-                        <a:rPr lang="en-US" sz="1300" b="1" dirty="0">
+                        <a:rPr lang="en-US" sz="1200" b="1" dirty="0">
                           <a:solidFill>
                             <a:schemeClr val="bg1"/>
                           </a:solidFill>
                         </a:rPr>
-                        <a:t>据点数</a:t>
+                        <a:t>小计（家）</a:t>
                       </a:r>
-                      <a:endParaRPr lang="en-US" sz="1300" dirty="0"/>
+                      <a:endParaRPr lang="en-US" sz="1200" dirty="0"/>
                     </a:p>
                   </a:txBody>
-                  <a:tcPr marL="109728" marR="109728" marT="0" marB="0" anchor="ctr">
+                  <a:tcPr marL="91440" marR="91440" marT="0" marB="0" anchor="ctr">
                     <a:lnL w="9525" cap="flat" cmpd="sng" algn="ctr">
                       <a:solidFill>
                         <a:srgbClr val="EADFC8"/>
@@ -8330,6 +8300,69 @@
                     </a:lnB>
                     <a:solidFill>
                       <a:schemeClr val="accent1"/>
+                    </a:solidFill>
+                  </a:tcPr>
+                </a:tc>
+              </a:tr>
+              <a:tr h="640080">
+                <a:tc>
+                  <a:txBody>
+                    <a:bodyPr/>
+                    <a:lstStyle/>
+                    <a:p>
+                      <a:pPr indent="0" marL="0">
+                        <a:buNone/>
+                      </a:pPr>
+                      <a:r>
+                        <a:rPr lang="en-US" sz="1200" b="1" dirty="0">
+                          <a:solidFill>
+                            <a:schemeClr val="tx1"/>
+                          </a:solidFill>
+                        </a:rPr>
+                        <a:t>便利连锁</a:t>
+                      </a:r>
+                      <a:endParaRPr lang="en-US" sz="1200" dirty="0"/>
+                    </a:p>
+                  </a:txBody>
+                  <a:tcPr marL="91440" marR="91440" marT="0" marB="0" anchor="ctr">
+                    <a:lnL w="9525" cap="flat" cmpd="sng" algn="ctr">
+                      <a:solidFill>
+                        <a:srgbClr val="EADFC8"/>
+                      </a:solidFill>
+                      <a:prstDash val="solid"/>
+                      <a:round/>
+                      <a:headEnd type="none" w="med" len="med"/>
+                      <a:tailEnd type="none" w="med" len="med"/>
+                    </a:lnL>
+                    <a:lnR w="9525" cap="flat" cmpd="sng" algn="ctr">
+                      <a:solidFill>
+                        <a:srgbClr val="EADFC8"/>
+                      </a:solidFill>
+                      <a:prstDash val="solid"/>
+                      <a:round/>
+                      <a:headEnd type="none" w="med" len="med"/>
+                      <a:tailEnd type="none" w="med" len="med"/>
+                    </a:lnR>
+                    <a:lnT w="9525" cap="flat" cmpd="sng" algn="ctr">
+                      <a:solidFill>
+                        <a:srgbClr val="EADFC8"/>
+                      </a:solidFill>
+                      <a:prstDash val="solid"/>
+                      <a:round/>
+                      <a:headEnd type="none" w="med" len="med"/>
+                      <a:tailEnd type="none" w="med" len="med"/>
+                    </a:lnT>
+                    <a:lnB w="9525" cap="flat" cmpd="sng" algn="ctr">
+                      <a:solidFill>
+                        <a:srgbClr val="EADFC8"/>
+                      </a:solidFill>
+                      <a:prstDash val="solid"/>
+                      <a:round/>
+                      <a:headEnd type="none" w="med" len="med"/>
+                      <a:tailEnd type="none" w="med" len="med"/>
+                    </a:lnB>
+                    <a:solidFill>
+                      <a:schemeClr val="bg1"/>
                     </a:solidFill>
                   </a:tcPr>
                 </a:tc>
@@ -8342,80 +8375,17 @@
                         <a:buNone/>
                       </a:pPr>
                       <a:r>
-                        <a:rPr lang="en-US" sz="1300" b="1" dirty="0">
-                          <a:solidFill>
-                            <a:schemeClr val="bg1"/>
-                          </a:solidFill>
-                        </a:rPr>
-                        <a:t>在链路中的角色</a:t>
-                      </a:r>
-                      <a:endParaRPr lang="en-US" sz="1300" dirty="0"/>
-                    </a:p>
-                  </a:txBody>
-                  <a:tcPr marL="109728" marR="109728" marT="0" marB="0" anchor="ctr">
-                    <a:lnL w="9525" cap="flat" cmpd="sng" algn="ctr">
-                      <a:solidFill>
-                        <a:srgbClr val="EADFC8"/>
-                      </a:solidFill>
-                      <a:prstDash val="solid"/>
-                      <a:round/>
-                      <a:headEnd type="none" w="med" len="med"/>
-                      <a:tailEnd type="none" w="med" len="med"/>
-                    </a:lnL>
-                    <a:lnR w="9525" cap="flat" cmpd="sng" algn="ctr">
-                      <a:solidFill>
-                        <a:srgbClr val="EADFC8"/>
-                      </a:solidFill>
-                      <a:prstDash val="solid"/>
-                      <a:round/>
-                      <a:headEnd type="none" w="med" len="med"/>
-                      <a:tailEnd type="none" w="med" len="med"/>
-                    </a:lnR>
-                    <a:lnT w="9525" cap="flat" cmpd="sng" algn="ctr">
-                      <a:solidFill>
-                        <a:srgbClr val="EADFC8"/>
-                      </a:solidFill>
-                      <a:prstDash val="solid"/>
-                      <a:round/>
-                      <a:headEnd type="none" w="med" len="med"/>
-                      <a:tailEnd type="none" w="med" len="med"/>
-                    </a:lnT>
-                    <a:lnB w="9525" cap="flat" cmpd="sng" algn="ctr">
-                      <a:solidFill>
-                        <a:srgbClr val="EADFC8"/>
-                      </a:solidFill>
-                      <a:prstDash val="solid"/>
-                      <a:round/>
-                      <a:headEnd type="none" w="med" len="med"/>
-                      <a:tailEnd type="none" w="med" len="med"/>
-                    </a:lnB>
-                    <a:solidFill>
-                      <a:schemeClr val="accent1"/>
-                    </a:solidFill>
-                  </a:tcPr>
-                </a:tc>
-              </a:tr>
-              <a:tr h="411480">
-                <a:tc>
-                  <a:txBody>
-                    <a:bodyPr/>
-                    <a:lstStyle/>
-                    <a:p>
-                      <a:pPr indent="0" marL="0">
-                        <a:buNone/>
-                      </a:pPr>
-                      <a:r>
-                        <a:rPr lang="en-US" sz="1300" dirty="0">
+                        <a:rPr lang="en-US" sz="1100" dirty="0">
                           <a:solidFill>
                             <a:schemeClr val="tx1"/>
                           </a:solidFill>
                         </a:rPr>
-                        <a:t>早餐店及面点门店</a:t>
+                        <a:t>美宜佳（福建）1,300 · 见福（福建）1,000 · 罗森（广东）300 · 邻几（福建）150 · 十分（厦门）105 · 罗森（福建）100 · 7-ELEVEN（福建）100</a:t>
                       </a:r>
-                      <a:endParaRPr lang="en-US" sz="1300" dirty="0"/>
+                      <a:endParaRPr lang="en-US" sz="1100" dirty="0"/>
                     </a:p>
                   </a:txBody>
-                  <a:tcPr marL="109728" marR="109728" marT="0" marB="0" anchor="ctr">
+                  <a:tcPr marL="91440" marR="91440" marT="0" marB="0" anchor="ctr">
                     <a:lnL w="9525" cap="flat" cmpd="sng" algn="ctr">
                       <a:solidFill>
                         <a:srgbClr val="EADFC8"/>
@@ -8466,17 +8436,80 @@
                         <a:buNone/>
                       </a:pPr>
                       <a:r>
-                        <a:rPr lang="en-US" sz="1300" dirty="0">
+                        <a:rPr lang="en-US" sz="1200" b="1" dirty="0">
                           <a:solidFill>
-                            <a:schemeClr val="accent5"/>
+                            <a:schemeClr val="tx1"/>
                           </a:solidFill>
                         </a:rPr>
-                        <a:t>待填</a:t>
+                        <a:t>2,980</a:t>
                       </a:r>
-                      <a:endParaRPr lang="en-US" sz="1300" dirty="0"/>
+                      <a:endParaRPr lang="en-US" sz="1200" dirty="0"/>
                     </a:p>
                   </a:txBody>
-                  <a:tcPr marL="109728" marR="109728" marT="0" marB="0" anchor="ctr">
+                  <a:tcPr marL="91440" marR="91440" marT="0" marB="0" anchor="ctr">
+                    <a:lnL w="9525" cap="flat" cmpd="sng" algn="ctr">
+                      <a:solidFill>
+                        <a:srgbClr val="EADFC8"/>
+                      </a:solidFill>
+                      <a:prstDash val="solid"/>
+                      <a:round/>
+                      <a:headEnd type="none" w="med" len="med"/>
+                      <a:tailEnd type="none" w="med" len="med"/>
+                    </a:lnL>
+                    <a:lnR w="9525" cap="flat" cmpd="sng" algn="ctr">
+                      <a:solidFill>
+                        <a:srgbClr val="EADFC8"/>
+                      </a:solidFill>
+                      <a:prstDash val="solid"/>
+                      <a:round/>
+                      <a:headEnd type="none" w="med" len="med"/>
+                      <a:tailEnd type="none" w="med" len="med"/>
+                    </a:lnR>
+                    <a:lnT w="9525" cap="flat" cmpd="sng" algn="ctr">
+                      <a:solidFill>
+                        <a:srgbClr val="EADFC8"/>
+                      </a:solidFill>
+                      <a:prstDash val="solid"/>
+                      <a:round/>
+                      <a:headEnd type="none" w="med" len="med"/>
+                      <a:tailEnd type="none" w="med" len="med"/>
+                    </a:lnT>
+                    <a:lnB w="9525" cap="flat" cmpd="sng" algn="ctr">
+                      <a:solidFill>
+                        <a:srgbClr val="EADFC8"/>
+                      </a:solidFill>
+                      <a:prstDash val="solid"/>
+                      <a:round/>
+                      <a:headEnd type="none" w="med" len="med"/>
+                      <a:tailEnd type="none" w="med" len="med"/>
+                    </a:lnB>
+                    <a:solidFill>
+                      <a:schemeClr val="bg1"/>
+                    </a:solidFill>
+                  </a:tcPr>
+                </a:tc>
+              </a:tr>
+              <a:tr h="384048">
+                <a:tc>
+                  <a:txBody>
+                    <a:bodyPr/>
+                    <a:lstStyle/>
+                    <a:p>
+                      <a:pPr indent="0" marL="0">
+                        <a:buNone/>
+                      </a:pPr>
+                      <a:r>
+                        <a:rPr lang="en-US" sz="1200" b="1" dirty="0">
+                          <a:solidFill>
+                            <a:schemeClr val="tx1"/>
+                          </a:solidFill>
+                        </a:rPr>
+                        <a:t>卖场</a:t>
+                      </a:r>
+                      <a:endParaRPr lang="en-US" sz="1200" dirty="0"/>
+                    </a:p>
+                  </a:txBody>
+                  <a:tcPr marL="91440" marR="91440" marT="0" marB="0" anchor="ctr">
                     <a:lnL w="9525" cap="flat" cmpd="sng" algn="ctr">
                       <a:solidFill>
                         <a:srgbClr val="EADFC8"/>
@@ -8527,80 +8560,17 @@
                         <a:buNone/>
                       </a:pPr>
                       <a:r>
-                        <a:rPr lang="en-US" sz="1300" dirty="0">
+                        <a:rPr lang="en-US" sz="1100" dirty="0">
                           <a:solidFill>
                             <a:schemeClr val="tx1"/>
                           </a:solidFill>
                         </a:rPr>
-                        <a:t>现做现售终端</a:t>
+                        <a:t>天虹 8 · 乐海 8 · 世纪汇鲜 3 · 人人乐 1</a:t>
                       </a:r>
-                      <a:endParaRPr lang="en-US" sz="1300" dirty="0"/>
+                      <a:endParaRPr lang="en-US" sz="1100" dirty="0"/>
                     </a:p>
                   </a:txBody>
-                  <a:tcPr marL="109728" marR="109728" marT="0" marB="0" anchor="ctr">
-                    <a:lnL w="9525" cap="flat" cmpd="sng" algn="ctr">
-                      <a:solidFill>
-                        <a:srgbClr val="EADFC8"/>
-                      </a:solidFill>
-                      <a:prstDash val="solid"/>
-                      <a:round/>
-                      <a:headEnd type="none" w="med" len="med"/>
-                      <a:tailEnd type="none" w="med" len="med"/>
-                    </a:lnL>
-                    <a:lnR w="9525" cap="flat" cmpd="sng" algn="ctr">
-                      <a:solidFill>
-                        <a:srgbClr val="EADFC8"/>
-                      </a:solidFill>
-                      <a:prstDash val="solid"/>
-                      <a:round/>
-                      <a:headEnd type="none" w="med" len="med"/>
-                      <a:tailEnd type="none" w="med" len="med"/>
-                    </a:lnR>
-                    <a:lnT w="9525" cap="flat" cmpd="sng" algn="ctr">
-                      <a:solidFill>
-                        <a:srgbClr val="EADFC8"/>
-                      </a:solidFill>
-                      <a:prstDash val="solid"/>
-                      <a:round/>
-                      <a:headEnd type="none" w="med" len="med"/>
-                      <a:tailEnd type="none" w="med" len="med"/>
-                    </a:lnT>
-                    <a:lnB w="9525" cap="flat" cmpd="sng" algn="ctr">
-                      <a:solidFill>
-                        <a:srgbClr val="EADFC8"/>
-                      </a:solidFill>
-                      <a:prstDash val="solid"/>
-                      <a:round/>
-                      <a:headEnd type="none" w="med" len="med"/>
-                      <a:tailEnd type="none" w="med" len="med"/>
-                    </a:lnB>
-                    <a:solidFill>
-                      <a:schemeClr val="bg1"/>
-                    </a:solidFill>
-                  </a:tcPr>
-                </a:tc>
-              </a:tr>
-              <a:tr h="411480">
-                <a:tc>
-                  <a:txBody>
-                    <a:bodyPr/>
-                    <a:lstStyle/>
-                    <a:p>
-                      <a:pPr indent="0" marL="0">
-                        <a:buNone/>
-                      </a:pPr>
-                      <a:r>
-                        <a:rPr lang="en-US" sz="1300" dirty="0">
-                          <a:solidFill>
-                            <a:schemeClr val="tx1"/>
-                          </a:solidFill>
-                        </a:rPr>
-                        <a:t>商超 / 农贸市场</a:t>
-                      </a:r>
-                      <a:endParaRPr lang="en-US" sz="1300" dirty="0"/>
-                    </a:p>
-                  </a:txBody>
-                  <a:tcPr marL="109728" marR="109728" marT="0" marB="0" anchor="ctr">
+                  <a:tcPr marL="91440" marR="91440" marT="0" marB="0" anchor="ctr">
                     <a:lnL w="9525" cap="flat" cmpd="sng" algn="ctr">
                       <a:solidFill>
                         <a:srgbClr val="EADFC8"/>
@@ -8651,17 +8621,80 @@
                         <a:buNone/>
                       </a:pPr>
                       <a:r>
-                        <a:rPr lang="en-US" sz="1300" dirty="0">
+                        <a:rPr lang="en-US" sz="1200" b="1" dirty="0">
                           <a:solidFill>
-                            <a:schemeClr val="accent5"/>
+                            <a:schemeClr val="tx1"/>
                           </a:solidFill>
                         </a:rPr>
-                        <a:t>待填</a:t>
+                        <a:t>20</a:t>
                       </a:r>
-                      <a:endParaRPr lang="en-US" sz="1300" dirty="0"/>
+                      <a:endParaRPr lang="en-US" sz="1200" dirty="0"/>
                     </a:p>
                   </a:txBody>
-                  <a:tcPr marL="109728" marR="109728" marT="0" marB="0" anchor="ctr">
+                  <a:tcPr marL="91440" marR="91440" marT="0" marB="0" anchor="ctr">
+                    <a:lnL w="9525" cap="flat" cmpd="sng" algn="ctr">
+                      <a:solidFill>
+                        <a:srgbClr val="EADFC8"/>
+                      </a:solidFill>
+                      <a:prstDash val="solid"/>
+                      <a:round/>
+                      <a:headEnd type="none" w="med" len="med"/>
+                      <a:tailEnd type="none" w="med" len="med"/>
+                    </a:lnL>
+                    <a:lnR w="9525" cap="flat" cmpd="sng" algn="ctr">
+                      <a:solidFill>
+                        <a:srgbClr val="EADFC8"/>
+                      </a:solidFill>
+                      <a:prstDash val="solid"/>
+                      <a:round/>
+                      <a:headEnd type="none" w="med" len="med"/>
+                      <a:tailEnd type="none" w="med" len="med"/>
+                    </a:lnR>
+                    <a:lnT w="9525" cap="flat" cmpd="sng" algn="ctr">
+                      <a:solidFill>
+                        <a:srgbClr val="EADFC8"/>
+                      </a:solidFill>
+                      <a:prstDash val="solid"/>
+                      <a:round/>
+                      <a:headEnd type="none" w="med" len="med"/>
+                      <a:tailEnd type="none" w="med" len="med"/>
+                    </a:lnT>
+                    <a:lnB w="9525" cap="flat" cmpd="sng" algn="ctr">
+                      <a:solidFill>
+                        <a:srgbClr val="EADFC8"/>
+                      </a:solidFill>
+                      <a:prstDash val="solid"/>
+                      <a:round/>
+                      <a:headEnd type="none" w="med" len="med"/>
+                      <a:tailEnd type="none" w="med" len="med"/>
+                    </a:lnB>
+                    <a:solidFill>
+                      <a:schemeClr val="bg1"/>
+                    </a:solidFill>
+                  </a:tcPr>
+                </a:tc>
+              </a:tr>
+              <a:tr h="384048">
+                <a:tc>
+                  <a:txBody>
+                    <a:bodyPr/>
+                    <a:lstStyle/>
+                    <a:p>
+                      <a:pPr indent="0" marL="0">
+                        <a:buNone/>
+                      </a:pPr>
+                      <a:r>
+                        <a:rPr lang="en-US" sz="1200" b="1" dirty="0">
+                          <a:solidFill>
+                            <a:schemeClr val="tx1"/>
+                          </a:solidFill>
+                        </a:rPr>
+                        <a:t>生鲜连锁</a:t>
+                      </a:r>
+                      <a:endParaRPr lang="en-US" sz="1200" dirty="0"/>
+                    </a:p>
+                  </a:txBody>
+                  <a:tcPr marL="91440" marR="91440" marT="0" marB="0" anchor="ctr">
                     <a:lnL w="9525" cap="flat" cmpd="sng" algn="ctr">
                       <a:solidFill>
                         <a:srgbClr val="EADFC8"/>
@@ -8712,80 +8745,17 @@
                         <a:buNone/>
                       </a:pPr>
                       <a:r>
-                        <a:rPr lang="en-US" sz="1300" dirty="0">
+                        <a:rPr lang="en-US" sz="1100" dirty="0">
                           <a:solidFill>
                             <a:schemeClr val="tx1"/>
                           </a:solidFill>
                         </a:rPr>
-                        <a:t>零售终端</a:t>
+                        <a:t>民兴 50 · 金红日 15 · 闽篮 12 · 集正 12 · 福鲜生 7 · 人和旺 6</a:t>
                       </a:r>
-                      <a:endParaRPr lang="en-US" sz="1300" dirty="0"/>
+                      <a:endParaRPr lang="en-US" sz="1100" dirty="0"/>
                     </a:p>
                   </a:txBody>
-                  <a:tcPr marL="109728" marR="109728" marT="0" marB="0" anchor="ctr">
-                    <a:lnL w="9525" cap="flat" cmpd="sng" algn="ctr">
-                      <a:solidFill>
-                        <a:srgbClr val="EADFC8"/>
-                      </a:solidFill>
-                      <a:prstDash val="solid"/>
-                      <a:round/>
-                      <a:headEnd type="none" w="med" len="med"/>
-                      <a:tailEnd type="none" w="med" len="med"/>
-                    </a:lnL>
-                    <a:lnR w="9525" cap="flat" cmpd="sng" algn="ctr">
-                      <a:solidFill>
-                        <a:srgbClr val="EADFC8"/>
-                      </a:solidFill>
-                      <a:prstDash val="solid"/>
-                      <a:round/>
-                      <a:headEnd type="none" w="med" len="med"/>
-                      <a:tailEnd type="none" w="med" len="med"/>
-                    </a:lnR>
-                    <a:lnT w="9525" cap="flat" cmpd="sng" algn="ctr">
-                      <a:solidFill>
-                        <a:srgbClr val="EADFC8"/>
-                      </a:solidFill>
-                      <a:prstDash val="solid"/>
-                      <a:round/>
-                      <a:headEnd type="none" w="med" len="med"/>
-                      <a:tailEnd type="none" w="med" len="med"/>
-                    </a:lnT>
-                    <a:lnB w="9525" cap="flat" cmpd="sng" algn="ctr">
-                      <a:solidFill>
-                        <a:srgbClr val="EADFC8"/>
-                      </a:solidFill>
-                      <a:prstDash val="solid"/>
-                      <a:round/>
-                      <a:headEnd type="none" w="med" len="med"/>
-                      <a:tailEnd type="none" w="med" len="med"/>
-                    </a:lnB>
-                    <a:solidFill>
-                      <a:schemeClr val="bg1"/>
-                    </a:solidFill>
-                  </a:tcPr>
-                </a:tc>
-              </a:tr>
-              <a:tr h="411480">
-                <a:tc>
-                  <a:txBody>
-                    <a:bodyPr/>
-                    <a:lstStyle/>
-                    <a:p>
-                      <a:pPr indent="0" marL="0">
-                        <a:buNone/>
-                      </a:pPr>
-                      <a:r>
-                        <a:rPr lang="en-US" sz="1300" dirty="0">
-                          <a:solidFill>
-                            <a:schemeClr val="tx1"/>
-                          </a:solidFill>
-                        </a:rPr>
-                        <a:t>团餐 / 单位食堂</a:t>
-                      </a:r>
-                      <a:endParaRPr lang="en-US" sz="1300" dirty="0"/>
-                    </a:p>
-                  </a:txBody>
-                  <a:tcPr marL="109728" marR="109728" marT="0" marB="0" anchor="ctr">
+                  <a:tcPr marL="91440" marR="91440" marT="0" marB="0" anchor="ctr">
                     <a:lnL w="9525" cap="flat" cmpd="sng" algn="ctr">
                       <a:solidFill>
                         <a:srgbClr val="EADFC8"/>
@@ -8836,17 +8806,80 @@
                         <a:buNone/>
                       </a:pPr>
                       <a:r>
-                        <a:rPr lang="en-US" sz="1300" dirty="0">
+                        <a:rPr lang="en-US" sz="1200" b="1" dirty="0">
                           <a:solidFill>
-                            <a:schemeClr val="accent5"/>
+                            <a:schemeClr val="tx1"/>
                           </a:solidFill>
                         </a:rPr>
-                        <a:t>待填</a:t>
+                        <a:t>102</a:t>
                       </a:r>
-                      <a:endParaRPr lang="en-US" sz="1300" dirty="0"/>
+                      <a:endParaRPr lang="en-US" sz="1200" dirty="0"/>
                     </a:p>
                   </a:txBody>
-                  <a:tcPr marL="109728" marR="109728" marT="0" marB="0" anchor="ctr">
+                  <a:tcPr marL="91440" marR="91440" marT="0" marB="0" anchor="ctr">
+                    <a:lnL w="9525" cap="flat" cmpd="sng" algn="ctr">
+                      <a:solidFill>
+                        <a:srgbClr val="EADFC8"/>
+                      </a:solidFill>
+                      <a:prstDash val="solid"/>
+                      <a:round/>
+                      <a:headEnd type="none" w="med" len="med"/>
+                      <a:tailEnd type="none" w="med" len="med"/>
+                    </a:lnL>
+                    <a:lnR w="9525" cap="flat" cmpd="sng" algn="ctr">
+                      <a:solidFill>
+                        <a:srgbClr val="EADFC8"/>
+                      </a:solidFill>
+                      <a:prstDash val="solid"/>
+                      <a:round/>
+                      <a:headEnd type="none" w="med" len="med"/>
+                      <a:tailEnd type="none" w="med" len="med"/>
+                    </a:lnR>
+                    <a:lnT w="9525" cap="flat" cmpd="sng" algn="ctr">
+                      <a:solidFill>
+                        <a:srgbClr val="EADFC8"/>
+                      </a:solidFill>
+                      <a:prstDash val="solid"/>
+                      <a:round/>
+                      <a:headEnd type="none" w="med" len="med"/>
+                      <a:tailEnd type="none" w="med" len="med"/>
+                    </a:lnT>
+                    <a:lnB w="9525" cap="flat" cmpd="sng" algn="ctr">
+                      <a:solidFill>
+                        <a:srgbClr val="EADFC8"/>
+                      </a:solidFill>
+                      <a:prstDash val="solid"/>
+                      <a:round/>
+                      <a:headEnd type="none" w="med" len="med"/>
+                      <a:tailEnd type="none" w="med" len="med"/>
+                    </a:lnB>
+                    <a:solidFill>
+                      <a:schemeClr val="bg1"/>
+                    </a:solidFill>
+                  </a:tcPr>
+                </a:tc>
+              </a:tr>
+              <a:tr h="384048">
+                <a:tc>
+                  <a:txBody>
+                    <a:bodyPr/>
+                    <a:lstStyle/>
+                    <a:p>
+                      <a:pPr indent="0" marL="0">
+                        <a:buNone/>
+                      </a:pPr>
+                      <a:r>
+                        <a:rPr lang="en-US" sz="1200" b="1" dirty="0">
+                          <a:solidFill>
+                            <a:schemeClr val="tx1"/>
+                          </a:solidFill>
+                        </a:rPr>
+                        <a:t>精品店</a:t>
+                      </a:r>
+                      <a:endParaRPr lang="en-US" sz="1200" dirty="0"/>
+                    </a:p>
+                  </a:txBody>
+                  <a:tcPr marL="91440" marR="91440" marT="0" marB="0" anchor="ctr">
                     <a:lnL w="9525" cap="flat" cmpd="sng" algn="ctr">
                       <a:solidFill>
                         <a:srgbClr val="EADFC8"/>
@@ -8897,80 +8930,17 @@
                         <a:buNone/>
                       </a:pPr>
                       <a:r>
-                        <a:rPr lang="en-US" sz="1300" dirty="0">
+                        <a:rPr lang="en-US" sz="1100" dirty="0">
                           <a:solidFill>
                             <a:schemeClr val="tx1"/>
                           </a:solidFill>
                         </a:rPr>
-                        <a:t>集中采购终端</a:t>
+                        <a:t>元初 181 · 美岁 10 · 千滋百味 9</a:t>
                       </a:r>
-                      <a:endParaRPr lang="en-US" sz="1300" dirty="0"/>
+                      <a:endParaRPr lang="en-US" sz="1100" dirty="0"/>
                     </a:p>
                   </a:txBody>
-                  <a:tcPr marL="109728" marR="109728" marT="0" marB="0" anchor="ctr">
-                    <a:lnL w="9525" cap="flat" cmpd="sng" algn="ctr">
-                      <a:solidFill>
-                        <a:srgbClr val="EADFC8"/>
-                      </a:solidFill>
-                      <a:prstDash val="solid"/>
-                      <a:round/>
-                      <a:headEnd type="none" w="med" len="med"/>
-                      <a:tailEnd type="none" w="med" len="med"/>
-                    </a:lnL>
-                    <a:lnR w="9525" cap="flat" cmpd="sng" algn="ctr">
-                      <a:solidFill>
-                        <a:srgbClr val="EADFC8"/>
-                      </a:solidFill>
-                      <a:prstDash val="solid"/>
-                      <a:round/>
-                      <a:headEnd type="none" w="med" len="med"/>
-                      <a:tailEnd type="none" w="med" len="med"/>
-                    </a:lnR>
-                    <a:lnT w="9525" cap="flat" cmpd="sng" algn="ctr">
-                      <a:solidFill>
-                        <a:srgbClr val="EADFC8"/>
-                      </a:solidFill>
-                      <a:prstDash val="solid"/>
-                      <a:round/>
-                      <a:headEnd type="none" w="med" len="med"/>
-                      <a:tailEnd type="none" w="med" len="med"/>
-                    </a:lnT>
-                    <a:lnB w="9525" cap="flat" cmpd="sng" algn="ctr">
-                      <a:solidFill>
-                        <a:srgbClr val="EADFC8"/>
-                      </a:solidFill>
-                      <a:prstDash val="solid"/>
-                      <a:round/>
-                      <a:headEnd type="none" w="med" len="med"/>
-                      <a:tailEnd type="none" w="med" len="med"/>
-                    </a:lnB>
-                    <a:solidFill>
-                      <a:schemeClr val="bg1"/>
-                    </a:solidFill>
-                  </a:tcPr>
-                </a:tc>
-              </a:tr>
-              <a:tr h="411480">
-                <a:tc>
-                  <a:txBody>
-                    <a:bodyPr/>
-                    <a:lstStyle/>
-                    <a:p>
-                      <a:pPr indent="0" marL="0">
-                        <a:buNone/>
-                      </a:pPr>
-                      <a:r>
-                        <a:rPr lang="en-US" sz="1300" dirty="0">
-                          <a:solidFill>
-                            <a:schemeClr val="tx1"/>
-                          </a:solidFill>
-                        </a:rPr>
-                        <a:t>其他</a:t>
-                      </a:r>
-                      <a:endParaRPr lang="en-US" sz="1300" dirty="0"/>
-                    </a:p>
-                  </a:txBody>
-                  <a:tcPr marL="109728" marR="109728" marT="0" marB="0" anchor="ctr">
+                  <a:tcPr marL="91440" marR="91440" marT="0" marB="0" anchor="ctr">
                     <a:lnL w="9525" cap="flat" cmpd="sng" algn="ctr">
                       <a:solidFill>
                         <a:srgbClr val="EADFC8"/>
@@ -9021,17 +8991,80 @@
                         <a:buNone/>
                       </a:pPr>
                       <a:r>
-                        <a:rPr lang="en-US" sz="1300" dirty="0">
+                        <a:rPr lang="en-US" sz="1200" b="1" dirty="0">
                           <a:solidFill>
-                            <a:schemeClr val="accent5"/>
+                            <a:schemeClr val="tx1"/>
                           </a:solidFill>
                         </a:rPr>
-                        <a:t>待填</a:t>
+                        <a:t>200</a:t>
                       </a:r>
-                      <a:endParaRPr lang="en-US" sz="1300" dirty="0"/>
+                      <a:endParaRPr lang="en-US" sz="1200" dirty="0"/>
                     </a:p>
                   </a:txBody>
-                  <a:tcPr marL="109728" marR="109728" marT="0" marB="0" anchor="ctr">
+                  <a:tcPr marL="91440" marR="91440" marT="0" marB="0" anchor="ctr">
+                    <a:lnL w="9525" cap="flat" cmpd="sng" algn="ctr">
+                      <a:solidFill>
+                        <a:srgbClr val="EADFC8"/>
+                      </a:solidFill>
+                      <a:prstDash val="solid"/>
+                      <a:round/>
+                      <a:headEnd type="none" w="med" len="med"/>
+                      <a:tailEnd type="none" w="med" len="med"/>
+                    </a:lnL>
+                    <a:lnR w="9525" cap="flat" cmpd="sng" algn="ctr">
+                      <a:solidFill>
+                        <a:srgbClr val="EADFC8"/>
+                      </a:solidFill>
+                      <a:prstDash val="solid"/>
+                      <a:round/>
+                      <a:headEnd type="none" w="med" len="med"/>
+                      <a:tailEnd type="none" w="med" len="med"/>
+                    </a:lnR>
+                    <a:lnT w="9525" cap="flat" cmpd="sng" algn="ctr">
+                      <a:solidFill>
+                        <a:srgbClr val="EADFC8"/>
+                      </a:solidFill>
+                      <a:prstDash val="solid"/>
+                      <a:round/>
+                      <a:headEnd type="none" w="med" len="med"/>
+                      <a:tailEnd type="none" w="med" len="med"/>
+                    </a:lnT>
+                    <a:lnB w="9525" cap="flat" cmpd="sng" algn="ctr">
+                      <a:solidFill>
+                        <a:srgbClr val="EADFC8"/>
+                      </a:solidFill>
+                      <a:prstDash val="solid"/>
+                      <a:round/>
+                      <a:headEnd type="none" w="med" len="med"/>
+                      <a:tailEnd type="none" w="med" len="med"/>
+                    </a:lnB>
+                    <a:solidFill>
+                      <a:schemeClr val="bg1"/>
+                    </a:solidFill>
+                  </a:tcPr>
+                </a:tc>
+              </a:tr>
+              <a:tr h="384048">
+                <a:tc>
+                  <a:txBody>
+                    <a:bodyPr/>
+                    <a:lstStyle/>
+                    <a:p>
+                      <a:pPr indent="0" marL="0">
+                        <a:buNone/>
+                      </a:pPr>
+                      <a:r>
+                        <a:rPr lang="en-US" sz="1200" b="1" dirty="0">
+                          <a:solidFill>
+                            <a:schemeClr val="tx1"/>
+                          </a:solidFill>
+                        </a:rPr>
+                        <a:t>面包连锁</a:t>
+                      </a:r>
+                      <a:endParaRPr lang="en-US" sz="1200" dirty="0"/>
+                    </a:p>
+                  </a:txBody>
+                  <a:tcPr marL="91440" marR="91440" marT="0" marB="0" anchor="ctr">
                     <a:lnL w="9525" cap="flat" cmpd="sng" algn="ctr">
                       <a:solidFill>
                         <a:srgbClr val="EADFC8"/>
@@ -9082,80 +9115,17 @@
                         <a:buNone/>
                       </a:pPr>
                       <a:r>
-                        <a:rPr lang="en-US" sz="1300" dirty="0">
+                        <a:rPr lang="en-US" sz="1100" dirty="0">
                           <a:solidFill>
                             <a:schemeClr val="tx1"/>
                           </a:solidFill>
                         </a:rPr>
-                        <a:t>—</a:t>
+                        <a:t>安德鲁森（厦门）150 · 澳联 80</a:t>
                       </a:r>
-                      <a:endParaRPr lang="en-US" sz="1300" dirty="0"/>
+                      <a:endParaRPr lang="en-US" sz="1100" dirty="0"/>
                     </a:p>
                   </a:txBody>
-                  <a:tcPr marL="109728" marR="109728" marT="0" marB="0" anchor="ctr">
-                    <a:lnL w="9525" cap="flat" cmpd="sng" algn="ctr">
-                      <a:solidFill>
-                        <a:srgbClr val="EADFC8"/>
-                      </a:solidFill>
-                      <a:prstDash val="solid"/>
-                      <a:round/>
-                      <a:headEnd type="none" w="med" len="med"/>
-                      <a:tailEnd type="none" w="med" len="med"/>
-                    </a:lnL>
-                    <a:lnR w="9525" cap="flat" cmpd="sng" algn="ctr">
-                      <a:solidFill>
-                        <a:srgbClr val="EADFC8"/>
-                      </a:solidFill>
-                      <a:prstDash val="solid"/>
-                      <a:round/>
-                      <a:headEnd type="none" w="med" len="med"/>
-                      <a:tailEnd type="none" w="med" len="med"/>
-                    </a:lnR>
-                    <a:lnT w="9525" cap="flat" cmpd="sng" algn="ctr">
-                      <a:solidFill>
-                        <a:srgbClr val="EADFC8"/>
-                      </a:solidFill>
-                      <a:prstDash val="solid"/>
-                      <a:round/>
-                      <a:headEnd type="none" w="med" len="med"/>
-                      <a:tailEnd type="none" w="med" len="med"/>
-                    </a:lnT>
-                    <a:lnB w="9525" cap="flat" cmpd="sng" algn="ctr">
-                      <a:solidFill>
-                        <a:srgbClr val="EADFC8"/>
-                      </a:solidFill>
-                      <a:prstDash val="solid"/>
-                      <a:round/>
-                      <a:headEnd type="none" w="med" len="med"/>
-                      <a:tailEnd type="none" w="med" len="med"/>
-                    </a:lnB>
-                    <a:solidFill>
-                      <a:schemeClr val="bg1"/>
-                    </a:solidFill>
-                  </a:tcPr>
-                </a:tc>
-              </a:tr>
-              <a:tr h="411480">
-                <a:tc>
-                  <a:txBody>
-                    <a:bodyPr/>
-                    <a:lstStyle/>
-                    <a:p>
-                      <a:pPr indent="0" marL="0">
-                        <a:buNone/>
-                      </a:pPr>
-                      <a:r>
-                        <a:rPr lang="en-US" sz="1300" b="1" dirty="0">
-                          <a:solidFill>
-                            <a:schemeClr val="tx1"/>
-                          </a:solidFill>
-                        </a:rPr>
-                        <a:t>合计</a:t>
-                      </a:r>
-                      <a:endParaRPr lang="en-US" sz="1300" dirty="0"/>
-                    </a:p>
-                  </a:txBody>
-                  <a:tcPr marL="109728" marR="109728" marT="0" marB="0" anchor="ctr">
+                  <a:tcPr marL="91440" marR="91440" marT="0" marB="0" anchor="ctr">
                     <a:lnL w="9525" cap="flat" cmpd="sng" algn="ctr">
                       <a:solidFill>
                         <a:srgbClr val="EADFC8"/>
@@ -9206,17 +9176,80 @@
                         <a:buNone/>
                       </a:pPr>
                       <a:r>
-                        <a:rPr lang="en-US" sz="1300" b="1" dirty="0">
+                        <a:rPr lang="en-US" sz="1200" b="1" dirty="0">
                           <a:solidFill>
                             <a:schemeClr val="tx1"/>
                           </a:solidFill>
                         </a:rPr>
-                        <a:t>3,719</a:t>
+                        <a:t>230</a:t>
                       </a:r>
-                      <a:endParaRPr lang="en-US" sz="1300" dirty="0"/>
+                      <a:endParaRPr lang="en-US" sz="1200" dirty="0"/>
                     </a:p>
                   </a:txBody>
-                  <a:tcPr marL="109728" marR="109728" marT="0" marB="0" anchor="ctr">
+                  <a:tcPr marL="91440" marR="91440" marT="0" marB="0" anchor="ctr">
+                    <a:lnL w="9525" cap="flat" cmpd="sng" algn="ctr">
+                      <a:solidFill>
+                        <a:srgbClr val="EADFC8"/>
+                      </a:solidFill>
+                      <a:prstDash val="solid"/>
+                      <a:round/>
+                      <a:headEnd type="none" w="med" len="med"/>
+                      <a:tailEnd type="none" w="med" len="med"/>
+                    </a:lnL>
+                    <a:lnR w="9525" cap="flat" cmpd="sng" algn="ctr">
+                      <a:solidFill>
+                        <a:srgbClr val="EADFC8"/>
+                      </a:solidFill>
+                      <a:prstDash val="solid"/>
+                      <a:round/>
+                      <a:headEnd type="none" w="med" len="med"/>
+                      <a:tailEnd type="none" w="med" len="med"/>
+                    </a:lnR>
+                    <a:lnT w="9525" cap="flat" cmpd="sng" algn="ctr">
+                      <a:solidFill>
+                        <a:srgbClr val="EADFC8"/>
+                      </a:solidFill>
+                      <a:prstDash val="solid"/>
+                      <a:round/>
+                      <a:headEnd type="none" w="med" len="med"/>
+                      <a:tailEnd type="none" w="med" len="med"/>
+                    </a:lnT>
+                    <a:lnB w="9525" cap="flat" cmpd="sng" algn="ctr">
+                      <a:solidFill>
+                        <a:srgbClr val="EADFC8"/>
+                      </a:solidFill>
+                      <a:prstDash val="solid"/>
+                      <a:round/>
+                      <a:headEnd type="none" w="med" len="med"/>
+                      <a:tailEnd type="none" w="med" len="med"/>
+                    </a:lnB>
+                    <a:solidFill>
+                      <a:schemeClr val="bg1"/>
+                    </a:solidFill>
+                  </a:tcPr>
+                </a:tc>
+              </a:tr>
+              <a:tr h="384048">
+                <a:tc>
+                  <a:txBody>
+                    <a:bodyPr/>
+                    <a:lstStyle/>
+                    <a:p>
+                      <a:pPr indent="0" marL="0">
+                        <a:buNone/>
+                      </a:pPr>
+                      <a:r>
+                        <a:rPr lang="en-US" sz="1200" b="1" dirty="0">
+                          <a:solidFill>
+                            <a:schemeClr val="tx1"/>
+                          </a:solidFill>
+                        </a:rPr>
+                        <a:t>中专大学</a:t>
+                      </a:r>
+                      <a:endParaRPr lang="en-US" sz="1200" dirty="0"/>
+                    </a:p>
+                  </a:txBody>
+                  <a:tcPr marL="91440" marR="91440" marT="0" marB="0" anchor="ctr">
                     <a:lnL w="9525" cap="flat" cmpd="sng" algn="ctr">
                       <a:solidFill>
                         <a:srgbClr val="EADFC8"/>
@@ -9267,17 +9300,17 @@
                         <a:buNone/>
                       </a:pPr>
                       <a:r>
-                        <a:rPr lang="en-US" sz="1300" dirty="0">
+                        <a:rPr lang="en-US" sz="1100" dirty="0">
                           <a:solidFill>
-                            <a:schemeClr val="tx2"/>
+                            <a:schemeClr val="tx1"/>
                           </a:solidFill>
                         </a:rPr>
-                        <a:t>未去重</a:t>
+                        <a:t>鹭银海 20 · 鸿润福 8 · 可思汉 6</a:t>
                       </a:r>
-                      <a:endParaRPr lang="en-US" sz="1300" dirty="0"/>
+                      <a:endParaRPr lang="en-US" sz="1100" dirty="0"/>
                     </a:p>
                   </a:txBody>
-                  <a:tcPr marL="109728" marR="109728" marT="0" marB="0" anchor="ctr">
+                  <a:tcPr marL="91440" marR="91440" marT="0" marB="0" anchor="ctr">
                     <a:lnL w="9525" cap="flat" cmpd="sng" algn="ctr">
                       <a:solidFill>
                         <a:srgbClr val="EADFC8"/>
@@ -9316,6 +9349,437 @@
                     </a:lnB>
                     <a:solidFill>
                       <a:schemeClr val="bg1"/>
+                    </a:solidFill>
+                  </a:tcPr>
+                </a:tc>
+                <a:tc>
+                  <a:txBody>
+                    <a:bodyPr/>
+                    <a:lstStyle/>
+                    <a:p>
+                      <a:pPr algn="r" indent="0" marL="0">
+                        <a:buNone/>
+                      </a:pPr>
+                      <a:r>
+                        <a:rPr lang="en-US" sz="1200" b="1" dirty="0">
+                          <a:solidFill>
+                            <a:schemeClr val="tx1"/>
+                          </a:solidFill>
+                        </a:rPr>
+                        <a:t>35</a:t>
+                      </a:r>
+                      <a:endParaRPr lang="en-US" sz="1200" dirty="0"/>
+                    </a:p>
+                  </a:txBody>
+                  <a:tcPr marL="91440" marR="91440" marT="0" marB="0" anchor="ctr">
+                    <a:lnL w="9525" cap="flat" cmpd="sng" algn="ctr">
+                      <a:solidFill>
+                        <a:srgbClr val="EADFC8"/>
+                      </a:solidFill>
+                      <a:prstDash val="solid"/>
+                      <a:round/>
+                      <a:headEnd type="none" w="med" len="med"/>
+                      <a:tailEnd type="none" w="med" len="med"/>
+                    </a:lnL>
+                    <a:lnR w="9525" cap="flat" cmpd="sng" algn="ctr">
+                      <a:solidFill>
+                        <a:srgbClr val="EADFC8"/>
+                      </a:solidFill>
+                      <a:prstDash val="solid"/>
+                      <a:round/>
+                      <a:headEnd type="none" w="med" len="med"/>
+                      <a:tailEnd type="none" w="med" len="med"/>
+                    </a:lnR>
+                    <a:lnT w="9525" cap="flat" cmpd="sng" algn="ctr">
+                      <a:solidFill>
+                        <a:srgbClr val="EADFC8"/>
+                      </a:solidFill>
+                      <a:prstDash val="solid"/>
+                      <a:round/>
+                      <a:headEnd type="none" w="med" len="med"/>
+                      <a:tailEnd type="none" w="med" len="med"/>
+                    </a:lnT>
+                    <a:lnB w="9525" cap="flat" cmpd="sng" algn="ctr">
+                      <a:solidFill>
+                        <a:srgbClr val="EADFC8"/>
+                      </a:solidFill>
+                      <a:prstDash val="solid"/>
+                      <a:round/>
+                      <a:headEnd type="none" w="med" len="med"/>
+                      <a:tailEnd type="none" w="med" len="med"/>
+                    </a:lnB>
+                    <a:solidFill>
+                      <a:schemeClr val="bg1"/>
+                    </a:solidFill>
+                  </a:tcPr>
+                </a:tc>
+              </a:tr>
+              <a:tr h="384048">
+                <a:tc>
+                  <a:txBody>
+                    <a:bodyPr/>
+                    <a:lstStyle/>
+                    <a:p>
+                      <a:pPr indent="0" marL="0">
+                        <a:buNone/>
+                      </a:pPr>
+                      <a:r>
+                        <a:rPr lang="en-US" sz="1200" b="1" dirty="0">
+                          <a:solidFill>
+                            <a:schemeClr val="tx1"/>
+                          </a:solidFill>
+                        </a:rPr>
+                        <a:t>二批</a:t>
+                      </a:r>
+                      <a:endParaRPr lang="en-US" sz="1200" dirty="0"/>
+                    </a:p>
+                  </a:txBody>
+                  <a:tcPr marL="91440" marR="91440" marT="0" marB="0" anchor="ctr">
+                    <a:lnL w="9525" cap="flat" cmpd="sng" algn="ctr">
+                      <a:solidFill>
+                        <a:srgbClr val="EADFC8"/>
+                      </a:solidFill>
+                      <a:prstDash val="solid"/>
+                      <a:round/>
+                      <a:headEnd type="none" w="med" len="med"/>
+                      <a:tailEnd type="none" w="med" len="med"/>
+                    </a:lnL>
+                    <a:lnR w="9525" cap="flat" cmpd="sng" algn="ctr">
+                      <a:solidFill>
+                        <a:srgbClr val="EADFC8"/>
+                      </a:solidFill>
+                      <a:prstDash val="solid"/>
+                      <a:round/>
+                      <a:headEnd type="none" w="med" len="med"/>
+                      <a:tailEnd type="none" w="med" len="med"/>
+                    </a:lnR>
+                    <a:lnT w="9525" cap="flat" cmpd="sng" algn="ctr">
+                      <a:solidFill>
+                        <a:srgbClr val="EADFC8"/>
+                      </a:solidFill>
+                      <a:prstDash val="solid"/>
+                      <a:round/>
+                      <a:headEnd type="none" w="med" len="med"/>
+                      <a:tailEnd type="none" w="med" len="med"/>
+                    </a:lnT>
+                    <a:lnB w="9525" cap="flat" cmpd="sng" algn="ctr">
+                      <a:solidFill>
+                        <a:srgbClr val="EADFC8"/>
+                      </a:solidFill>
+                      <a:prstDash val="solid"/>
+                      <a:round/>
+                      <a:headEnd type="none" w="med" len="med"/>
+                      <a:tailEnd type="none" w="med" len="med"/>
+                    </a:lnB>
+                    <a:solidFill>
+                      <a:schemeClr val="bg1"/>
+                    </a:solidFill>
+                  </a:tcPr>
+                </a:tc>
+                <a:tc>
+                  <a:txBody>
+                    <a:bodyPr/>
+                    <a:lstStyle/>
+                    <a:p>
+                      <a:pPr indent="0" marL="0">
+                        <a:buNone/>
+                      </a:pPr>
+                      <a:r>
+                        <a:rPr lang="en-US" sz="1100" dirty="0">
+                          <a:solidFill>
+                            <a:schemeClr val="tx1"/>
+                          </a:solidFill>
+                        </a:rPr>
+                        <a:t>百胜达、达昌隆等 13 · 恩记、钰信、云翔等 12</a:t>
+                      </a:r>
+                      <a:endParaRPr lang="en-US" sz="1100" dirty="0"/>
+                    </a:p>
+                  </a:txBody>
+                  <a:tcPr marL="91440" marR="91440" marT="0" marB="0" anchor="ctr">
+                    <a:lnL w="9525" cap="flat" cmpd="sng" algn="ctr">
+                      <a:solidFill>
+                        <a:srgbClr val="EADFC8"/>
+                      </a:solidFill>
+                      <a:prstDash val="solid"/>
+                      <a:round/>
+                      <a:headEnd type="none" w="med" len="med"/>
+                      <a:tailEnd type="none" w="med" len="med"/>
+                    </a:lnL>
+                    <a:lnR w="9525" cap="flat" cmpd="sng" algn="ctr">
+                      <a:solidFill>
+                        <a:srgbClr val="EADFC8"/>
+                      </a:solidFill>
+                      <a:prstDash val="solid"/>
+                      <a:round/>
+                      <a:headEnd type="none" w="med" len="med"/>
+                      <a:tailEnd type="none" w="med" len="med"/>
+                    </a:lnR>
+                    <a:lnT w="9525" cap="flat" cmpd="sng" algn="ctr">
+                      <a:solidFill>
+                        <a:srgbClr val="EADFC8"/>
+                      </a:solidFill>
+                      <a:prstDash val="solid"/>
+                      <a:round/>
+                      <a:headEnd type="none" w="med" len="med"/>
+                      <a:tailEnd type="none" w="med" len="med"/>
+                    </a:lnT>
+                    <a:lnB w="9525" cap="flat" cmpd="sng" algn="ctr">
+                      <a:solidFill>
+                        <a:srgbClr val="EADFC8"/>
+                      </a:solidFill>
+                      <a:prstDash val="solid"/>
+                      <a:round/>
+                      <a:headEnd type="none" w="med" len="med"/>
+                      <a:tailEnd type="none" w="med" len="med"/>
+                    </a:lnB>
+                    <a:solidFill>
+                      <a:schemeClr val="bg1"/>
+                    </a:solidFill>
+                  </a:tcPr>
+                </a:tc>
+                <a:tc>
+                  <a:txBody>
+                    <a:bodyPr/>
+                    <a:lstStyle/>
+                    <a:p>
+                      <a:pPr algn="r" indent="0" marL="0">
+                        <a:buNone/>
+                      </a:pPr>
+                      <a:r>
+                        <a:rPr lang="en-US" sz="1200" b="1" dirty="0">
+                          <a:solidFill>
+                            <a:schemeClr val="tx1"/>
+                          </a:solidFill>
+                        </a:rPr>
+                        <a:t>25</a:t>
+                      </a:r>
+                      <a:endParaRPr lang="en-US" sz="1200" dirty="0"/>
+                    </a:p>
+                  </a:txBody>
+                  <a:tcPr marL="91440" marR="91440" marT="0" marB="0" anchor="ctr">
+                    <a:lnL w="9525" cap="flat" cmpd="sng" algn="ctr">
+                      <a:solidFill>
+                        <a:srgbClr val="EADFC8"/>
+                      </a:solidFill>
+                      <a:prstDash val="solid"/>
+                      <a:round/>
+                      <a:headEnd type="none" w="med" len="med"/>
+                      <a:tailEnd type="none" w="med" len="med"/>
+                    </a:lnL>
+                    <a:lnR w="9525" cap="flat" cmpd="sng" algn="ctr">
+                      <a:solidFill>
+                        <a:srgbClr val="EADFC8"/>
+                      </a:solidFill>
+                      <a:prstDash val="solid"/>
+                      <a:round/>
+                      <a:headEnd type="none" w="med" len="med"/>
+                      <a:tailEnd type="none" w="med" len="med"/>
+                    </a:lnR>
+                    <a:lnT w="9525" cap="flat" cmpd="sng" algn="ctr">
+                      <a:solidFill>
+                        <a:srgbClr val="EADFC8"/>
+                      </a:solidFill>
+                      <a:prstDash val="solid"/>
+                      <a:round/>
+                      <a:headEnd type="none" w="med" len="med"/>
+                      <a:tailEnd type="none" w="med" len="med"/>
+                    </a:lnT>
+                    <a:lnB w="9525" cap="flat" cmpd="sng" algn="ctr">
+                      <a:solidFill>
+                        <a:srgbClr val="EADFC8"/>
+                      </a:solidFill>
+                      <a:prstDash val="solid"/>
+                      <a:round/>
+                      <a:headEnd type="none" w="med" len="med"/>
+                      <a:tailEnd type="none" w="med" len="med"/>
+                    </a:lnB>
+                    <a:solidFill>
+                      <a:schemeClr val="bg1"/>
+                    </a:solidFill>
+                  </a:tcPr>
+                </a:tc>
+              </a:tr>
+              <a:tr h="384048">
+                <a:tc>
+                  <a:txBody>
+                    <a:bodyPr/>
+                    <a:lstStyle/>
+                    <a:p>
+                      <a:pPr indent="0" marL="0">
+                        <a:buNone/>
+                      </a:pPr>
+                      <a:r>
+                        <a:rPr lang="en-US" sz="1200" b="1" dirty="0">
+                          <a:solidFill>
+                            <a:schemeClr val="tx1"/>
+                          </a:solidFill>
+                        </a:rPr>
+                        <a:t>合计</a:t>
+                      </a:r>
+                      <a:endParaRPr lang="en-US" sz="1200" dirty="0"/>
+                    </a:p>
+                  </a:txBody>
+                  <a:tcPr marL="91440" marR="91440" marT="0" marB="0" anchor="ctr">
+                    <a:lnL w="9525" cap="flat" cmpd="sng" algn="ctr">
+                      <a:solidFill>
+                        <a:srgbClr val="EADFC8"/>
+                      </a:solidFill>
+                      <a:prstDash val="solid"/>
+                      <a:round/>
+                      <a:headEnd type="none" w="med" len="med"/>
+                      <a:tailEnd type="none" w="med" len="med"/>
+                    </a:lnL>
+                    <a:lnR w="9525" cap="flat" cmpd="sng" algn="ctr">
+                      <a:solidFill>
+                        <a:srgbClr val="EADFC8"/>
+                      </a:solidFill>
+                      <a:prstDash val="solid"/>
+                      <a:round/>
+                      <a:headEnd type="none" w="med" len="med"/>
+                      <a:tailEnd type="none" w="med" len="med"/>
+                    </a:lnR>
+                    <a:lnT w="9525" cap="flat" cmpd="sng" algn="ctr">
+                      <a:solidFill>
+                        <a:srgbClr val="EADFC8"/>
+                      </a:solidFill>
+                      <a:prstDash val="solid"/>
+                      <a:round/>
+                      <a:headEnd type="none" w="med" len="med"/>
+                      <a:tailEnd type="none" w="med" len="med"/>
+                    </a:lnT>
+                    <a:lnB w="9525" cap="flat" cmpd="sng" algn="ctr">
+                      <a:solidFill>
+                        <a:srgbClr val="EADFC8"/>
+                      </a:solidFill>
+                      <a:prstDash val="solid"/>
+                      <a:round/>
+                      <a:headEnd type="none" w="med" len="med"/>
+                      <a:tailEnd type="none" w="med" len="med"/>
+                    </a:lnB>
+                    <a:solidFill>
+                      <a:schemeClr val="accent4"/>
+                    </a:solidFill>
+                  </a:tcPr>
+                </a:tc>
+                <a:tc>
+                  <a:txBody>
+                    <a:bodyPr/>
+                    <a:lstStyle/>
+                    <a:p>
+                      <a:pPr indent="0" marL="0">
+                        <a:buNone/>
+                      </a:pPr>
+                      <a:r>
+                        <a:rPr lang="en-US" sz="1100" dirty="0">
+                          <a:solidFill>
+                            <a:schemeClr val="accent5"/>
+                          </a:solidFill>
+                        </a:rPr>
+                        <a:t>各类小计合计；原资料合计为 3,719，相差 127，待核对</a:t>
+                      </a:r>
+                      <a:endParaRPr lang="en-US" sz="1100" dirty="0"/>
+                    </a:p>
+                  </a:txBody>
+                  <a:tcPr marL="91440" marR="91440" marT="0" marB="0" anchor="ctr">
+                    <a:lnL w="9525" cap="flat" cmpd="sng" algn="ctr">
+                      <a:solidFill>
+                        <a:srgbClr val="EADFC8"/>
+                      </a:solidFill>
+                      <a:prstDash val="solid"/>
+                      <a:round/>
+                      <a:headEnd type="none" w="med" len="med"/>
+                      <a:tailEnd type="none" w="med" len="med"/>
+                    </a:lnL>
+                    <a:lnR w="9525" cap="flat" cmpd="sng" algn="ctr">
+                      <a:solidFill>
+                        <a:srgbClr val="EADFC8"/>
+                      </a:solidFill>
+                      <a:prstDash val="solid"/>
+                      <a:round/>
+                      <a:headEnd type="none" w="med" len="med"/>
+                      <a:tailEnd type="none" w="med" len="med"/>
+                    </a:lnR>
+                    <a:lnT w="9525" cap="flat" cmpd="sng" algn="ctr">
+                      <a:solidFill>
+                        <a:srgbClr val="EADFC8"/>
+                      </a:solidFill>
+                      <a:prstDash val="solid"/>
+                      <a:round/>
+                      <a:headEnd type="none" w="med" len="med"/>
+                      <a:tailEnd type="none" w="med" len="med"/>
+                    </a:lnT>
+                    <a:lnB w="9525" cap="flat" cmpd="sng" algn="ctr">
+                      <a:solidFill>
+                        <a:srgbClr val="EADFC8"/>
+                      </a:solidFill>
+                      <a:prstDash val="solid"/>
+                      <a:round/>
+                      <a:headEnd type="none" w="med" len="med"/>
+                      <a:tailEnd type="none" w="med" len="med"/>
+                    </a:lnB>
+                    <a:solidFill>
+                      <a:schemeClr val="accent4"/>
+                    </a:solidFill>
+                  </a:tcPr>
+                </a:tc>
+                <a:tc>
+                  <a:txBody>
+                    <a:bodyPr/>
+                    <a:lstStyle/>
+                    <a:p>
+                      <a:pPr algn="r" indent="0" marL="0">
+                        <a:buNone/>
+                      </a:pPr>
+                      <a:r>
+                        <a:rPr lang="en-US" sz="1200" b="1" dirty="0">
+                          <a:solidFill>
+                            <a:schemeClr val="tx1"/>
+                          </a:solidFill>
+                        </a:rPr>
+                        <a:t>3,592</a:t>
+                      </a:r>
+                      <a:endParaRPr lang="en-US" sz="1200" dirty="0"/>
+                    </a:p>
+                  </a:txBody>
+                  <a:tcPr marL="91440" marR="91440" marT="0" marB="0" anchor="ctr">
+                    <a:lnL w="9525" cap="flat" cmpd="sng" algn="ctr">
+                      <a:solidFill>
+                        <a:srgbClr val="EADFC8"/>
+                      </a:solidFill>
+                      <a:prstDash val="solid"/>
+                      <a:round/>
+                      <a:headEnd type="none" w="med" len="med"/>
+                      <a:tailEnd type="none" w="med" len="med"/>
+                    </a:lnL>
+                    <a:lnR w="9525" cap="flat" cmpd="sng" algn="ctr">
+                      <a:solidFill>
+                        <a:srgbClr val="EADFC8"/>
+                      </a:solidFill>
+                      <a:prstDash val="solid"/>
+                      <a:round/>
+                      <a:headEnd type="none" w="med" len="med"/>
+                      <a:tailEnd type="none" w="med" len="med"/>
+                    </a:lnR>
+                    <a:lnT w="9525" cap="flat" cmpd="sng" algn="ctr">
+                      <a:solidFill>
+                        <a:srgbClr val="EADFC8"/>
+                      </a:solidFill>
+                      <a:prstDash val="solid"/>
+                      <a:round/>
+                      <a:headEnd type="none" w="med" len="med"/>
+                      <a:tailEnd type="none" w="med" len="med"/>
+                    </a:lnT>
+                    <a:lnB w="9525" cap="flat" cmpd="sng" algn="ctr">
+                      <a:solidFill>
+                        <a:srgbClr val="EADFC8"/>
+                      </a:solidFill>
+                      <a:prstDash val="solid"/>
+                      <a:round/>
+                      <a:headEnd type="none" w="med" len="med"/>
+                      <a:tailEnd type="none" w="med" len="med"/>
+                    </a:lnB>
+                    <a:solidFill>
+                      <a:schemeClr val="accent4"/>
                     </a:solidFill>
                   </a:tcPr>
                 </a:tc>
@@ -9326,13 +9790,60 @@
       </p:graphicFrame>
       <p:sp>
         <p:nvSpPr>
-          <p:cNvPr id="20" name="Text 16"/>
+          <p:cNvPr id="17" name="Text 13"/>
           <p:cNvSpPr txBox="1"/>
           <p:nvPr/>
         </p:nvSpPr>
         <p:spPr>
           <a:xfrm>
-            <a:off x="548640" y="6053328"/>
+            <a:off x="3840480" y="5394960"/>
+            <a:ext cx="7772400" cy="320040"/>
+          </a:xfrm>
+          <a:prstGeom prst="rect">
+            <a:avLst/>
+          </a:prstGeom>
+          <a:noFill/>
+          <a:ln/>
+        </p:spPr>
+        <p:txBody>
+          <a:bodyPr wrap="square" lIns="0" tIns="0" rIns="0" bIns="0" rtlCol="0" anchor="t"/>
+          <a:lstStyle/>
+          <a:p>
+            <a:pPr indent="0" marL="0">
+              <a:buNone/>
+            </a:pPr>
+            <a:r>
+              <a:rPr lang="en-US" sz="1100" b="1" dirty="0">
+                <a:solidFill>
+                  <a:schemeClr val="accent5"/>
+                </a:solidFill>
+              </a:rPr>
+              <a:t>客户定位：</a:t>
+            </a:r>
+            <a:pPr indent="0" marL="0">
+              <a:buNone/>
+            </a:pPr>
+            <a:r>
+              <a:rPr lang="en-US" sz="1100" dirty="0">
+                <a:solidFill>
+                  <a:schemeClr val="tx1"/>
+                </a:solidFill>
+              </a:rPr>
+              <a:t>以上为馒头产品潜在终端渠道，非预拌粉直接客户；B2B 直接客户为原料经销商及馒头生产厂。</a:t>
+            </a:r>
+            <a:endParaRPr lang="en-US" sz="1100" dirty="0"/>
+          </a:p>
+        </p:txBody>
+      </p:sp>
+      <p:sp>
+        <p:nvSpPr>
+          <p:cNvPr id="18" name="Text 14"/>
+          <p:cNvSpPr txBox="1"/>
+          <p:nvPr/>
+        </p:nvSpPr>
+        <p:spPr>
+          <a:xfrm>
+            <a:off x="548640" y="5852160"/>
             <a:ext cx="11064240" cy="274320"/>
           </a:xfrm>
           <a:prstGeom prst="rect">
@@ -9354,7 +9865,7 @@
                   <a:schemeClr val="tx2"/>
                 </a:solidFill>
               </a:rPr>
-              <a:t>注：分类为建议框架，各类数量待合作伙伴提供明细后填入；据点数据未经去重、未确认进场，不代表已有客户或订单。</a:t>
+              <a:t>注：小计依原表；便利连锁明细合计 3,055（含罗森广东 300，非福建），与小计 2,980 不符；中专大学明细合计 34，与小计 35 不符。以上均待合作伙伴核对，未去重、未确认进场。</a:t>
             </a:r>
             <a:endParaRPr lang="en-US" sz="1000" dirty="0"/>
           </a:p>
@@ -12223,7 +12734,7 @@
             <a:avLst/>
           </a:prstGeom>
           <a:solidFill>
-            <a:srgbClr val="E6DCC6"/>
+            <a:srgbClr val="FFFFFF"/>
           </a:solidFill>
           <a:ln w="19050">
             <a:solidFill>
@@ -12335,7 +12846,7 @@
                   <a:schemeClr val="accent1"/>
                 </a:solidFill>
               </a:rPr>
-              <a:t>色系待确认</a:t>
+              <a:t>白色</a:t>
             </a:r>
             <a:endParaRPr lang="en-US" sz="1200" dirty="0"/>
           </a:p>

</xml_diff>

<commit_message>
DR-002: use partner channel table as source (total 3,592), drop 3,719
Co-Authored-By: Claude Opus 5.5 <noreply@anthropic.com>
Claude-Session: https://claude.ai/code/session_0137DxXVQUvWUjpTeTg3QLMn
</commit_message>
<xml_diff>
--- a/DR-002/DR-002_中粮海嘉五行预拌粉合作计划_V1.0.pptx
+++ b/DR-002/DR-002_中粮海嘉五行预拌粉合作计划_V1.0.pptx
@@ -120,44 +120,44 @@
   <p:extLst>
     <p:ext uri="{521415D9-36F7-43E2-AB2F-B90AF26B5E84}">
       <p14:sectionLst xmlns:p14="http://schemas.microsoft.com/office/powerpoint/2010/main">
-        <p14:section name="开篇" id="{b4b9687c-e152-5b57-c5ec-596f3f4f5d04}">
+        <p14:section name="开篇" id="{e387be06-75fb-0e5d-9d51-aafa7465c9b3}">
           <p14:sldIdLst>
             <p14:sldId id="256"/>
           </p14:sldIdLst>
         </p14:section>
-        <p14:section name="合作基础" id="{b15c7e50-474f-0815-b078-ea3b8ff480c8}">
+        <p14:section name="合作基础" id="{94e8e016-a2a2-7f2c-2966-480abbdf3503}">
           <p14:sldIdLst>
             <p14:sldId id="257"/>
             <p14:sldId id="258"/>
           </p14:sldIdLst>
         </p14:section>
-        <p14:section name="产品与模式" id="{af2488d6-4c99-57a2-6c39-5ac11627249d}">
+        <p14:section name="产品与模式" id="{1903e921-ed52-8e9f-1214-4eb95378a451}">
           <p14:sldIdLst>
             <p14:sldId id="259"/>
             <p14:sldId id="260"/>
             <p14:sldId id="261"/>
           </p14:sldIdLst>
         </p14:section>
-        <p14:section name="市场落地" id="{b690f230-459c-8e9e-8adc-fb7952c32538}">
+        <p14:section name="市场落地" id="{3776469d-b58c-c571-f142-38fcabebfc53}">
           <p14:sldIdLst>
             <p14:sldId id="262"/>
           </p14:sldIdLst>
         </p14:section>
-        <p14:section name="收益与财务" id="{cffdfe82-2868-3987-f474-fd5a6f65c4e7}">
+        <p14:section name="收益与财务" id="{043e74f4-d124-4f24-15cd-e2780fbef54a}">
           <p14:sldIdLst>
             <p14:sldId id="263"/>
             <p14:sldId id="264"/>
             <p14:sldId id="265"/>
           </p14:sldIdLst>
         </p14:section>
-        <p14:section name="行动计划" id="{55e5ddcf-f428-75a4-e284-10801fa839e4}">
+        <p14:section name="行动计划" id="{9c8cd32f-46f5-3c91-98a7-46781cf900db}">
           <p14:sldIdLst>
             <p14:sldId id="266"/>
             <p14:sldId id="267"/>
             <p14:sldId id="268"/>
           </p14:sldIdLst>
         </p14:section>
-        <p14:section name="附件" id="{044dc920-872f-a002-f6ea-9dd79b908aa3}">
+        <p14:section name="附件" id="{65072dff-8dc0-e9fb-a210-b19db8b276b5}">
           <p14:sldIdLst>
             <p14:sldId id="269"/>
           </p14:sldIdLst>
@@ -1285,7 +1285,7 @@
           <a:p>
             <a:r>
               <a:rPr lang="en-US" dirty="0"/>
-              <a:t>附件为合作伙伴提供的潜在终端渠道清单，含便利连锁、卖场、生鲜连锁、精品店、面包连锁、中专大学及二批。原资料合计3,719，各类小计合计3,592，明细与小计有不符之处，须核对。罗森（广东）300家不在福建。这些均为潜在终端渠道，不是预拌粉的B2B直接客户，尚未去重及确认进场。</a:t>
+              <a:t>附件依合作伙伴提供的渠道表：便利连锁2,980、卖场20、生鲜连锁102、精品店200、面包连锁230、中专大学35、二批25，合计3,592家。含罗森（广东）300家。均为潜在终端渠道，不是预拌粉的B2B直接客户，尚未去重及确认进场。</a:t>
             </a:r>
             <a:endParaRPr lang="en-US" dirty="0"/>
           </a:p>
@@ -1725,7 +1725,7 @@
           <a:p>
             <a:r>
               <a:rPr lang="en-US" dirty="0"/>
-              <a:t>产业链：预拌粉供应→原料经销商→馒头生产厂→终端渠道→消费者。B2B直接销售对象为原料经销商及馒头生产厂；福建3,719个据点属于潜在终端渠道资源，尚未去重及确认进场，不是直接客户。</a:t>
+              <a:t>产业链：预拌粉供应→原料经销商→馒头生产厂→终端渠道→消费者。B2B直接销售对象为原料经销商及馒头生产厂；附件所列3,592家门店属于潜在终端渠道资源，尚未去重及确认进场，不是直接客户。</a:t>
             </a:r>
             <a:endParaRPr lang="en-US" dirty="0"/>
           </a:p>
@@ -7826,7 +7826,7 @@
                   <a:schemeClr val="accent2"/>
                 </a:solidFill>
               </a:rPr>
-              <a:t>3,719</a:t>
+              <a:t>3,592</a:t>
             </a:r>
             <a:endParaRPr lang="en-US" sz="6000" dirty="0"/>
           </a:p>
@@ -7862,7 +7862,7 @@
                   <a:schemeClr val="bg1"/>
                 </a:solidFill>
               </a:rPr>
-              <a:t>原资料合计</a:t>
+              <a:t>家潜在终端门店</a:t>
             </a:r>
             <a:endParaRPr lang="en-US" sz="1400" dirty="0"/>
           </a:p>
@@ -7876,7 +7876,7 @@
                   <a:schemeClr val="bg1"/>
                 </a:solidFill>
               </a:rPr>
-              <a:t>潜在终端渠道据点</a:t>
+              <a:t>七类渠道合计</a:t>
             </a:r>
             <a:endParaRPr lang="en-US" sz="1400" dirty="0"/>
           </a:p>
@@ -9672,10 +9672,10 @@
                       <a:r>
                         <a:rPr lang="en-US" sz="1100" dirty="0">
                           <a:solidFill>
-                            <a:schemeClr val="accent5"/>
+                            <a:schemeClr val="tx1"/>
                           </a:solidFill>
                         </a:rPr>
-                        <a:t>各类小计合计；原资料合计为 3,719，相差 127，待核对</a:t>
+                        <a:t>七类渠道小计合计</a:t>
                       </a:r>
                       <a:endParaRPr lang="en-US" sz="1100" dirty="0"/>
                     </a:p>
@@ -9865,7 +9865,7 @@
                   <a:schemeClr val="tx2"/>
                 </a:solidFill>
               </a:rPr>
-              <a:t>注：小计依原表；便利连锁明细合计 3,055（含罗森广东 300，非福建），与小计 2,980 不符；中专大学明细合计 34，与小计 35 不符。以上均待合作伙伴核对，未去重、未确认进场。</a:t>
+              <a:t>注：数据依合作伙伴提供之渠道表，小计依原表；含罗森（广东）300家；部分品牌明细与小计略有差异，待核对；未去重、未确认进场。</a:t>
             </a:r>
             <a:endParaRPr lang="en-US" sz="1000" dirty="0"/>
           </a:p>

</xml_diff>

<commit_message>
DR-002: add SKU function directions to P04 with compliance note; refresh PPTX/PDF
Co-Authored-By: Claude Opus 5.5 <noreply@anthropic.com>
Claude-Session: https://claude.ai/code/session_0137DxXVQUvWUjpTeTg3QLMn
</commit_message>
<xml_diff>
--- a/DR-002/DR-002_中粮海嘉五行预拌粉合作计划_V1.0.pptx
+++ b/DR-002/DR-002_中粮海嘉五行预拌粉合作计划_V1.0.pptx
@@ -120,44 +120,44 @@
   <p:extLst>
     <p:ext uri="{521415D9-36F7-43E2-AB2F-B90AF26B5E84}">
       <p14:sectionLst xmlns:p14="http://schemas.microsoft.com/office/powerpoint/2010/main">
-        <p14:section name="开篇" id="{e387be06-75fb-0e5d-9d51-aafa7465c9b3}">
+        <p14:section name="开篇" id="{8366acdc-4112-517f-be5b-b3d5e52d7a1f}">
           <p14:sldIdLst>
             <p14:sldId id="256"/>
           </p14:sldIdLst>
         </p14:section>
-        <p14:section name="合作基础" id="{94e8e016-a2a2-7f2c-2966-480abbdf3503}">
+        <p14:section name="合作基础" id="{7b58d337-0e92-40d2-f33a-d38bf7c20b8f}">
           <p14:sldIdLst>
             <p14:sldId id="257"/>
             <p14:sldId id="258"/>
           </p14:sldIdLst>
         </p14:section>
-        <p14:section name="产品与模式" id="{1903e921-ed52-8e9f-1214-4eb95378a451}">
+        <p14:section name="产品与模式" id="{256ef605-132c-df2c-9329-c6447f13bae0}">
           <p14:sldIdLst>
             <p14:sldId id="259"/>
             <p14:sldId id="260"/>
             <p14:sldId id="261"/>
           </p14:sldIdLst>
         </p14:section>
-        <p14:section name="市场落地" id="{3776469d-b58c-c571-f142-38fcabebfc53}">
+        <p14:section name="市场落地" id="{34f8dddb-a7d8-c667-28b6-35c301ae3243}">
           <p14:sldIdLst>
             <p14:sldId id="262"/>
           </p14:sldIdLst>
         </p14:section>
-        <p14:section name="收益与财务" id="{043e74f4-d124-4f24-15cd-e2780fbef54a}">
+        <p14:section name="收益与财务" id="{b1f6307c-6199-310d-de13-bfd6674e483f}">
           <p14:sldIdLst>
             <p14:sldId id="263"/>
             <p14:sldId id="264"/>
             <p14:sldId id="265"/>
           </p14:sldIdLst>
         </p14:section>
-        <p14:section name="行动计划" id="{9c8cd32f-46f5-3c91-98a7-46781cf900db}">
+        <p14:section name="行动计划" id="{bae6fa1b-0285-1657-dc08-f1271b7c9ceb}">
           <p14:sldIdLst>
             <p14:sldId id="266"/>
             <p14:sldId id="267"/>
             <p14:sldId id="268"/>
           </p14:sldIdLst>
         </p14:section>
-        <p14:section name="附件" id="{65072dff-8dc0-e9fb-a210-b19db8b276b5}">
+        <p14:section name="附件" id="{91c2a5c6-138d-b616-c160-0c940ef10200}">
           <p14:sldIdLst>
             <p14:sldId id="269"/>
           </p14:sldIdLst>
@@ -1549,7 +1549,7 @@
           <a:p>
             <a:r>
               <a:rPr lang="en-US" dirty="0"/>
-              <a:t>宽瑜膳元五行系列5个SKU：五黑馒头、五红馒头、茯苓馒头、姜黄馒头、海藻馒头，均为馒头专用预拌粉，25公斤/包。产品属普通食品，卡片文字为合规表述；各SKU的五行功能方向须经食品合规审核后再决定对外说法。茯苓、姜黄是否在适用的药食同源目录及使用范围内，须合规确认。</a:t>
+              <a:t>宽瑜膳元五行系列5个SKU及功能方向：五黑馒头（黑色，补肾）、五红馒头（红色，补血）、茯苓馒头（白色，祛湿）、姜黄馒头（黄色，固肝）、海藻馒头（绿色，减重减脂），均为馒头专用预拌粉，25公斤/包。功能方向为提案方研发定位，对外宣传、标签与广告用语须经食品合规审核。茯苓、姜黄是否在适用的药食同源目录及使用范围内，须合规确认。</a:t>
             </a:r>
             <a:endParaRPr lang="en-US" dirty="0"/>
           </a:p>
@@ -12206,8 +12206,8 @@
         </p:nvSpPr>
         <p:spPr>
           <a:xfrm>
-            <a:off x="685800" y="3977640"/>
-            <a:ext cx="1792224" cy="731520"/>
+            <a:off x="685800" y="3886200"/>
+            <a:ext cx="1792224" cy="914400"/>
           </a:xfrm>
           <a:prstGeom prst="rect">
             <a:avLst/>
@@ -12223,28 +12223,42 @@
               <a:buNone/>
             </a:pPr>
             <a:r>
-              <a:rPr lang="en-US" sz="1200" dirty="0">
+              <a:rPr lang="en-US" sz="1100" dirty="0">
                 <a:solidFill>
                   <a:schemeClr val="tx2"/>
                 </a:solidFill>
               </a:rPr>
+              <a:t>功能方向</a:t>
+            </a:r>
+            <a:endParaRPr lang="en-US" sz="1400" dirty="0"/>
+          </a:p>
+          <a:p>
+            <a:pPr algn="ctr" indent="0" marL="0">
+              <a:buNone/>
+            </a:pPr>
+            <a:r>
+              <a:rPr lang="en-US" sz="1600" b="1" dirty="0">
+                <a:solidFill>
+                  <a:schemeClr val="accent5"/>
+                </a:solidFill>
+              </a:rPr>
+              <a:t>补肾</a:t>
+            </a:r>
+            <a:endParaRPr lang="en-US" sz="1400" dirty="0"/>
+          </a:p>
+          <a:p>
+            <a:pPr algn="ctr" indent="0" marL="0">
+              <a:buNone/>
+            </a:pPr>
+            <a:r>
+              <a:rPr lang="en-US" sz="1100" dirty="0">
+                <a:solidFill>
+                  <a:schemeClr val="tx2"/>
+                </a:solidFill>
+              </a:rPr>
               <a:t>五黑食材配伍</a:t>
             </a:r>
-            <a:endParaRPr lang="en-US" sz="1200" dirty="0"/>
-          </a:p>
-          <a:p>
-            <a:pPr algn="ctr" indent="0" marL="0">
-              <a:buNone/>
-            </a:pPr>
-            <a:r>
-              <a:rPr lang="en-US" sz="1200" dirty="0">
-                <a:solidFill>
-                  <a:schemeClr val="tx2"/>
-                </a:solidFill>
-              </a:rPr>
-              <a:t>传统“五黑”食养理念</a:t>
-            </a:r>
-            <a:endParaRPr lang="en-US" sz="1200" dirty="0"/>
+            <a:endParaRPr lang="en-US" sz="1400" dirty="0"/>
           </a:p>
         </p:txBody>
       </p:sp>
@@ -12533,8 +12547,8 @@
         </p:nvSpPr>
         <p:spPr>
           <a:xfrm>
-            <a:off x="2935224" y="3977640"/>
-            <a:ext cx="1792224" cy="731520"/>
+            <a:off x="2935224" y="3886200"/>
+            <a:ext cx="1792224" cy="914400"/>
           </a:xfrm>
           <a:prstGeom prst="rect">
             <a:avLst/>
@@ -12550,28 +12564,42 @@
               <a:buNone/>
             </a:pPr>
             <a:r>
-              <a:rPr lang="en-US" sz="1200" dirty="0">
+              <a:rPr lang="en-US" sz="1100" dirty="0">
                 <a:solidFill>
                   <a:schemeClr val="tx2"/>
                 </a:solidFill>
               </a:rPr>
+              <a:t>功能方向</a:t>
+            </a:r>
+            <a:endParaRPr lang="en-US" sz="1400" dirty="0"/>
+          </a:p>
+          <a:p>
+            <a:pPr algn="ctr" indent="0" marL="0">
+              <a:buNone/>
+            </a:pPr>
+            <a:r>
+              <a:rPr lang="en-US" sz="1600" b="1" dirty="0">
+                <a:solidFill>
+                  <a:schemeClr val="accent5"/>
+                </a:solidFill>
+              </a:rPr>
+              <a:t>补血</a:t>
+            </a:r>
+            <a:endParaRPr lang="en-US" sz="1400" dirty="0"/>
+          </a:p>
+          <a:p>
+            <a:pPr algn="ctr" indent="0" marL="0">
+              <a:buNone/>
+            </a:pPr>
+            <a:r>
+              <a:rPr lang="en-US" sz="1100" dirty="0">
+                <a:solidFill>
+                  <a:schemeClr val="tx2"/>
+                </a:solidFill>
+              </a:rPr>
               <a:t>五红食材配伍</a:t>
             </a:r>
-            <a:endParaRPr lang="en-US" sz="1200" dirty="0"/>
-          </a:p>
-          <a:p>
-            <a:pPr algn="ctr" indent="0" marL="0">
-              <a:buNone/>
-            </a:pPr>
-            <a:r>
-              <a:rPr lang="en-US" sz="1200" dirty="0">
-                <a:solidFill>
-                  <a:schemeClr val="tx2"/>
-                </a:solidFill>
-              </a:rPr>
-              <a:t>传统“五红”食养理念</a:t>
-            </a:r>
-            <a:endParaRPr lang="en-US" sz="1200" dirty="0"/>
+            <a:endParaRPr lang="en-US" sz="1400" dirty="0"/>
           </a:p>
         </p:txBody>
       </p:sp>
@@ -12860,8 +12888,8 @@
         </p:nvSpPr>
         <p:spPr>
           <a:xfrm>
-            <a:off x="5184648" y="3977640"/>
-            <a:ext cx="1792224" cy="731520"/>
+            <a:off x="5184648" y="3886200"/>
+            <a:ext cx="1792224" cy="914400"/>
           </a:xfrm>
           <a:prstGeom prst="rect">
             <a:avLst/>
@@ -12877,28 +12905,42 @@
               <a:buNone/>
             </a:pPr>
             <a:r>
-              <a:rPr lang="en-US" sz="1200" dirty="0">
+              <a:rPr lang="en-US" sz="1100" dirty="0">
                 <a:solidFill>
                   <a:schemeClr val="tx2"/>
                 </a:solidFill>
               </a:rPr>
-              <a:t>药食同源原料茯苓</a:t>
-            </a:r>
-            <a:endParaRPr lang="en-US" sz="1200" dirty="0"/>
+              <a:t>功能方向</a:t>
+            </a:r>
+            <a:endParaRPr lang="en-US" sz="1400" dirty="0"/>
           </a:p>
           <a:p>
             <a:pPr algn="ctr" indent="0" marL="0">
               <a:buNone/>
             </a:pPr>
             <a:r>
-              <a:rPr lang="en-US" sz="1200" dirty="0">
+              <a:rPr lang="en-US" sz="1600" b="1" dirty="0">
+                <a:solidFill>
+                  <a:schemeClr val="accent5"/>
+                </a:solidFill>
+              </a:rPr>
+              <a:t>祛湿</a:t>
+            </a:r>
+            <a:endParaRPr lang="en-US" sz="1400" dirty="0"/>
+          </a:p>
+          <a:p>
+            <a:pPr algn="ctr" indent="0" marL="0">
+              <a:buNone/>
+            </a:pPr>
+            <a:r>
+              <a:rPr lang="en-US" sz="1100" dirty="0">
                 <a:solidFill>
                   <a:schemeClr val="tx2"/>
                 </a:solidFill>
               </a:rPr>
-              <a:t>入面制作</a:t>
-            </a:r>
-            <a:endParaRPr lang="en-US" sz="1200" dirty="0"/>
+              <a:t>茯苓入面制作</a:t>
+            </a:r>
+            <a:endParaRPr lang="en-US" sz="1400" dirty="0"/>
           </a:p>
         </p:txBody>
       </p:sp>
@@ -13187,8 +13229,8 @@
         </p:nvSpPr>
         <p:spPr>
           <a:xfrm>
-            <a:off x="7434072" y="3977640"/>
-            <a:ext cx="1792224" cy="731520"/>
+            <a:off x="7434072" y="3886200"/>
+            <a:ext cx="1792224" cy="914400"/>
           </a:xfrm>
           <a:prstGeom prst="rect">
             <a:avLst/>
@@ -13204,28 +13246,42 @@
               <a:buNone/>
             </a:pPr>
             <a:r>
-              <a:rPr lang="en-US" sz="1200" dirty="0">
+              <a:rPr lang="en-US" sz="1100" dirty="0">
                 <a:solidFill>
                   <a:schemeClr val="tx2"/>
                 </a:solidFill>
               </a:rPr>
-              <a:t>姜黄入面</a:t>
-            </a:r>
-            <a:endParaRPr lang="en-US" sz="1200" dirty="0"/>
+              <a:t>功能方向</a:t>
+            </a:r>
+            <a:endParaRPr lang="en-US" sz="1400" dirty="0"/>
           </a:p>
           <a:p>
             <a:pPr algn="ctr" indent="0" marL="0">
               <a:buNone/>
             </a:pPr>
             <a:r>
-              <a:rPr lang="en-US" sz="1200" dirty="0">
+              <a:rPr lang="en-US" sz="1600" b="1" dirty="0">
+                <a:solidFill>
+                  <a:schemeClr val="accent5"/>
+                </a:solidFill>
+              </a:rPr>
+              <a:t>固肝</a:t>
+            </a:r>
+            <a:endParaRPr lang="en-US" sz="1400" dirty="0"/>
+          </a:p>
+          <a:p>
+            <a:pPr algn="ctr" indent="0" marL="0">
+              <a:buNone/>
+            </a:pPr>
+            <a:r>
+              <a:rPr lang="en-US" sz="1100" dirty="0">
                 <a:solidFill>
                   <a:schemeClr val="tx2"/>
                 </a:solidFill>
               </a:rPr>
-              <a:t>天然金黄色泽</a:t>
-            </a:r>
-            <a:endParaRPr lang="en-US" sz="1200" dirty="0"/>
+              <a:t>姜黄入面制作</a:t>
+            </a:r>
+            <a:endParaRPr lang="en-US" sz="1400" dirty="0"/>
           </a:p>
         </p:txBody>
       </p:sp>
@@ -13514,8 +13570,8 @@
         </p:nvSpPr>
         <p:spPr>
           <a:xfrm>
-            <a:off x="9683496" y="3977640"/>
-            <a:ext cx="1792224" cy="731520"/>
+            <a:off x="9683496" y="3886200"/>
+            <a:ext cx="1792224" cy="914400"/>
           </a:xfrm>
           <a:prstGeom prst="rect">
             <a:avLst/>
@@ -13531,28 +13587,42 @@
               <a:buNone/>
             </a:pPr>
             <a:r>
-              <a:rPr lang="en-US" sz="1200" dirty="0">
+              <a:rPr lang="en-US" sz="1100" dirty="0">
                 <a:solidFill>
                   <a:schemeClr val="tx2"/>
                 </a:solidFill>
               </a:rPr>
-              <a:t>海藻入面</a:t>
-            </a:r>
-            <a:endParaRPr lang="en-US" sz="1200" dirty="0"/>
+              <a:t>功能方向</a:t>
+            </a:r>
+            <a:endParaRPr lang="en-US" sz="1400" dirty="0"/>
           </a:p>
           <a:p>
             <a:pPr algn="ctr" indent="0" marL="0">
               <a:buNone/>
             </a:pPr>
             <a:r>
-              <a:rPr lang="en-US" sz="1200" dirty="0">
+              <a:rPr lang="en-US" sz="1600" b="1" dirty="0">
+                <a:solidFill>
+                  <a:schemeClr val="accent5"/>
+                </a:solidFill>
+              </a:rPr>
+              <a:t>减重 · 减脂</a:t>
+            </a:r>
+            <a:endParaRPr lang="en-US" sz="1400" dirty="0"/>
+          </a:p>
+          <a:p>
+            <a:pPr algn="ctr" indent="0" marL="0">
+              <a:buNone/>
+            </a:pPr>
+            <a:r>
+              <a:rPr lang="en-US" sz="1100" dirty="0">
                 <a:solidFill>
                   <a:schemeClr val="tx2"/>
                 </a:solidFill>
               </a:rPr>
-              <a:t>轻食主食定位</a:t>
-            </a:r>
-            <a:endParaRPr lang="en-US" sz="1200" dirty="0"/>
+              <a:t>海藻入面制作</a:t>
+            </a:r>
+            <a:endParaRPr lang="en-US" sz="1400" dirty="0"/>
           </a:p>
         </p:txBody>
       </p:sp>
@@ -13645,7 +13715,7 @@
                   <a:schemeClr val="tx2"/>
                 </a:solidFill>
               </a:rPr>
-              <a:t>注：产品为普通食品，对外不作预防、治疗疾病或保健功能声称；各SKU功能方向表述须经食品合规审核后方可使用；配方组成以陈博士最终确认为准。</a:t>
+              <a:t>注：功能方向为提案方研发定位；对外宣传、标签及广告用语须经食品合规审核后方可使用（普通食品不得声称疾病预防、治疗或保健功能）；配方以陈博士确认为准。</a:t>
             </a:r>
             <a:endParaRPr lang="en-US" sz="1000" dirty="0"/>
           </a:p>

</xml_diff>